<commit_message>
Explain IMOBX mission with sourced documentary context
</commit_message>
<xml_diff>
--- a/pitchdeck.pptx
+++ b/pitchdeck.pptx
@@ -817,7 +817,7 @@
           <a:lstStyle/>
           <a:p>
             <a:r>
-              <a:t>Do not describe all informal-settlement residents as displaced. The founders' target group still requires local definition and consultation. Do not state a number of pilot residents as already enrolled.</a:t>
+              <a:t>Brazil’s 2022 Census recorded around 16.4 million residents in favelas and urban communities, 8.1% of the population. IBGE describes community formation and identities, while UN-Habitat provides the wider inadequate-housing context. These are national/global references, not evidence of the selected pilot site. Do not describe all informal-settlement residents as displaced. Listen to households about location, work, services and their preferences. The founders’ target group requires local definition and consultation. No pilot residents are claimed as enrolled.</a:t>
             </a:r>
           </a:p>
           <a:p/>
@@ -1197,7 +1197,7 @@
           <a:lstStyle/>
           <a:p>
             <a:r>
-              <a:t>Ostrom informs the design direction: boundaries, affected users' participation, monitoring and accessible dispute resolution. There is no tenant-token allocation or adopted voting-weight plan. Compare household/member participation options with advisers and residents.</a:t>
+              <a:t>Ostrom informs the design direction: boundaries, affected users' participation, monitoring and accessible dispute resolution. There is no tenant-token allocation or adopted voting-weight plan. Compare household/member participation options with advisers and residents. IMOBX’s ambition is a DAO supported by tested shared rules and useful digital records; the current paper sets out the proposed decision boundaries.</a:t>
             </a:r>
           </a:p>
           <a:p/>

</xml_diff>

<commit_message>
Explain IMOBX roadmap and governance; credit Rafael cost references
</commit_message>
<xml_diff>
--- a/pitchdeck.pptx
+++ b/pitchdeck.pptx
@@ -519,7 +519,7 @@
           <a:p/>
           <a:p>
             <a:r>
-              <a:t>Sources and factual limits: companion whitepaper v0.1.</a:t>
+              <a:t>Sources and factual limits: companion whitepaper v0.2.</a:t>
             </a:r>
           </a:p>
         </p:txBody>
@@ -589,13 +589,13 @@
           <a:lstStyle/>
           <a:p>
             <a:r>
-              <a:t>This roadmap has evidence gates rather than a promised calendar. Token-specific paper/website v2 follows the legal/provider and contract verification gates. Permits, funding and scope determine construction time.</a:t>
+              <a:t>Proposed preparation targets start only from an agreed date; construction needs funding, property and permits. Observe at least three operating months before the first replication review. Website v1 is published; operational v2 reports real delivery/cash and does not require a token. Optional v3 token access follows rights, legal/provider and technical verification. See roadmap.html and faq.html. A second local team must repeat the process; one thousand homes does not prove self-sufficiency.</a:t>
             </a:r>
           </a:p>
           <a:p/>
           <a:p>
             <a:r>
-              <a:t>Sources and factual limits: companion whitepaper v0.1.</a:t>
+              <a:t>Sources and factual limits: companion whitepaper v0.2.</a:t>
             </a:r>
           </a:p>
         </p:txBody>
@@ -671,7 +671,7 @@
           <a:p/>
           <a:p>
             <a:r>
-              <a:t>Sources and factual limits: companion whitepaper v0.1.</a:t>
+              <a:t>Sources and factual limits: companion whitepaper v0.2.</a:t>
             </a:r>
           </a:p>
         </p:txBody>
@@ -747,7 +747,7 @@
           <a:p/>
           <a:p>
             <a:r>
-              <a:t>Sources and factual limits: companion whitepaper v0.1.</a:t>
+              <a:t>Sources and factual limits: companion whitepaper v0.2.</a:t>
             </a:r>
           </a:p>
         </p:txBody>
@@ -823,7 +823,7 @@
           <a:p/>
           <a:p>
             <a:r>
-              <a:t>Sources and factual limits: companion whitepaper v0.1.</a:t>
+              <a:t>Sources and factual limits: companion whitepaper v0.2.</a:t>
             </a:r>
           </a:p>
         </p:txBody>
@@ -893,13 +893,13 @@
           <a:lstStyle/>
           <a:p>
             <a:r>
-              <a:t>The five lines total $27,777. The historical 36-home total is $999,972 with a 12-month proposal. This is neither an independent quote nor a one-home delivery commitment. The cost is an evidence item to reconcile, not a headline return claim. Rafael’s November village concept includes shared outdoor space, rooftop solar, an orchard and two study rooms. Explain these as intended household/community benefits, with maintenance and resident decision rules. The January two-loft amount is $27,777 combined, a different scope from this per-home village proposal. See the dated study archive.</a:t>
+              <a:t>Rafael explicitly cited SindusCon/CUB and SINAPI in November 2025. On 30 November he provided a $21,883.86 construction calculation plus land, then an optimized $27,777 budget with direct procurement and shared costs. The five lines total $27,777. He specified 36 homes, $999,972 and a 12-month program. Present this engineering basis rather than an unexplained number. Preserve scope and current execution records. A blanket 15% CUB deduction is not an independently proved saving: the reference scope matters. The January two-loft contract is $27,777 combined and is a separate case.</a:t>
             </a:r>
           </a:p>
           <a:p/>
           <a:p>
             <a:r>
-              <a:t>Sources and factual limits: companion whitepaper v0.1.</a:t>
+              <a:t>Sources and factual limits: companion whitepaper v0.2.</a:t>
             </a:r>
           </a:p>
         </p:txBody>
@@ -975,7 +975,7 @@
           <a:p/>
           <a:p>
             <a:r>
-              <a:t>Sources and factual limits: companion whitepaper v0.1.</a:t>
+              <a:t>Sources and factual limits: companion whitepaper v0.2.</a:t>
             </a:r>
           </a:p>
         </p:txBody>
@@ -1051,7 +1051,7 @@
           <a:p/>
           <a:p>
             <a:r>
-              <a:t>Sources and factual limits: companion whitepaper v0.1.</a:t>
+              <a:t>Sources and factual limits: companion whitepaper v0.2.</a:t>
             </a:r>
           </a:p>
         </p:txBody>
@@ -1127,7 +1127,7 @@
           <a:p/>
           <a:p>
             <a:r>
-              <a:t>Sources and factual limits: companion whitepaper v0.1.</a:t>
+              <a:t>Sources and factual limits: companion whitepaper v0.2.</a:t>
             </a:r>
           </a:p>
         </p:txBody>
@@ -1197,13 +1197,13 @@
           <a:lstStyle/>
           <a:p>
             <a:r>
-              <a:t>Ostrom informs the design direction: boundaries, affected users' participation, monitoring and accessible dispute resolution. There is no tenant-token allocation or adopted voting-weight plan. Compare household/member participation options with advisers and residents. IMOBX’s ambition is a DAO supported by tested shared rules and useful digital records; the current paper sets out the proposed decision boundaries.</a:t>
+              <a:t>One token, one vote on everything risks purchased control. The consultation example uses equal voice per verified member in resident matters, relevant experience for elected/appointed work roles, and financial-holder rights defined by their instrument. It is not an adopted charter. Ostrom informs boundaries, local fit, collective choice, accountable monitoring, proportionate responses, conflicts, recognized authority and nested levels. See roadmap.html#governance. Online activity or a score does not decide housing rights.</a:t>
             </a:r>
           </a:p>
           <a:p/>
           <a:p>
             <a:r>
-              <a:t>Sources and factual limits: companion whitepaper v0.1.</a:t>
+              <a:t>Sources and factual limits: companion whitepaper v0.2.</a:t>
             </a:r>
           </a:p>
         </p:txBody>
@@ -1273,13 +1273,13 @@
           <a:lstStyle/>
           <a:p>
             <a:r>
-              <a:t>Arctide fee components are described in its integration documentation. The IMOBX recipient and integration are not demonstrated. The Flock remains neutral. Its contribution/reward backend is a separate authorized service; this deck does not promise live payouts.</a:t>
+              <a:t>The Flock stays neutral. Arc documents USDC gas; Arctide documents token/USDC pairs and configured fee recipients. Argus also documents USDC distributions and accumulator dividends; Uniswap v4 supports custom hooks. No exclusive-reward or universal-cost advantage is established. Trial receipt reconciliation, permissions, support costs and provider replacement. No automated agent acquires authority over homes by being called a mentor.</a:t>
             </a:r>
           </a:p>
           <a:p/>
           <a:p>
             <a:r>
-              <a:t>Sources and factual limits: companion whitepaper v0.1.</a:t>
+              <a:t>Sources and factual limits: companion whitepaper v0.2.</a:t>
             </a:r>
           </a:p>
         </p:txBody>
@@ -1349,13 +1349,13 @@
           <a:lstStyle/>
           <a:p>
             <a:r>
-              <a:t>CVM Guidance Opinion 40 concerns cryptoasset characteristics and rights. Do not claim SEC, MiCA or Brazilian approval. No supply, APY, sale date, tenant allocation or payout plan is agreed. Website v2 requires accepted rights and a permitted provider route.</a:t>
+              <a:t>Under Law 13.019's nonprofit definition for public-sector partnerships, results support the social purpose rather than distributions. Do not promise the nonprofit's profits as investor dividends. Consider participation without profit rights or a separately permitted financial arrangement with Brazilian advisers; no structure is adopted. A DAO/governance label does not settle securities treatment. No supply, APY, sale date or tenant allocation is agreed.</a:t>
             </a:r>
           </a:p>
           <a:p/>
           <a:p>
             <a:r>
-              <a:t>Sources and factual limits: companion whitepaper v0.1.</a:t>
+              <a:t>Sources and factual limits: companion whitepaper v0.2.</a:t>
             </a:r>
           </a:p>
         </p:txBody>
@@ -4992,7 +4992,7 @@
               </a:defRPr>
             </a:pPr>
             <a:r>
-              <a:t>Move from evidence to a delivered pilot.</a:t>
+              <a:t>Evidence gates, with parallel work streams.</a:t>
             </a:r>
           </a:p>
         </p:txBody>
@@ -5028,7 +5028,7 @@
               </a:defRPr>
             </a:pPr>
             <a:r>
-              <a:t>Three work streams: housing evidence, operating/legal design and digital communication.</a:t>
+              <a:t>The distinct roadmap links housing delivery, governance and useful digital services.</a:t>
             </a:r>
           </a:p>
         </p:txBody>
@@ -5100,7 +5100,7 @@
               </a:defRPr>
             </a:pPr>
             <a:r>
-              <a:t>Agree founder roles, property file and selected resident pathway.</a:t>
+              <a:t>Days 1–30: roles, entity/property evidence, scoped budget and consultation.</a:t>
             </a:r>
           </a:p>
         </p:txBody>
@@ -5172,7 +5172,7 @@
               </a:defRPr>
             </a:pPr>
             <a:r>
-              <a:t>Reconcile the budget, cash rules and governance; review the whitepaper.</a:t>
+              <a:t>Days 31–60: cash rules and decision exercises; day 90: readiness decision.</a:t>
             </a:r>
           </a:p>
         </p:txBody>
@@ -5244,7 +5244,7 @@
               </a:defRPr>
             </a:pPr>
             <a:r>
-              <a:t>Publish verified website v1 information; deliver, report and evaluate the next cohort.</a:t>
+              <a:t>Funded pilot → operating evidence → token decision and repeatable delivery.</a:t>
             </a:r>
           </a:p>
         </p:txBody>
@@ -6948,7 +6948,7 @@
               </a:defRPr>
             </a:pPr>
             <a:r>
-              <a:t>A cost proposal exists. The pilot needs its own budget.</a:t>
+              <a:t>A reference-based budget. A delivery plan to track.</a:t>
             </a:r>
           </a:p>
         </p:txBody>
@@ -6984,7 +6984,7 @@
               </a:defRPr>
             </a:pPr>
             <a:r>
-              <a:t>US$27,777 per home was a founder-supplied proposal based on at least 36 homes.</a:t>
+              <a:t>Rafael’s $27,777 per-home budget uses CUB/SINAPI references and cost engineering.</a:t>
             </a:r>
           </a:p>
         </p:txBody>
@@ -7200,7 +7200,7 @@
               </a:defRPr>
             </a:pPr>
             <a:r>
-              <a:t>Update the selected pilot in BRL, with scope, margin, contingency and operating costs.</a:t>
+              <a:t>Track the reference period, BRL scope and actual spending; the village assumes 36 homes.</a:t>
             </a:r>
           </a:p>
         </p:txBody>
@@ -8904,7 +8904,7 @@
               </a:defRPr>
             </a:pPr>
             <a:r>
-              <a:t>Write down who decides what.</a:t>
+              <a:t>A voice comes from a role, not just a balance.</a:t>
             </a:r>
           </a:p>
         </p:txBody>
@@ -8940,7 +8940,7 @@
               </a:defRPr>
             </a:pPr>
             <a:r>
-              <a:t>Residents help shape suitable local decisions; their contracts define their rights.</a:t>
+              <a:t>Consult on resident authority, delegated work and separately defined financial rights.</a:t>
             </a:r>
           </a:p>
         </p:txBody>
@@ -9012,7 +9012,7 @@
               </a:defRPr>
             </a:pPr>
             <a:r>
-              <a:t>Consult on maintenance priorities, shared facilities and support.</a:t>
+              <a:t>Resident voice on shared use and maintenance within agreed limits.</a:t>
             </a:r>
           </a:p>
         </p:txBody>
@@ -9084,7 +9084,7 @@
               </a:defRPr>
             </a:pPr>
             <a:r>
-              <a:t>Define board duties, budget authority and conflict rules.</a:t>
+              <a:t>Time-limited delivery roles, conflict checks and replaceable representatives.</a:t>
             </a:r>
           </a:p>
         </p:txBody>
@@ -9156,7 +9156,7 @@
               </a:defRPr>
             </a:pPr>
             <a:r>
-              <a:t>Protect occupancy and the ownership path from unrelated token votes.</a:t>
+              <a:t>Occupancy and purchase rights stay protected by agreements and law.</a:t>
             </a:r>
           </a:p>
         </p:txBody>
@@ -9429,7 +9429,7 @@
               </a:defRPr>
             </a:pPr>
             <a:r>
-              <a:t>The Flock is the proposed Telegram project desk. Arctide is a candidate for USDC settlement.</a:t>
+              <a:t>The Flock is the proposed Telegram desk. Arc is the settlement network; Arctide is a candidate application.</a:t>
             </a:r>
           </a:p>
         </p:txBody>
@@ -9501,7 +9501,7 @@
               </a:defRPr>
             </a:pPr>
             <a:r>
-              <a:t>Approved updates and support requests reach the responsible people.</a:t>
+              <a:t>Approved rules, requests and responses make responsibilities visible.</a:t>
             </a:r>
           </a:p>
         </p:txBody>
@@ -9573,7 +9573,7 @@
               </a:defRPr>
             </a:pPr>
             <a:r>
-              <a:t>A configured project-fee recipient could receive supplementary USDC trade fees.</a:t>
+              <a:t>Compare Arctide project fees with Argus and Uniswap alternatives.</a:t>
             </a:r>
           </a:p>
         </p:txBody>
@@ -9645,7 +9645,7 @@
               </a:defRPr>
             </a:pPr>
             <a:r>
-              <a:t>Housing contracts and private resident records keep their own responsible process.</a:t>
+              <a:t>SIAH/HiveDAO coordination is proposed backend work, not a deployed IMOBX claim.</a:t>
             </a:r>
           </a:p>
         </p:txBody>
@@ -9882,7 +9882,7 @@
               </a:defRPr>
             </a:pPr>
             <a:r>
-              <a:t>Define the right before selecting the token.</a:t>
+              <a:t>Separate participation from financial entitlement.</a:t>
             </a:r>
           </a:p>
         </p:txBody>
@@ -9918,7 +9918,7 @@
               </a:defRPr>
             </a:pPr>
             <a:r>
-              <a:t>A participation credential and a financial interest are different products.</a:t>
+              <a:t>A mission-led nonprofit operator and an investor dividend need distinct legal consideration.</a:t>
             </a:r>
           </a:p>
         </p:txBody>
@@ -9990,7 +9990,7 @@
               </a:defRPr>
             </a:pPr>
             <a:r>
-              <a:t>Specify issuer, rights, governance scope and transfer process.</a:t>
+              <a:t>Choose the legal form and protect restricted donations and resident commitments.</a:t>
             </a:r>
           </a:p>
         </p:txBody>
@@ -10062,7 +10062,7 @@
               </a:defRPr>
             </a:pPr>
             <a:r>
-              <a:t>Review eligibility, offer language and providers with Brazilian advisers.</a:t>
+              <a:t>Define any financial claim, issuer, cash source and permitted offer/transfer route.</a:t>
             </a:r>
           </a:p>
         </p:txBody>
@@ -10134,7 +10134,7 @@
               </a:defRPr>
             </a:pPr>
             <a:r>
-              <a:t>Proceed with ordinary contracts if a token adds no useful benefit.</a:t>
+              <a:t>Reinvestment may grow operations; it is not automatic token yield or appreciation.</a:t>
             </a:r>
           </a:p>
         </p:txBody>

</xml_diff>

<commit_message>
Define SIAH Protocol brand and Hive DAO operating model
</commit_message>
<xml_diff>
--- a/pitchdeck.pptx
+++ b/pitchdeck.pptx
@@ -1273,7 +1273,7 @@
           <a:lstStyle/>
           <a:p>
             <a:r>
-              <a:t>The Flock stays neutral. Arc documents USDC gas; Arctide documents token/USDC pairs and configured fee recipients. Argus also documents USDC distributions and accumulator dividends; Uniswap v4 supports custom hooks. No exclusive-reward or universal-cost advantage is established. Trial receipt reconciliation, permissions, support costs and provider replacement. No automated agent acquires authority over homes by being called a mentor.</a:t>
+              <a:t>Hive DAO describes the operating model, not a separate evidence service. Participants should be able to identify a need, take responsibility within agreed roles and budgets, obtain required authorization, check delivery and payment, and pass context to a successor. SIAH Protocol is the brand. Agents help maintain context and permissions around treasuries, identities and wallets. Resident rights and financial-holder rights stay distinct. Demonstrate coordination, challenges and handover without constant founder instructions. Complete IMOBX operation remains to be verified; the engineering follows separate authorized work. The Flock remains neutral and reusable across projects. Arc is the settlement network; Arctide is a candidate fee source, with Argus and Uniswap alternatives requiring their own integration proof.</a:t>
             </a:r>
           </a:p>
           <a:p/>
@@ -9393,7 +9393,7 @@
               </a:defRPr>
             </a:pPr>
             <a:r>
-              <a:t>Use digital records where they reduce work.</a:t>
+              <a:t>Make fair cooperation the simplest path.</a:t>
             </a:r>
           </a:p>
         </p:txBody>
@@ -9429,7 +9429,7 @@
               </a:defRPr>
             </a:pPr>
             <a:r>
-              <a:t>The Flock is the proposed Telegram desk. Arc is the settlement network; Arctide is a candidate application.</a:t>
+              <a:t>SIAH Protocol is the brand. Hive DAO names the decentralized operating rails.</a:t>
             </a:r>
           </a:p>
         </p:txBody>
@@ -9501,7 +9501,7 @@
               </a:defRPr>
             </a:pPr>
             <a:r>
-              <a:t>Approved rules, requests and responses make responsibilities visible.</a:t>
+              <a:t>Shared context, voluntary roles and succession help work continue.</a:t>
             </a:r>
           </a:p>
         </p:txBody>
@@ -9573,7 +9573,7 @@
               </a:defRPr>
             </a:pPr>
             <a:r>
-              <a:t>Compare Arctide project fees with Argus and Uniswap alternatives.</a:t>
+              <a:t>Ostrom-informed rules; Python agents; Arc settlement; possible Arctide fees.</a:t>
             </a:r>
           </a:p>
         </p:txBody>
@@ -9645,7 +9645,7 @@
               </a:defRPr>
             </a:pPr>
             <a:r>
-              <a:t>SIAH/HiveDAO coordination is proposed backend work, not a deployed IMOBX claim.</a:t>
+              <a:t>The Flock supplies Telegram access; IMOBX would test the complete loop.</a:t>
             </a:r>
           </a:p>
         </p:txBody>

</xml_diff>

<commit_message>
Explain the housing and DAO model in everyday language
</commit_message>
<xml_diff>
--- a/pitchdeck.pptx
+++ b/pitchdeck.pptx
@@ -513,7 +513,7 @@
           <a:lstStyle/>
           <a:p>
             <a:r>
-              <a:t>Introduce Rafael's proposed construction/local role and John's proposed community/digital role. Their agreements, the legal entity and pilot property control still need documentary confirmation. This deck is for partners, not an investment solicitation.</a:t>
+              <a:t>Rafael brings construction and local experience; John handles community and digital work. Their roles, the legal organization and the right to use each property need written agreements. This draft explains the plan and asks for partners; it does not offer an investment.</a:t>
             </a:r>
           </a:p>
           <a:p/>
@@ -589,7 +589,7 @@
           <a:lstStyle/>
           <a:p>
             <a:r>
-              <a:t>Proposed preparation targets start only from an agreed date; construction needs funding, property and permits. Observe at least three operating months before the first replication review. Website v1 is published; operational v2 reports real delivery/cash and does not require a token. Optional v3 token access follows rights, legal/provider and technical verification. See roadmap.html and faq.html. A second local team must repeat the process; one thousand homes does not prove self-sufficiency.</a:t>
+              <a:t>These are preparation targets from an agreed start, not promised building dates. Construction needs property, funding and permissions. Follow at least three operating months before the first expansion review. Website v1 explains the plan; v2 reports real building and accounts without needing a token. Any later token access follows agreed rights and checked legal and payment arrangements.</a:t>
             </a:r>
           </a:p>
           <a:p/>
@@ -665,7 +665,7 @@
           <a:lstStyle/>
           <a:p>
             <a:r>
-              <a:t>Set numeric service targets after the pilot baseline. No invented beneficiaries, capital commitments or completed transfers are shown. Trading volume and holder count are financial market observations, not housing impact.</a:t>
+              <a:t>Agree response times and affordability targets with local participants. Report homes as planned, contracted, delivered or transferred, with checked records. Token prices and holder counts do not measure how well families are housed. No completed transfers or committed capital are invented here.</a:t>
             </a:r>
           </a:p>
           <a:p/>
@@ -741,7 +741,7 @@
           <a:lstStyle/>
           <a:p>
             <a:r>
-              <a:t>Agree the specific scope, responsible people, deliverables and decision dates with each partner. No funding amount or token purchase is requested by this draft. Read the companion whitepaper for assumptions, sources and unresolved decisions.</a:t>
+              <a:t>Agree the specific work, responsible people and dates with each partner. This draft does not ask readers to buy a token or promise a funding award. The paper and pilot guide give the calculations, sources and decisions still needed.</a:t>
             </a:r>
           </a:p>
           <a:p/>
@@ -817,7 +817,7 @@
           <a:lstStyle/>
           <a:p>
             <a:r>
-              <a:t>Brazil’s 2022 Census recorded around 16.4 million residents in favelas and urban communities, 8.1% of the population. IBGE describes community formation and identities, while UN-Habitat provides the wider inadequate-housing context. These are national/global references, not evidence of the selected pilot site. Do not describe all informal-settlement residents as displaced. Listen to households about location, work, services and their preferences. The founders’ target group requires local definition and consultation. No pilot residents are claimed as enrolled.</a:t>
+              <a:t>Brazil’s 2022 Census counted about 16.4 million residents in favelas and urban communities, 8.1% of the population. That is national context, not a description of a selected family or site. Living in a favela does not itself mean being displaced. Listen to families about work, schools, transport, support networks and whether a move suits them. No pilot families are claimed as enrolled.</a:t>
             </a:r>
           </a:p>
           <a:p/>
@@ -893,7 +893,7 @@
           <a:lstStyle/>
           <a:p>
             <a:r>
-              <a:t>Rafael explicitly cited SindusCon/CUB and SINAPI in November 2025. On 30 November he provided a $21,883.86 construction calculation plus land, then an optimized $27,777 budget with direct procurement and shared costs. The five lines total $27,777. He specified 36 homes, $999,972 and a 12-month program. Present this engineering basis rather than an unexplained number. Preserve scope and current execution records. A blanket 15% CUB deduction is not an independently proved saving: the reference scope matters. The January two-loft contract is $27,777 combined and is a separate case.</a:t>
+              <a:t>On 30 November 2025 Rafael showed a US$21,883.86 construction calculation plus land, then the revised US$27,777 budget. Direct purchasing and shared costs form part of the plan. Thirty-six homes total US$999,972, with a proposed 12-month program. These are Rafael’s budget figures, not an index-published finished-home price. Track dates, included work, prices in reais and actual invoices. The separate January contract is US$27,777 for both lofts together.</a:t>
             </a:r>
           </a:p>
           <a:p/>
@@ -969,7 +969,7 @@
           <a:lstStyle/>
           <a:p>
             <a:r>
-              <a:t>A proposed donation or memorandum is not a completed property transfer. A token is not the title record. The legal form and transfer arrangement need Brazilian professional review.</a:t>
+              <a:t>A promise to donate is different from a completed property transfer. A founder linked to the builder should not approve its own bill. Brazilian advisers need to review the property and legal arrangement. A token does not replace title registration.</a:t>
             </a:r>
           </a:p>
           <a:p/>
@@ -1045,7 +1045,7 @@
           <a:lstStyle/>
           <a:p>
             <a:r>
-              <a:t>Historical 98% rental distributions are not adopted here. Resident purchase credits are obligations or entitlements, not extra cash. A resale payment belongs to the seller except for separately collected fees. Locked trading liquidity is not available construction cash.</a:t>
+              <a:t>No old percentage split is agreed. Money credited toward a family’s purchase is not a second receipt of cash. Money paid by a buyer to a token seller normally goes to that seller, apart from separately collected fees. Money locked in a trading market is not also available to build homes.</a:t>
             </a:r>
           </a:p>
           <a:p/>
@@ -1121,7 +1121,7 @@
           <a:lstStyle/>
           <a:p>
             <a:r>
-              <a:t>One thousand homes is a hypothesis, not a break-even result. Grants may help eligible costs but one-off awards are not recurring income. Three- or six-year reviews do not guarantee a distribution.</a:t>
+              <a:t>Having a thousand homes does not itself show that the accounts balance. One-off grants can help construction but do not become continuing income. Any ongoing charge needs a real, affordable service under agreed terms. Reviews after three or six years are not promises of payouts.</a:t>
             </a:r>
           </a:p>
           <a:p/>
@@ -1197,7 +1197,7 @@
           <a:lstStyle/>
           <a:p>
             <a:r>
-              <a:t>One token, one vote on everything risks purchased control. The consultation example uses equal voice per verified member in resident matters, relevant experience for elected/appointed work roles, and financial-holder rights defined by their instrument. It is not an adopted charter. Ostrom informs boundaries, local fit, collective choice, accountable monitoring, proportionate responses, conflicts, recognized authority and nested levels. See roadmap.html#governance. Online activity or a score does not decide housing rights.</a:t>
+              <a:t>One option is equal member voice in resident matters, elected people responsible for work, and investor rights limited to the written investment agreement. Buying tokens would not buy membership or control over every housing decision. Ostrom’s ideas help us ask who participates, who checks and how disputes are resolved. These are proposed rules to agree. Online activity and scores do not decide housing rights.</a:t>
             </a:r>
           </a:p>
           <a:p/>
@@ -1273,7 +1273,7 @@
           <a:lstStyle/>
           <a:p>
             <a:r>
-              <a:t>Hive DAO describes the operating model, not a separate evidence service. Participants should be able to identify a need, take responsibility within agreed roles and budgets, obtain required authorization, check delivery and payment, and pass context to a successor. SIAH Protocol is the brand. Agents help maintain context and permissions around treasuries, identities and wallets. Resident rights and financial-holder rights stay distinct. Demonstrate coordination, challenges and handover without constant founder instructions. Complete IMOBX operation remains to be verified; the engineering follows separate authorized work. The Flock remains neutral and reusable across projects. Arc is the settlement network; Arctide is a candidate fee source, with Argus and Uniswap alternatives requiring their own integration proof.</a:t>
+              <a:t>Hive DAO is the operating model. The aim is for work to continue without constant founder instructions, with room to disagree and ask for review. For example: report a leak, assess it, approve a repair, check delivery and payment, then leave the record ready for the next person. The plan combines Ostrom’s ideas, agents written in Python, Arc payments and possible Arctide project fees. The complete process still needs to be built and demonstrated in IMOBX. The Flock can serve other projects too; other trading apps need their own integration checks.</a:t>
             </a:r>
           </a:p>
           <a:p/>
@@ -1349,7 +1349,7 @@
           <a:lstStyle/>
           <a:p>
             <a:r>
-              <a:t>Under Law 13.019's nonprofit definition for public-sector partnerships, results support the social purpose rather than distributions. Do not promise the nonprofit's profits as investor dividends. Consider participation without profit rights or a separately permitted financial arrangement with Brazilian advisers; no structure is adopted. A DAO/governance label does not settle securities treatment. No supply, APY, sale date or tenant allocation is agreed.</a:t>
+              <a:t>The nonprofit idea keeps resources serving housing. Under Law 13.019’s definition for public-sector partnerships, nonprofits use results for their social purpose. A nonprofit cannot simply promise those results as investor dividends. Brazilian advisers need to review any other permitted investment arrangement. No supply, return rate, sale date or resident token plan is agreed. The token’s name does not decide its legal treatment.</a:t>
             </a:r>
           </a:p>
           <a:p/>
@@ -4503,7 +4503,7 @@
               </a:defRPr>
             </a:pPr>
             <a:r>
-              <a:t>A home. An agreement. A record of the money.</a:t>
+              <a:t>Rent a home. Work toward owning it.</a:t>
             </a:r>
           </a:p>
         </p:txBody>
@@ -4539,7 +4539,7 @@
               </a:defRPr>
             </a:pPr>
             <a:r>
-              <a:t>IMOBX is preparing a Rio housing pilot with a written rent-to-own pathway and project reporting.</a:t>
+              <a:t>IMOBX is preparing a first rent-to-own housing project in Rio.</a:t>
             </a:r>
           </a:p>
         </p:txBody>
@@ -4611,7 +4611,7 @@
               </a:defRPr>
             </a:pPr>
             <a:r>
-              <a:t>Ground work: construction, property access and resident operations.</a:t>
+              <a:t>Local construction and clear family agreements.</a:t>
             </a:r>
           </a:p>
         </p:txBody>
@@ -4683,7 +4683,7 @@
               </a:defRPr>
             </a:pPr>
             <a:r>
-              <a:t>Digital work: clear information, questions and approved reports.</a:t>
+              <a:t>Residents help shape shared spaces and decisions.</a:t>
             </a:r>
           </a:p>
         </p:txBody>
@@ -4755,7 +4755,7 @@
               </a:defRPr>
             </a:pPr>
             <a:r>
-              <a:t>Current stage: design and evidence review.</a:t>
+              <a:t>Current stage: planning, documents and design.</a:t>
             </a:r>
           </a:p>
         </p:txBody>
@@ -4992,7 +4992,7 @@
               </a:defRPr>
             </a:pPr>
             <a:r>
-              <a:t>Evidence gates, with parallel work streams.</a:t>
+              <a:t>Prepare, test, then decide the next step.</a:t>
             </a:r>
           </a:p>
         </p:txBody>
@@ -5028,7 +5028,7 @@
               </a:defRPr>
             </a:pPr>
             <a:r>
-              <a:t>The distinct roadmap links housing delivery, governance and useful digital services.</a:t>
+              <a:t>The roadmap links homes, money, shared decisions and digital tools.</a:t>
             </a:r>
           </a:p>
         </p:txBody>
@@ -5100,7 +5100,7 @@
               </a:defRPr>
             </a:pPr>
             <a:r>
-              <a:t>Days 1–30: roles, entity/property evidence, scoped budget and consultation.</a:t>
+              <a:t>Days 1–30: roles, property, budget and family discussions.</a:t>
             </a:r>
           </a:p>
         </p:txBody>
@@ -5172,7 +5172,7 @@
               </a:defRPr>
             </a:pPr>
             <a:r>
-              <a:t>Days 31–60: cash rules and decision exercises; day 90: readiness decision.</a:t>
+              <a:t>Days 31–60: money rules and worked examples; day 90: readiness decision.</a:t>
             </a:r>
           </a:p>
         </p:txBody>
@@ -5244,7 +5244,7 @@
               </a:defRPr>
             </a:pPr>
             <a:r>
-              <a:t>Funded pilot → operating evidence → token decision and repeatable delivery.</a:t>
+              <a:t>Fund the pilot, follow results and test with another local team.</a:t>
             </a:r>
           </a:p>
         </p:txBody>
@@ -5481,7 +5481,7 @@
               </a:defRPr>
             </a:pPr>
             <a:r>
-              <a:t>Count homes and fulfilled commitments.</a:t>
+              <a:t>Measure homes and promises kept.</a:t>
             </a:r>
           </a:p>
         </p:txBody>
@@ -5517,7 +5517,7 @@
               </a:defRPr>
             </a:pPr>
             <a:r>
-              <a:t>The first scorecard measures delivery, cash discipline and resident experience.</a:t>
+              <a:t>Follow actual costs, accounts and families’ experience.</a:t>
             </a:r>
           </a:p>
         </p:txBody>
@@ -5589,7 +5589,7 @@
               </a:defRPr>
             </a:pPr>
             <a:r>
-              <a:t>Budget and schedule variance; property rights and resident agreement.</a:t>
+              <a:t>Check completed work, final cost and delays.</a:t>
             </a:r>
           </a:p>
         </p:txBody>
@@ -5661,7 +5661,7 @@
               </a:defRPr>
             </a:pPr>
             <a:r>
-              <a:t>Monthly source/use/reserve reconciliation; maintenance and unresolved issues.</a:t>
+              <a:t>Match every receipt and payment; report repairs and unresolved issues.</a:t>
             </a:r>
           </a:p>
         </p:txBody>
@@ -5733,7 +5733,7 @@
               </a:defRPr>
             </a:pPr>
             <a:r>
-              <a:t>Resident participation and progress under the ownership agreement.</a:t>
+              <a:t>Show participation and progress toward owning the home.</a:t>
             </a:r>
           </a:p>
         </p:txBody>
@@ -5970,7 +5970,7 @@
               </a:defRPr>
             </a:pPr>
             <a:r>
-              <a:t>Help define and verify the first pilot.</a:t>
+              <a:t>Help prepare the first project.</a:t>
             </a:r>
           </a:p>
         </p:txBody>
@@ -6006,7 +6006,7 @@
               </a:defRPr>
             </a:pPr>
             <a:r>
-              <a:t>The next ask is practical expertise and a bounded delivery arrangement.</a:t>
+              <a:t>We need people who can check the homes, agreements and budget.</a:t>
             </a:r>
           </a:p>
         </p:txBody>
@@ -6078,7 +6078,7 @@
               </a:defRPr>
             </a:pPr>
             <a:r>
-              <a:t>Property and building partners: confirm scope, access, costs and delivery.</a:t>
+              <a:t>Building partners: confirm the work, property access, costs and timing.</a:t>
             </a:r>
           </a:p>
         </p:txBody>
@@ -6150,7 +6150,7 @@
               </a:defRPr>
             </a:pPr>
             <a:r>
-              <a:t>Housing, accounting and legal partners: review rights, reserves and funding route.</a:t>
+              <a:t>Housing, accounting and legal advisers: review agreements and money rules.</a:t>
             </a:r>
           </a:p>
         </p:txBody>
@@ -6222,7 +6222,7 @@
               </a:defRPr>
             </a:pPr>
             <a:r>
-              <a:t>Resident/community partners: test the agreement, information and support process.</a:t>
+              <a:t>Families and community partners: test the information and help process.</a:t>
             </a:r>
           </a:p>
         </p:txBody>
@@ -6459,7 +6459,7 @@
               </a:defRPr>
             </a:pPr>
             <a:r>
-              <a:t>Start with households and the home.</a:t>
+              <a:t>Start with what a family needs.</a:t>
             </a:r>
           </a:p>
         </p:txBody>
@@ -6495,7 +6495,7 @@
               </a:defRPr>
             </a:pPr>
             <a:r>
-              <a:t>The intended pilot serves households displaced or excluded from ordinary housing finance.</a:t>
+              <a:t>The first project would help displaced families and people unable to use ordinary housing finance.</a:t>
             </a:r>
           </a:p>
         </p:txBody>
@@ -6567,7 +6567,7 @@
               </a:defRPr>
             </a:pPr>
             <a:r>
-              <a:t>Define eligibility and affordability with local participants.</a:t>
+              <a:t>Agree who can join and what payments are affordable.</a:t>
             </a:r>
           </a:p>
         </p:txBody>
@@ -6639,7 +6639,7 @@
               </a:defRPr>
             </a:pPr>
             <a:r>
-              <a:t>Explain payments, maintenance and the ownership path in ordinary Portuguese.</a:t>
+              <a:t>Explain repairs, payments and the path to buying the home.</a:t>
             </a:r>
           </a:p>
         </p:txBody>
@@ -6711,7 +6711,7 @@
               </a:defRPr>
             </a:pPr>
             <a:r>
-              <a:t>Provide a support and dispute route residents can actually use.</a:t>
+              <a:t>Make help and complaints easy to access.</a:t>
             </a:r>
           </a:p>
         </p:txBody>
@@ -6948,7 +6948,7 @@
               </a:defRPr>
             </a:pPr>
             <a:r>
-              <a:t>A reference-based budget. A delivery plan to track.</a:t>
+              <a:t>Rafael has supplied a building budget.</a:t>
             </a:r>
           </a:p>
         </p:txBody>
@@ -6984,7 +6984,7 @@
               </a:defRPr>
             </a:pPr>
             <a:r>
-              <a:t>Rafael’s $27,777 per-home budget uses CUB/SINAPI references and cost engineering.</a:t>
+              <a:t>His US$27,777 per-home plan uses CUB and SINAPI, Brazilian building-cost references.</a:t>
             </a:r>
           </a:p>
         </p:txBody>
@@ -7056,7 +7056,7 @@
               </a:defRPr>
             </a:pPr>
             <a:r>
-              <a:t>Land $5,550 · construction $18,600 · solar $1,500.</a:t>
+              <a:t>Land US$5,550 · construction US$18,600 · solar US$1,500.</a:t>
             </a:r>
           </a:p>
         </p:txBody>
@@ -7128,7 +7128,7 @@
               </a:defRPr>
             </a:pPr>
             <a:r>
-              <a:t>Shared infrastructure $1,500 · legal/design $627.</a:t>
+              <a:t>Shared works US$1,500 · design and legal work US$627.</a:t>
             </a:r>
           </a:p>
         </p:txBody>
@@ -7200,7 +7200,7 @@
               </a:defRPr>
             </a:pPr>
             <a:r>
-              <a:t>Track the reference period, BRL scope and actual spending; the village assumes 36 homes.</a:t>
+              <a:t>The village plan assumes at least 36 homes built together.</a:t>
             </a:r>
           </a:p>
         </p:txBody>
@@ -7437,7 +7437,7 @@
               </a:defRPr>
             </a:pPr>
             <a:r>
-              <a:t>One accountable organization coordinates the home.</a:t>
+              <a:t>Put the home and responsibilities in writing.</a:t>
             </a:r>
           </a:p>
         </p:txBody>
@@ -7473,7 +7473,7 @@
               </a:defRPr>
             </a:pPr>
             <a:r>
-              <a:t>Property control, resident agreements and builder responsibilities must connect in writing.</a:t>
+              <a:t>IMOBX would arrange property access, family agreements and building work.</a:t>
             </a:r>
           </a:p>
         </p:txBody>
@@ -7545,7 +7545,7 @@
               </a:defRPr>
             </a:pPr>
             <a:r>
-              <a:t>Document ownership or operating authority for the selected property.</a:t>
+              <a:t>Check who owns the property and how IMOBX may use it.</a:t>
             </a:r>
           </a:p>
         </p:txBody>
@@ -7617,7 +7617,7 @@
               </a:defRPr>
             </a:pPr>
             <a:r>
-              <a:t>Contract the builder and disclose related-party terms.</a:t>
+              <a:t>Agree the builder’s work, price, deadline and who checks it.</a:t>
             </a:r>
           </a:p>
         </p:txBody>
@@ -7689,7 +7689,7 @@
               </a:defRPr>
             </a:pPr>
             <a:r>
-              <a:t>Specify what the resident pays, earns toward ownership and receives at completion.</a:t>
+              <a:t>Explain payments, purchase progress and the final transfer.</a:t>
             </a:r>
           </a:p>
         </p:txBody>
@@ -7926,7 +7926,7 @@
               </a:defRPr>
             </a:pPr>
             <a:r>
-              <a:t>Keep each source and use visible.</a:t>
+              <a:t>Show where each payment goes.</a:t>
             </a:r>
           </a:p>
         </p:txBody>
@@ -7962,7 +7962,7 @@
               </a:defRPr>
             </a:pPr>
             <a:r>
-              <a:t>Rent, grants, service receipts and trading fees enter the books separately.</a:t>
+              <a:t>Keep rent, donations, grants, service income and trading fees separately identified.</a:t>
             </a:r>
           </a:p>
         </p:txBody>
@@ -8034,7 +8034,7 @@
               </a:defRPr>
             </a:pPr>
             <a:r>
-              <a:t>Pay taxes, collection and agreed property/organization costs.</a:t>
+              <a:t>Pay taxes, repairs and agreed running costs.</a:t>
             </a:r>
           </a:p>
         </p:txBody>
@@ -8106,7 +8106,7 @@
               </a:defRPr>
             </a:pPr>
             <a:r>
-              <a:t>Fund repairs, resident commitments, vacancies and reserves.</a:t>
+              <a:t>Keep money for empty homes and commitments to families.</a:t>
             </a:r>
           </a:p>
         </p:txBody>
@@ -8178,7 +8178,7 @@
               </a:defRPr>
             </a:pPr>
             <a:r>
-              <a:t>Commit growth capital under an agreed rule; assess any lawful surplus afterward.</a:t>
+              <a:t>Fund more homes; consider any permitted investor payments afterward.</a:t>
             </a:r>
           </a:p>
         </p:txBody>
@@ -8415,7 +8415,7 @@
               </a:defRPr>
             </a:pPr>
             <a:r>
-              <a:t>Self-sufficiency has two tests.</a:t>
+              <a:t>Pay today’s bills. Plan the next homes.</a:t>
             </a:r>
           </a:p>
         </p:txBody>
@@ -8451,7 +8451,7 @@
               </a:defRPr>
             </a:pPr>
             <a:r>
-              <a:t>Cover the homes already operating. Then finance the next cohort.</a:t>
+              <a:t>Running the existing homes and building more need separate budgets.</a:t>
             </a:r>
           </a:p>
         </p:txBody>
@@ -8523,7 +8523,7 @@
               </a:defRPr>
             </a:pPr>
             <a:r>
-              <a:t>Test full operating costs through low or zero trading activity.</a:t>
+              <a:t>Check the budget with little or no trading income.</a:t>
             </a:r>
           </a:p>
         </p:txBody>
@@ -8595,7 +8595,7 @@
               </a:defRPr>
             </a:pPr>
             <a:r>
-              <a:t>Account for rent ending when a home transfers to its resident.</a:t>
+              <a:t>Rent ends when the family becomes the home’s owner.</a:t>
             </a:r>
           </a:p>
         </p:txBody>
@@ -8667,7 +8667,7 @@
               </a:defRPr>
             </a:pPr>
             <a:r>
-              <a:t>Identify retained assets or recurring services; model expansion capital separately.</a:t>
+              <a:t>Show how continuing income and new building funds will be found.</a:t>
             </a:r>
           </a:p>
         </p:txBody>
@@ -8904,7 +8904,7 @@
               </a:defRPr>
             </a:pPr>
             <a:r>
-              <a:t>A voice comes from a role, not just a balance.</a:t>
+              <a:t>Give residents a real say.</a:t>
             </a:r>
           </a:p>
         </p:txBody>
@@ -8940,7 +8940,7 @@
               </a:defRPr>
             </a:pPr>
             <a:r>
-              <a:t>Consult on resident authority, delegated work and separately defined financial rights.</a:t>
+              <a:t>Discuss which decisions belong to residents, workers and possible investors.</a:t>
             </a:r>
           </a:p>
         </p:txBody>
@@ -9012,7 +9012,7 @@
               </a:defRPr>
             </a:pPr>
             <a:r>
-              <a:t>Resident voice on shared use and maintenance within agreed limits.</a:t>
+              <a:t>Residents help decide how shared spaces and repairs work.</a:t>
             </a:r>
           </a:p>
         </p:txBody>
@@ -9084,7 +9084,7 @@
               </a:defRPr>
             </a:pPr>
             <a:r>
-              <a:t>Time-limited delivery roles, conflict checks and replaceable representatives.</a:t>
+              <a:t>People chosen for work have time limits and can be replaced.</a:t>
             </a:r>
           </a:p>
         </p:txBody>
@@ -9156,7 +9156,7 @@
               </a:defRPr>
             </a:pPr>
             <a:r>
-              <a:t>Occupancy and purchase rights stay protected by agreements and law.</a:t>
+              <a:t>Housing and purchase rights stay protected by agreements and law.</a:t>
             </a:r>
           </a:p>
         </p:txBody>
@@ -9393,7 +9393,7 @@
               </a:defRPr>
             </a:pPr>
             <a:r>
-              <a:t>Make fair cooperation the simplest path.</a:t>
+              <a:t>Make fair cooperation easier.</a:t>
             </a:r>
           </a:p>
         </p:txBody>
@@ -9429,7 +9429,7 @@
               </a:defRPr>
             </a:pPr>
             <a:r>
-              <a:t>SIAH Protocol is the brand. Hive DAO names the decentralized operating rails.</a:t>
+              <a:t>SIAH Protocol is the brand. Hive DAO is how we aim to share responsibility.</a:t>
             </a:r>
           </a:p>
         </p:txBody>
@@ -9501,7 +9501,7 @@
               </a:defRPr>
             </a:pPr>
             <a:r>
-              <a:t>Shared context, voluntary roles and succession help work continue.</a:t>
+              <a:t>See what needs doing, choose work and leave useful records.</a:t>
             </a:r>
           </a:p>
         </p:txBody>
@@ -9573,7 +9573,7 @@
               </a:defRPr>
             </a:pPr>
             <a:r>
-              <a:t>Ostrom-informed rules; Python agents; Arc settlement; possible Arctide fees.</a:t>
+              <a:t>Software agents help track people, wallets, tasks and approvals.</a:t>
             </a:r>
           </a:p>
         </p:txBody>
@@ -9645,7 +9645,7 @@
               </a:defRPr>
             </a:pPr>
             <a:r>
-              <a:t>The Flock supplies Telegram access; IMOBX would test the complete loop.</a:t>
+              <a:t>The Flock is the Telegram bot; Arc and Arctide are possible payment tools.</a:t>
             </a:r>
           </a:p>
         </p:txBody>
@@ -9882,7 +9882,7 @@
               </a:defRPr>
             </a:pPr>
             <a:r>
-              <a:t>Separate participation from financial entitlement.</a:t>
+              <a:t>Decide what a token would actually give.</a:t>
             </a:r>
           </a:p>
         </p:txBody>
@@ -9918,7 +9918,7 @@
               </a:defRPr>
             </a:pPr>
             <a:r>
-              <a:t>A mission-led nonprofit operator and an investor dividend need distinct legal consideration.</a:t>
+              <a:t>A community membership record and an investment do different jobs.</a:t>
             </a:r>
           </a:p>
         </p:txBody>
@@ -9990,7 +9990,7 @@
               </a:defRPr>
             </a:pPr>
             <a:r>
-              <a:t>Choose the legal form and protect restricted donations and resident commitments.</a:t>
+              <a:t>Choose the legal form and keep donations for their agreed purpose.</a:t>
             </a:r>
           </a:p>
         </p:txBody>
@@ -10062,7 +10062,7 @@
               </a:defRPr>
             </a:pPr>
             <a:r>
-              <a:t>Define any financial claim, issuer, cash source and permitted offer/transfer route.</a:t>
+              <a:t>Explain who owes what, where payment money comes from and how to leave.</a:t>
             </a:r>
           </a:p>
         </p:txBody>
@@ -10134,7 +10134,7 @@
               </a:defRPr>
             </a:pPr>
             <a:r>
-              <a:t>Reinvestment may grow operations; it is not automatic token yield or appreciation.</a:t>
+              <a:t>Using money to build more homes does not automatically raise a token’s price.</a:t>
             </a:r>
           </a:p>
         </p:txBody>

</xml_diff>

<commit_message>
Explain daily DAO decisions without internal naming
</commit_message>
<xml_diff>
--- a/pitchdeck.pptx
+++ b/pitchdeck.pptx
@@ -1273,7 +1273,7 @@
           <a:lstStyle/>
           <a:p>
             <a:r>
-              <a:t>Hive DAO is the operating model. The aim is for work to continue without constant founder instructions, with room to disagree and ask for review. For example: report a leak, assess it, approve a repair, check delivery and payment, then leave the record ready for the next person. The plan combines Ostrom’s ideas, agents written in Python, Arc payments and possible Arctide project fees. The complete process still needs to be built and demonstrated in IMOBX. The Flock can serve other projects too; other trading apps need their own integration checks.</a:t>
+              <a:t>Before the pilot, residents and the organization need to agree which matters each group decides, spending limits and how a decision can be reviewed. For example: a resident reports a leak, the maintenance role assesses it and obtains a quote, spending follows the agreed rule, and another person checks the repair and payment. Routine work should proceed within those limits without constant founder instructions. Residents need ways to choose and replace responsible people. The Telegram bot would show requests, decisions and progress; software assistants could organize documents and reminders. Blockchain could show payment amounts and destinations. These tools follow the rules agreed by participants. The complete process still needs to be demonstrated in IMOBX.</a:t>
             </a:r>
           </a:p>
           <a:p/>
@@ -9393,7 +9393,7 @@
               </a:defRPr>
             </a:pPr>
             <a:r>
-              <a:t>Make fair cooperation easier.</a:t>
+              <a:t>From a request to checked work.</a:t>
             </a:r>
           </a:p>
         </p:txBody>
@@ -9429,7 +9429,7 @@
               </a:defRPr>
             </a:pPr>
             <a:r>
-              <a:t>SIAH Protocol is the brand. Hive DAO is how we aim to share responsibility.</a:t>
+              <a:t>Agreed roles, spending limits and shared records keep everyday work moving.</a:t>
             </a:r>
           </a:p>
         </p:txBody>
@@ -9501,7 +9501,7 @@
               </a:defRPr>
             </a:pPr>
             <a:r>
-              <a:t>See what needs doing, choose work and leave useful records.</a:t>
+              <a:t>A resident raises an issue; a responsible person takes it forward.</a:t>
             </a:r>
           </a:p>
         </p:txBody>
@@ -9573,7 +9573,7 @@
               </a:defRPr>
             </a:pPr>
             <a:r>
-              <a:t>Software agents help track people, wallets, tasks and approvals.</a:t>
+              <a:t>Someone else checks the work, payment and receipt.</a:t>
             </a:r>
           </a:p>
         </p:txBody>
@@ -9645,7 +9645,7 @@
               </a:defRPr>
             </a:pPr>
             <a:r>
-              <a:t>The Flock is the Telegram bot; Arc and Arctide are possible payment tools.</a:t>
+              <a:t>Open tasks and approvals are ready for whoever takes over.</a:t>
             </a:r>
           </a:p>
         </p:txBody>

</xml_diff>

<commit_message>
Explain the housing DAO through participant needs and defined rights
</commit_message>
<xml_diff>
--- a/pitchdeck.pptx
+++ b/pitchdeck.pptx
@@ -1273,7 +1273,7 @@
           <a:lstStyle/>
           <a:p>
             <a:r>
-              <a:t>Before the pilot, residents and the organization need to agree which matters each group decides, spending limits and how a decision can be reviewed. For example: a resident reports a leak, the maintenance role assesses it and obtains a quote, spending follows the agreed rule, and another person checks the repair and payment. Routine work should proceed within those limits without constant founder instructions. Residents need ways to choose and replace responsible people. The Telegram bot would show requests, decisions and progress; software assistants could organize documents and reminders. Blockchain could show payment amounts and destinations. These tools follow the rules agreed by participants. The complete process still needs to be demonstrated in IMOBX.</a:t>
+              <a:t>Before the pilot, residents and the organization need to agree which matters each group decides, spending limits and how a decision can be reviewed. For example: a resident reports a leak, the maintenance role assesses it and obtains a quote, spending follows the agreed rule, and another person checks the repair and payment. Routine work should proceed within those limits without constant founder instructions. Residents need ways to choose and replace responsible people. The support channel would show requests, decisions and progress; software assistants could organize documents and reminders. Blockchain could show payment amounts and destinations. These tools follow the rules agreed by participants. The complete process still needs to be demonstrated in IMOBX.</a:t>
             </a:r>
           </a:p>
           <a:p/>
@@ -1349,7 +1349,7 @@
           <a:lstStyle/>
           <a:p>
             <a:r>
-              <a:t>The nonprofit idea keeps resources serving housing. Under Law 13.019’s definition for public-sector partnerships, nonprofits use results for their social purpose. A nonprofit cannot simply promise those results as investor dividends. Brazilian advisers need to review any other permitted investment arrangement. No supply, return rate, sale date or resident token plan is agreed. The token’s name does not decide its legal treatment.</a:t>
+              <a:t>The nonprofit idea keeps resources serving housing. Under Law 13.019’s definition for public-sector partnerships, nonprofits use results for their social purpose. A nonprofit cannot simply promise those results as investor dividends. Brazilian advisers need to review any other permitted investment arrangement. No supply, return rate, sale date or resident token plan is agreed. The token’s name does not decide its legal treatment. A token could record defined decision or permitted financial rights across projects. These rights are not yet chosen. We need to speak with families, property contributors, builders, staff, donors, possible investors, neighbours and independent checkers before treating their needs as agreed. The participation map is a proposal for those conversations.</a:t>
             </a:r>
           </a:p>
           <a:p/>
@@ -9882,7 +9882,7 @@
               </a:defRPr>
             </a:pPr>
             <a:r>
-              <a:t>Decide what a token would actually give.</a:t>
+              <a:t>A home, a voice and an investment are different rights.</a:t>
             </a:r>
           </a:p>
         </p:txBody>
@@ -9918,7 +9918,7 @@
               </a:defRPr>
             </a:pPr>
             <a:r>
-              <a:t>A community membership record and an investment do different jobs.</a:t>
+              <a:t>A possible token needs a specific job and a written agreement.</a:t>
             </a:r>
           </a:p>
         </p:txBody>
@@ -9990,7 +9990,7 @@
               </a:defRPr>
             </a:pPr>
             <a:r>
-              <a:t>Choose the legal form and keep donations for their agreed purpose.</a:t>
+              <a:t>Families need a protected path to owning their whole home.</a:t>
             </a:r>
           </a:p>
         </p:txBody>
@@ -10062,7 +10062,7 @@
               </a:defRPr>
             </a:pPr>
             <a:r>
-              <a:t>Explain who owes what, where payment money comes from and how to leave.</a:t>
+              <a:t>Residents need a say; staff need clear duties and spending limits.</a:t>
             </a:r>
           </a:p>
         </p:txBody>
@@ -10134,7 +10134,7 @@
               </a:defRPr>
             </a:pPr>
             <a:r>
-              <a:t>Using money to build more homes does not automatically raise a token’s price.</a:t>
+              <a:t>Any investor needs defined income, losses and exit terms.</a:t>
             </a:r>
           </a:p>
         </p:txBody>

</xml_diff>

<commit_message>
Clarify the proposed token's capital-raising purpose
</commit_message>
<xml_diff>
--- a/pitchdeck.pptx
+++ b/pitchdeck.pptx
@@ -1349,7 +1349,7 @@
           <a:lstStyle/>
           <a:p>
             <a:r>
-              <a:t>The nonprofit idea keeps resources serving housing. Under Law 13.019’s definition for public-sector partnerships, nonprofits use results for their social purpose. A nonprofit cannot simply promise those results as investor dividends. Brazilian advisers need to review any other permitted investment arrangement. No supply, return rate, sale date or resident token plan is agreed. The token’s name does not decide its legal treatment. A token could record defined decision or permitted financial rights across projects. These rights are not yet chosen. We need to speak with families, property contributors, builders, staff, donors, possible investors, neighbours and independent checkers before treating their needs as agreed. The participation map is a proposal for those conversations.</a:t>
+              <a:t>The nonprofit idea keeps resources serving housing. Under Law 13.019’s definition for public-sector partnerships, nonprofits use results for their social purpose. A nonprofit cannot simply promise those results as investor dividends. Brazilian advisers need to review any other permitted investment arrangement. No supply, return rate, sale date or resident token plan is agreed. The token’s name does not decide its legal treatment. A token could record defined decision or permitted financial rights across projects. These rights are not yet chosen. We need to speak with families, property contributors, builders, staff, donors, possible investors, neighbours and independent checkers before treating their needs as agreed. The participation map is a proposal for those conversations. The financial purpose is capital raising for budgeted housing work. Formation of a share company, an investment offering and later trading are separate decisions. Financing may precede construction after the necessary organization, property authority, budget and permitted fundraising route are ready. Future income is forecast, not received. New investment paid to the issuer differs from a resale that pays another investor. The financing structure remains under study.</a:t>
             </a:r>
           </a:p>
           <a:p/>
@@ -9882,7 +9882,7 @@
               </a:defRPr>
             </a:pPr>
             <a:r>
-              <a:t>A home, a voice and an investment are different rights.</a:t>
+              <a:t>Raise capital for homes. Define what investors receive.</a:t>
             </a:r>
           </a:p>
         </p:txBody>
@@ -9918,7 +9918,7 @@
               </a:defRPr>
             </a:pPr>
             <a:r>
-              <a:t>A possible token needs a specific job and a written agreement.</a:t>
+              <a:t>We are studying a financial token to fund construction and growth.</a:t>
             </a:r>
           </a:p>
         </p:txBody>
@@ -9990,7 +9990,7 @@
               </a:defRPr>
             </a:pPr>
             <a:r>
-              <a:t>Families need a protected path to owning their whole home.</a:t>
+              <a:t>A new issue would bring investment money into the housing operation.</a:t>
             </a:r>
           </a:p>
         </p:txBody>
@@ -10062,7 +10062,7 @@
               </a:defRPr>
             </a:pPr>
             <a:r>
-              <a:t>Residents need a say; staff need clear duties and spending limits.</a:t>
+              <a:t>Define the issuer, financial rights, income source, losses and exit.</a:t>
             </a:r>
           </a:p>
         </p:txBody>
@@ -10134,7 +10134,7 @@
               </a:defRPr>
             </a:pPr>
             <a:r>
-              <a:t>Any investor needs defined income, losses and exit terms.</a:t>
+              <a:t>Keep family agreements and residents’ say in decisions protected.</a:t>
             </a:r>
           </a:p>
         </p:txBody>

</xml_diff>

<commit_message>
Keep internal review history out of the public housing proposal
</commit_message>
<xml_diff>
--- a/pitchdeck.pptx
+++ b/pitchdeck.pptx
@@ -1045,7 +1045,7 @@
           <a:lstStyle/>
           <a:p>
             <a:r>
-              <a:t>No old percentage split is agreed. Money credited toward a family’s purchase is not a second receipt of cash. Money paid by a buyer to a token seller normally goes to that seller, apart from separately collected fees. Money locked in a trading market is not also available to build homes.</a:t>
+              <a:t>Money credited toward a family’s purchase is not a second receipt of cash. Money paid by a buyer to a token seller normally goes to that seller, apart from separately collected fees. Money locked in a trading market is not also available to build homes.</a:t>
             </a:r>
           </a:p>
           <a:p/>
@@ -1121,7 +1121,7 @@
           <a:lstStyle/>
           <a:p>
             <a:r>
-              <a:t>Having a thousand homes does not itself show that the accounts balance. One-off grants can help construction but do not become continuing income. Any ongoing charge needs a real, affordable service under agreed terms. Reviews after three or six years are not promises of payouts.</a:t>
+              <a:t>Having a thousand homes does not itself show that the accounts balance. One-off grants can help construction but do not become continuing income. Any ongoing charge needs a real, affordable service under agreed terms.</a:t>
             </a:r>
           </a:p>
           <a:p/>

</xml_diff>

<commit_message>
Explain the housing proposal and add participation and source pages
</commit_message>
<xml_diff>
--- a/pitchdeck.pptx
+++ b/pitchdeck.pptx
@@ -519,7 +519,7 @@
           <a:p/>
           <a:p>
             <a:r>
-              <a:t>Sources and factual limits: companion whitepaper v0.2.</a:t>
+              <a:t>Sources and factual limits: companion whitepaper v0.6 and reference.html.</a:t>
             </a:r>
           </a:p>
         </p:txBody>
@@ -589,13 +589,13 @@
           <a:lstStyle/>
           <a:p>
             <a:r>
-              <a:t>These are preparation targets from an agreed start, not promised building dates. Construction needs property, funding and permissions. Follow at least three operating months before the first expansion review. Website v1 explains the plan; v2 reports real building and accounts without needing a token. Any later token access follows agreed rights and checked legal and payment arrangements.</a:t>
+              <a:t>The six stages are legal structure and property; resident participation; first homes; transparent treasury; funding and account review; more homes and owner partnerships. Rafael contributes construction and local knowledge; John contributes communication and digital coordination. Adviser, accounting, approval and independent inspection roles still need appointments. OLYMPUS is a possible founder-linked contractor requiring independent approval. A community or charitable partner is a possible relationship. Construction dates depend on the chosen project, funding and permissions. A review after at least three operating months is proposed before expanding. The roadmap lists responsibilities and reasons to pause each stage.</a:t>
             </a:r>
           </a:p>
           <a:p/>
           <a:p>
             <a:r>
-              <a:t>Sources and factual limits: companion whitepaper v0.2.</a:t>
+              <a:t>Sources and factual limits: companion whitepaper v0.6 and reference.html.</a:t>
             </a:r>
           </a:p>
         </p:txBody>
@@ -671,7 +671,7 @@
           <a:p/>
           <a:p>
             <a:r>
-              <a:t>Sources and factual limits: companion whitepaper v0.2.</a:t>
+              <a:t>Sources and factual limits: companion whitepaper v0.6 and reference.html.</a:t>
             </a:r>
           </a:p>
         </p:txBody>
@@ -741,13 +741,13 @@
           <a:lstStyle/>
           <a:p>
             <a:r>
-              <a:t>Agree the specific work, responsible people and dates with each partner. This draft does not ask readers to buy a token or promise a funding award. The paper and pilot guide give the calculations, sources and decisions still needed.</a:t>
+              <a:t>These are possible contributions, not confirmed partnerships or contracts. The contact page has separate routes and explanations. Receiving contacts are still placeholders: visitors can prepare and copy an introduction, but the website sends nothing. A property introduction can lead to assessment, not an automatic transfer. A founder-linked builder needs independent contract and delivery review. See contact.html and rent-to-own.html#property.</a:t>
             </a:r>
           </a:p>
           <a:p/>
           <a:p>
             <a:r>
-              <a:t>Sources and factual limits: companion whitepaper v0.2.</a:t>
+              <a:t>Sources and factual limits: companion whitepaper v0.6 and reference.html.</a:t>
             </a:r>
           </a:p>
         </p:txBody>
@@ -823,7 +823,7 @@
           <a:p/>
           <a:p>
             <a:r>
-              <a:t>Sources and factual limits: companion whitepaper v0.2.</a:t>
+              <a:t>Sources and factual limits: companion whitepaper v0.6 and reference.html.</a:t>
             </a:r>
           </a:p>
         </p:txBody>
@@ -899,7 +899,7 @@
           <a:p/>
           <a:p>
             <a:r>
-              <a:t>Sources and factual limits: companion whitepaper v0.2.</a:t>
+              <a:t>Sources and factual limits: companion whitepaper v0.6 and reference.html.</a:t>
             </a:r>
           </a:p>
         </p:txBody>
@@ -969,13 +969,13 @@
           <a:lstStyle/>
           <a:p>
             <a:r>
-              <a:t>A promise to donate is different from a completed property transfer. A founder linked to the builder should not approve its own bill. Brazilian advisers need to review the property and legal arrangement. A token does not replace title registration.</a:t>
+              <a:t>This is the proposed arrangement, not a current home offer. The first purchase price, monthly payment, purchase credit and payment period have not been set. Rafael’s village budget and the two-loft contract are construction cases, not household sale prices. Repair charges, hardship and exit terms remain open. The household explanation is at rent-to-own.html. Property authority, budget and independent inspection remain necessary for delivery.</a:t>
             </a:r>
           </a:p>
           <a:p/>
           <a:p>
             <a:r>
-              <a:t>Sources and factual limits: companion whitepaper v0.2.</a:t>
+              <a:t>Sources and factual limits: companion whitepaper v0.6 and reference.html.</a:t>
             </a:r>
           </a:p>
         </p:txBody>
@@ -1051,7 +1051,7 @@
           <a:p/>
           <a:p>
             <a:r>
-              <a:t>Sources and factual limits: companion whitepaper v0.2.</a:t>
+              <a:t>Sources and factual limits: companion whitepaper v0.6 and reference.html.</a:t>
             </a:r>
           </a:p>
         </p:txBody>
@@ -1127,7 +1127,7 @@
           <a:p/>
           <a:p>
             <a:r>
-              <a:t>Sources and factual limits: companion whitepaper v0.2.</a:t>
+              <a:t>Sources and factual limits: companion whitepaper v0.6 and reference.html.</a:t>
             </a:r>
           </a:p>
         </p:txBody>
@@ -1197,13 +1197,13 @@
           <a:lstStyle/>
           <a:p>
             <a:r>
-              <a:t>One option is equal member voice in resident matters, elected people responsible for work, and investor rights limited to the written investment agreement. Buying tokens would not buy membership or control over every housing decision. Ostrom’s ideas help us ask who participates, who checks and how disputes are resolved. These are proposed rules to agree. Online activity and scores do not decide housing rights.</a:t>
+              <a:t>The voting procedure, spending limits and review route have not been agreed with participants. In the proposed repair process, a resident reports a leak, a maintenance contact obtains a quote, spending follows the agreed limit and another person checks the work. Buying tokens would not give control over another household’s contracted purchase price. See rent-to-own.html#decisions and roadmap.html#governance. Do not describe this proposal as a functioning resident assembly.</a:t>
             </a:r>
           </a:p>
           <a:p/>
           <a:p>
             <a:r>
-              <a:t>Sources and factual limits: companion whitepaper v0.2.</a:t>
+              <a:t>Sources and factual limits: companion whitepaper v0.6 and reference.html.</a:t>
             </a:r>
           </a:p>
         </p:txBody>
@@ -1279,7 +1279,7 @@
           <a:p/>
           <a:p>
             <a:r>
-              <a:t>Sources and factual limits: companion whitepaper v0.2.</a:t>
+              <a:t>Sources and factual limits: companion whitepaper v0.6 and reference.html.</a:t>
             </a:r>
           </a:p>
         </p:txBody>
@@ -1349,13 +1349,13 @@
           <a:lstStyle/>
           <a:p>
             <a:r>
-              <a:t>The nonprofit idea keeps resources serving housing. Under Law 13.019’s definition for public-sector partnerships, nonprofits use results for their social purpose. A nonprofit cannot simply promise those results as investor dividends. Brazilian advisers need to review any other permitted investment arrangement. No supply, return rate, sale date or resident token plan is agreed. The token’s name does not decide its legal treatment. A token could record defined decision or permitted financial rights across projects. These rights are not yet chosen. We need to speak with families, property contributors, builders, staff, donors, possible investors, neighbours and independent checkers before treating their needs as agreed. The participation map is a proposal for those conversations. The financial purpose is capital raising for budgeted housing work. Formation of a share company, an investment offering and later trading are separate decisions. Financing may precede construction after the necessary organization, property authority, budget and permitted fundraising route are ready. Future income is forecast, not received. New investment paid to the issuer differs from a resale that pays another investor. The financing structure remains under study.</a:t>
+              <a:t>Four scenarios remain: no IMOBX token, a service or membership benefit, fee participation, or an investment in the operation. These are alternatives, not combined promised rights. Capital for construction, outreach payments and investor income have different budgets and commitments. Residents’ participation would not depend on investment or promotion. Reference.html#token compares what a buyer might receive and the decisions still open.</a:t>
             </a:r>
           </a:p>
           <a:p/>
           <a:p>
             <a:r>
-              <a:t>Sources and factual limits: companion whitepaper v0.2.</a:t>
+              <a:t>Sources and factual limits: companion whitepaper v0.6 and reference.html.</a:t>
             </a:r>
           </a:p>
         </p:txBody>
@@ -4497,13 +4497,13 @@
             <a:pPr>
               <a:defRPr sz="4000" b="0">
                 <a:solidFill>
-                  <a:srgbClr val="1A1A1A"/>
-                </a:solidFill>
-                <a:latin typeface="Arial"/>
-              </a:defRPr>
-            </a:pPr>
-            <a:r>
-              <a:t>Rent a home. Work toward owning it.</a:t>
+                  <a:srgbClr val="193D4E"/>
+                </a:solidFill>
+                <a:latin typeface="Arial"/>
+              </a:defRPr>
+            </a:pPr>
+            <a:r>
+              <a:t>Families would rent toward owning their home.</a:t>
             </a:r>
           </a:p>
         </p:txBody>
@@ -4605,7 +4605,7 @@
             <a:pPr>
               <a:defRPr sz="1800" b="0">
                 <a:solidFill>
-                  <a:srgbClr val="1A1A1A"/>
+                  <a:srgbClr val="193D4E"/>
                 </a:solidFill>
                 <a:latin typeface="Arial"/>
               </a:defRPr>
@@ -4677,7 +4677,7 @@
             <a:pPr>
               <a:defRPr sz="1800" b="0">
                 <a:solidFill>
-                  <a:srgbClr val="1A1A1A"/>
+                  <a:srgbClr val="193D4E"/>
                 </a:solidFill>
                 <a:latin typeface="Arial"/>
               </a:defRPr>
@@ -4749,7 +4749,7 @@
             <a:pPr>
               <a:defRPr sz="1800" b="0">
                 <a:solidFill>
-                  <a:srgbClr val="1A1A1A"/>
+                  <a:srgbClr val="193D4E"/>
                 </a:solidFill>
                 <a:latin typeface="Arial"/>
               </a:defRPr>
@@ -4791,7 +4791,7 @@
               </a:defRPr>
             </a:pPr>
             <a:r>
-              <a:t>IMOBX / PARTNER DISCUSSION DRAFT / 15 OCT 2026</a:t>
+              <a:t>IMOBX / PARTNER DISCUSSION DRAFT / v0.6 / 2026-10-17</a:t>
             </a:r>
           </a:p>
         </p:txBody>
@@ -4986,13 +4986,13 @@
             <a:pPr>
               <a:defRPr sz="4000" b="0">
                 <a:solidFill>
-                  <a:srgbClr val="1A1A1A"/>
-                </a:solidFill>
-                <a:latin typeface="Arial"/>
-              </a:defRPr>
-            </a:pPr>
-            <a:r>
-              <a:t>Prepare, test, then decide the next step.</a:t>
+                  <a:srgbClr val="193D4E"/>
+                </a:solidFill>
+                <a:latin typeface="Arial"/>
+              </a:defRPr>
+            </a:pPr>
+            <a:r>
+              <a:t>Each stage needs evidence before it advances.</a:t>
             </a:r>
           </a:p>
         </p:txBody>
@@ -5028,7 +5028,7 @@
               </a:defRPr>
             </a:pPr>
             <a:r>
-              <a:t>The roadmap links homes, money, shared decisions and digital tools.</a:t>
+              <a:t>The roadmap names proposed roles and conditions for proceeding.</a:t>
             </a:r>
           </a:p>
         </p:txBody>
@@ -5094,13 +5094,13 @@
             <a:pPr>
               <a:defRPr sz="1800" b="0">
                 <a:solidFill>
-                  <a:srgbClr val="1A1A1A"/>
-                </a:solidFill>
-                <a:latin typeface="Arial"/>
-              </a:defRPr>
-            </a:pPr>
-            <a:r>
-              <a:t>Days 1–30: roles, property, budget and family discussions.</a:t>
+                  <a:srgbClr val="193D4E"/>
+                </a:solidFill>
+                <a:latin typeface="Arial"/>
+              </a:defRPr>
+            </a:pPr>
+            <a:r>
+              <a:t>Property rights, household terms and budgets underpin the first homes.</a:t>
             </a:r>
           </a:p>
         </p:txBody>
@@ -5166,13 +5166,13 @@
             <a:pPr>
               <a:defRPr sz="1800" b="0">
                 <a:solidFill>
-                  <a:srgbClr val="1A1A1A"/>
-                </a:solidFill>
-                <a:latin typeface="Arial"/>
-              </a:defRPr>
-            </a:pPr>
-            <a:r>
-              <a:t>Days 31–60: money rules and worked examples; day 90: readiness decision.</a:t>
+                  <a:srgbClr val="193D4E"/>
+                </a:solidFill>
+                <a:latin typeface="Arial"/>
+              </a:defRPr>
+            </a:pPr>
+            <a:r>
+              <a:t>Digital payment trials and token research can progress alongside them.</a:t>
             </a:r>
           </a:p>
         </p:txBody>
@@ -5238,13 +5238,13 @@
             <a:pPr>
               <a:defRPr sz="1800" b="0">
                 <a:solidFill>
-                  <a:srgbClr val="1A1A1A"/>
-                </a:solidFill>
-                <a:latin typeface="Arial"/>
-              </a:defRPr>
-            </a:pPr>
-            <a:r>
-              <a:t>Fund the pilot, follow results and test with another local team.</a:t>
+                  <a:srgbClr val="193D4E"/>
+                </a:solidFill>
+                <a:latin typeface="Arial"/>
+              </a:defRPr>
+            </a:pPr>
+            <a:r>
+              <a:t>Expansion follows operating results and funding for existing commitments.</a:t>
             </a:r>
           </a:p>
         </p:txBody>
@@ -5280,7 +5280,7 @@
               </a:defRPr>
             </a:pPr>
             <a:r>
-              <a:t>IMOBX / PARTNER DISCUSSION DRAFT / 15 OCT 2026</a:t>
+              <a:t>IMOBX / PARTNER DISCUSSION DRAFT / v0.6 / 2026-10-17</a:t>
             </a:r>
           </a:p>
         </p:txBody>
@@ -5475,7 +5475,7 @@
             <a:pPr>
               <a:defRPr sz="4000" b="0">
                 <a:solidFill>
-                  <a:srgbClr val="1A1A1A"/>
+                  <a:srgbClr val="193D4E"/>
                 </a:solidFill>
                 <a:latin typeface="Arial"/>
               </a:defRPr>
@@ -5583,7 +5583,7 @@
             <a:pPr>
               <a:defRPr sz="1800" b="0">
                 <a:solidFill>
-                  <a:srgbClr val="1A1A1A"/>
+                  <a:srgbClr val="193D4E"/>
                 </a:solidFill>
                 <a:latin typeface="Arial"/>
               </a:defRPr>
@@ -5655,7 +5655,7 @@
             <a:pPr>
               <a:defRPr sz="1800" b="0">
                 <a:solidFill>
-                  <a:srgbClr val="1A1A1A"/>
+                  <a:srgbClr val="193D4E"/>
                 </a:solidFill>
                 <a:latin typeface="Arial"/>
               </a:defRPr>
@@ -5727,7 +5727,7 @@
             <a:pPr>
               <a:defRPr sz="1800" b="0">
                 <a:solidFill>
-                  <a:srgbClr val="1A1A1A"/>
+                  <a:srgbClr val="193D4E"/>
                 </a:solidFill>
                 <a:latin typeface="Arial"/>
               </a:defRPr>
@@ -5769,7 +5769,7 @@
               </a:defRPr>
             </a:pPr>
             <a:r>
-              <a:t>IMOBX / PARTNER DISCUSSION DRAFT / 15 OCT 2026</a:t>
+              <a:t>IMOBX / PARTNER DISCUSSION DRAFT / v0.6 / 2026-10-17</a:t>
             </a:r>
           </a:p>
         </p:txBody>
@@ -5964,13 +5964,13 @@
             <a:pPr>
               <a:defRPr sz="4000" b="0">
                 <a:solidFill>
-                  <a:srgbClr val="1A1A1A"/>
-                </a:solidFill>
-                <a:latin typeface="Arial"/>
-              </a:defRPr>
-            </a:pPr>
-            <a:r>
-              <a:t>Help prepare the first project.</a:t>
+                  <a:srgbClr val="193D4E"/>
+                </a:solidFill>
+                <a:latin typeface="Arial"/>
+              </a:defRPr>
+            </a:pPr>
+            <a:r>
+              <a:t>One property can become a project to assess.</a:t>
             </a:r>
           </a:p>
         </p:txBody>
@@ -6006,7 +6006,7 @@
               </a:defRPr>
             </a:pPr>
             <a:r>
-              <a:t>We need people who can check the homes, agreements and budget.</a:t>
+              <a:t>An owner, building team, local organization and funder could develop a costed proposal together.</a:t>
             </a:r>
           </a:p>
         </p:txBody>
@@ -6072,13 +6072,13 @@
             <a:pPr>
               <a:defRPr sz="1800" b="0">
                 <a:solidFill>
-                  <a:srgbClr val="1A1A1A"/>
-                </a:solidFill>
-                <a:latin typeface="Arial"/>
-              </a:defRPr>
-            </a:pPr>
-            <a:r>
-              <a:t>Building partners: confirm the work, property access, costs and timing.</a:t>
+                  <a:srgbClr val="193D4E"/>
+                </a:solidFill>
+                <a:latin typeface="Arial"/>
+              </a:defRPr>
+            </a:pPr>
+            <a:r>
+              <a:t>Owners: property, condition and donation, sale or lease terms.</a:t>
             </a:r>
           </a:p>
         </p:txBody>
@@ -6144,13 +6144,13 @@
             <a:pPr>
               <a:defRPr sz="1800" b="0">
                 <a:solidFill>
-                  <a:srgbClr val="1A1A1A"/>
-                </a:solidFill>
-                <a:latin typeface="Arial"/>
-              </a:defRPr>
-            </a:pPr>
-            <a:r>
-              <a:t>Housing, accounting and legal advisers: review agreements and money rules.</a:t>
+                  <a:srgbClr val="193D4E"/>
+                </a:solidFill>
+                <a:latin typeface="Arial"/>
+              </a:defRPr>
+            </a:pPr>
+            <a:r>
+              <a:t>Builders and funders: costed work, funding purpose and commitments.</a:t>
             </a:r>
           </a:p>
         </p:txBody>
@@ -6216,13 +6216,13 @@
             <a:pPr>
               <a:defRPr sz="1800" b="0">
                 <a:solidFill>
-                  <a:srgbClr val="1A1A1A"/>
-                </a:solidFill>
-                <a:latin typeface="Arial"/>
-              </a:defRPr>
-            </a:pPr>
-            <a:r>
-              <a:t>Families and community partners: test the information and help process.</a:t>
+                  <a:srgbClr val="193D4E"/>
+                </a:solidFill>
+                <a:latin typeface="Arial"/>
+              </a:defRPr>
+            </a:pPr>
+            <a:r>
+              <a:t>Households: affordable terms, location, repairs and resident decisions.</a:t>
             </a:r>
           </a:p>
         </p:txBody>
@@ -6258,7 +6258,7 @@
               </a:defRPr>
             </a:pPr>
             <a:r>
-              <a:t>IMOBX / PARTNER DISCUSSION DRAFT / 15 OCT 2026</a:t>
+              <a:t>IMOBX / PARTNER DISCUSSION DRAFT / v0.6 / 2026-10-17</a:t>
             </a:r>
           </a:p>
         </p:txBody>
@@ -6453,7 +6453,7 @@
             <a:pPr>
               <a:defRPr sz="4000" b="0">
                 <a:solidFill>
-                  <a:srgbClr val="1A1A1A"/>
+                  <a:srgbClr val="193D4E"/>
                 </a:solidFill>
                 <a:latin typeface="Arial"/>
               </a:defRPr>
@@ -6561,7 +6561,7 @@
             <a:pPr>
               <a:defRPr sz="1800" b="0">
                 <a:solidFill>
-                  <a:srgbClr val="1A1A1A"/>
+                  <a:srgbClr val="193D4E"/>
                 </a:solidFill>
                 <a:latin typeface="Arial"/>
               </a:defRPr>
@@ -6633,7 +6633,7 @@
             <a:pPr>
               <a:defRPr sz="1800" b="0">
                 <a:solidFill>
-                  <a:srgbClr val="1A1A1A"/>
+                  <a:srgbClr val="193D4E"/>
                 </a:solidFill>
                 <a:latin typeface="Arial"/>
               </a:defRPr>
@@ -6705,7 +6705,7 @@
             <a:pPr>
               <a:defRPr sz="1800" b="0">
                 <a:solidFill>
-                  <a:srgbClr val="1A1A1A"/>
+                  <a:srgbClr val="193D4E"/>
                 </a:solidFill>
                 <a:latin typeface="Arial"/>
               </a:defRPr>
@@ -6747,7 +6747,7 @@
               </a:defRPr>
             </a:pPr>
             <a:r>
-              <a:t>IMOBX / PARTNER DISCUSSION DRAFT / 15 OCT 2026</a:t>
+              <a:t>IMOBX / PARTNER DISCUSSION DRAFT / v0.6 / 2026-10-17</a:t>
             </a:r>
           </a:p>
         </p:txBody>
@@ -6942,7 +6942,7 @@
             <a:pPr>
               <a:defRPr sz="4000" b="0">
                 <a:solidFill>
-                  <a:srgbClr val="1A1A1A"/>
+                  <a:srgbClr val="193D4E"/>
                 </a:solidFill>
                 <a:latin typeface="Arial"/>
               </a:defRPr>
@@ -7050,7 +7050,7 @@
             <a:pPr>
               <a:defRPr sz="1800" b="0">
                 <a:solidFill>
-                  <a:srgbClr val="1A1A1A"/>
+                  <a:srgbClr val="193D4E"/>
                 </a:solidFill>
                 <a:latin typeface="Arial"/>
               </a:defRPr>
@@ -7122,7 +7122,7 @@
             <a:pPr>
               <a:defRPr sz="1800" b="0">
                 <a:solidFill>
-                  <a:srgbClr val="1A1A1A"/>
+                  <a:srgbClr val="193D4E"/>
                 </a:solidFill>
                 <a:latin typeface="Arial"/>
               </a:defRPr>
@@ -7194,7 +7194,7 @@
             <a:pPr>
               <a:defRPr sz="1800" b="0">
                 <a:solidFill>
-                  <a:srgbClr val="1A1A1A"/>
+                  <a:srgbClr val="193D4E"/>
                 </a:solidFill>
                 <a:latin typeface="Arial"/>
               </a:defRPr>
@@ -7236,7 +7236,7 @@
               </a:defRPr>
             </a:pPr>
             <a:r>
-              <a:t>IMOBX / PARTNER DISCUSSION DRAFT / 15 OCT 2026</a:t>
+              <a:t>IMOBX / PARTNER DISCUSSION DRAFT / v0.6 / 2026-10-17</a:t>
             </a:r>
           </a:p>
         </p:txBody>
@@ -7431,13 +7431,13 @@
             <a:pPr>
               <a:defRPr sz="4000" b="0">
                 <a:solidFill>
-                  <a:srgbClr val="1A1A1A"/>
-                </a:solidFill>
-                <a:latin typeface="Arial"/>
-              </a:defRPr>
-            </a:pPr>
-            <a:r>
-              <a:t>Put the home and responsibilities in writing.</a:t>
+                  <a:srgbClr val="193D4E"/>
+                </a:solidFill>
+                <a:latin typeface="Arial"/>
+              </a:defRPr>
+            </a:pPr>
+            <a:r>
+              <a:t>Part of each payment would go towards buying the home.</a:t>
             </a:r>
           </a:p>
         </p:txBody>
@@ -7473,7 +7473,7 @@
               </a:defRPr>
             </a:pPr>
             <a:r>
-              <a:t>IMOBX would arrange property access, family agreements and building work.</a:t>
+              <a:t>The household could see what it has paid towards the purchase and how much remains.</a:t>
             </a:r>
           </a:p>
         </p:txBody>
@@ -7539,13 +7539,13 @@
             <a:pPr>
               <a:defRPr sz="1800" b="0">
                 <a:solidFill>
-                  <a:srgbClr val="1A1A1A"/>
-                </a:solidFill>
-                <a:latin typeface="Arial"/>
-              </a:defRPr>
-            </a:pPr>
-            <a:r>
-              <a:t>Check who owns the property and how IMOBX may use it.</a:t>
+                  <a:srgbClr val="193D4E"/>
+                </a:solidFill>
+                <a:latin typeface="Arial"/>
+              </a:defRPr>
+            </a:pPr>
+            <a:r>
+              <a:t>The agreement sets the price and how much of each payment goes towards buying.</a:t>
             </a:r>
           </a:p>
         </p:txBody>
@@ -7611,13 +7611,13 @@
             <a:pPr>
               <a:defRPr sz="1800" b="0">
                 <a:solidFill>
-                  <a:srgbClr val="1A1A1A"/>
-                </a:solidFill>
-                <a:latin typeface="Arial"/>
-              </a:defRPr>
-            </a:pPr>
-            <a:r>
-              <a:t>Agree the builder’s work, price, deadline and who checks it.</a:t>
+                  <a:srgbClr val="193D4E"/>
+                </a:solidFill>
+                <a:latin typeface="Arial"/>
+              </a:defRPr>
+            </a:pPr>
+            <a:r>
+              <a:t>The household can follow the amount paid and the remaining price.</a:t>
             </a:r>
           </a:p>
         </p:txBody>
@@ -7683,13 +7683,13 @@
             <a:pPr>
               <a:defRPr sz="1800" b="0">
                 <a:solidFill>
-                  <a:srgbClr val="1A1A1A"/>
-                </a:solidFill>
-                <a:latin typeface="Arial"/>
-              </a:defRPr>
-            </a:pPr>
-            <a:r>
-              <a:t>Explain payments, purchase progress and the final transfer.</a:t>
+                  <a:srgbClr val="193D4E"/>
+                </a:solidFill>
+                <a:latin typeface="Arial"/>
+              </a:defRPr>
+            </a:pPr>
+            <a:r>
+              <a:t>The whole home transfers to the household once the purchase terms are met.</a:t>
             </a:r>
           </a:p>
         </p:txBody>
@@ -7725,7 +7725,7 @@
               </a:defRPr>
             </a:pPr>
             <a:r>
-              <a:t>IMOBX / PARTNER DISCUSSION DRAFT / 15 OCT 2026</a:t>
+              <a:t>IMOBX / PARTNER DISCUSSION DRAFT / v0.6 / 2026-10-17</a:t>
             </a:r>
           </a:p>
         </p:txBody>
@@ -7920,7 +7920,7 @@
             <a:pPr>
               <a:defRPr sz="4000" b="0">
                 <a:solidFill>
-                  <a:srgbClr val="1A1A1A"/>
+                  <a:srgbClr val="193D4E"/>
                 </a:solidFill>
                 <a:latin typeface="Arial"/>
               </a:defRPr>
@@ -8028,7 +8028,7 @@
             <a:pPr>
               <a:defRPr sz="1800" b="0">
                 <a:solidFill>
-                  <a:srgbClr val="1A1A1A"/>
+                  <a:srgbClr val="193D4E"/>
                 </a:solidFill>
                 <a:latin typeface="Arial"/>
               </a:defRPr>
@@ -8100,7 +8100,7 @@
             <a:pPr>
               <a:defRPr sz="1800" b="0">
                 <a:solidFill>
-                  <a:srgbClr val="1A1A1A"/>
+                  <a:srgbClr val="193D4E"/>
                 </a:solidFill>
                 <a:latin typeface="Arial"/>
               </a:defRPr>
@@ -8172,7 +8172,7 @@
             <a:pPr>
               <a:defRPr sz="1800" b="0">
                 <a:solidFill>
-                  <a:srgbClr val="1A1A1A"/>
+                  <a:srgbClr val="193D4E"/>
                 </a:solidFill>
                 <a:latin typeface="Arial"/>
               </a:defRPr>
@@ -8214,7 +8214,7 @@
               </a:defRPr>
             </a:pPr>
             <a:r>
-              <a:t>IMOBX / PARTNER DISCUSSION DRAFT / 15 OCT 2026</a:t>
+              <a:t>IMOBX / PARTNER DISCUSSION DRAFT / v0.6 / 2026-10-17</a:t>
             </a:r>
           </a:p>
         </p:txBody>
@@ -8409,7 +8409,7 @@
             <a:pPr>
               <a:defRPr sz="4000" b="0">
                 <a:solidFill>
-                  <a:srgbClr val="1A1A1A"/>
+                  <a:srgbClr val="193D4E"/>
                 </a:solidFill>
                 <a:latin typeface="Arial"/>
               </a:defRPr>
@@ -8517,7 +8517,7 @@
             <a:pPr>
               <a:defRPr sz="1800" b="0">
                 <a:solidFill>
-                  <a:srgbClr val="1A1A1A"/>
+                  <a:srgbClr val="193D4E"/>
                 </a:solidFill>
                 <a:latin typeface="Arial"/>
               </a:defRPr>
@@ -8589,7 +8589,7 @@
             <a:pPr>
               <a:defRPr sz="1800" b="0">
                 <a:solidFill>
-                  <a:srgbClr val="1A1A1A"/>
+                  <a:srgbClr val="193D4E"/>
                 </a:solidFill>
                 <a:latin typeface="Arial"/>
               </a:defRPr>
@@ -8661,7 +8661,7 @@
             <a:pPr>
               <a:defRPr sz="1800" b="0">
                 <a:solidFill>
-                  <a:srgbClr val="1A1A1A"/>
+                  <a:srgbClr val="193D4E"/>
                 </a:solidFill>
                 <a:latin typeface="Arial"/>
               </a:defRPr>
@@ -8703,7 +8703,7 @@
               </a:defRPr>
             </a:pPr>
             <a:r>
-              <a:t>IMOBX / PARTNER DISCUSSION DRAFT / 15 OCT 2026</a:t>
+              <a:t>IMOBX / PARTNER DISCUSSION DRAFT / v0.6 / 2026-10-17</a:t>
             </a:r>
           </a:p>
         </p:txBody>
@@ -8898,13 +8898,13 @@
             <a:pPr>
               <a:defRPr sz="4000" b="0">
                 <a:solidFill>
-                  <a:srgbClr val="1A1A1A"/>
-                </a:solidFill>
-                <a:latin typeface="Arial"/>
-              </a:defRPr>
-            </a:pPr>
-            <a:r>
-              <a:t>Give residents a real say.</a:t>
+                  <a:srgbClr val="193D4E"/>
+                </a:solidFill>
+                <a:latin typeface="Arial"/>
+              </a:defRPr>
+            </a:pPr>
+            <a:r>
+              <a:t>Residents would decide how shared spaces are used.</a:t>
             </a:r>
           </a:p>
         </p:txBody>
@@ -8940,7 +8940,7 @@
               </a:defRPr>
             </a:pPr>
             <a:r>
-              <a:t>Discuss which decisions belong to residents, workers and possible investors.</a:t>
+              <a:t>Courtyard use, study-room hours, repair priorities and representatives are resident matters.</a:t>
             </a:r>
           </a:p>
         </p:txBody>
@@ -9006,13 +9006,13 @@
             <a:pPr>
               <a:defRPr sz="1800" b="0">
                 <a:solidFill>
-                  <a:srgbClr val="1A1A1A"/>
-                </a:solidFill>
-                <a:latin typeface="Arial"/>
-              </a:defRPr>
-            </a:pPr>
-            <a:r>
-              <a:t>Residents help decide how shared spaces and repairs work.</a:t>
+                  <a:srgbClr val="193D4E"/>
+                </a:solidFill>
+                <a:latin typeface="Arial"/>
+              </a:defRPr>
+            </a:pPr>
+            <a:r>
+              <a:t>One vote per member is an option under discussion.</a:t>
             </a:r>
           </a:p>
         </p:txBody>
@@ -9078,13 +9078,13 @@
             <a:pPr>
               <a:defRPr sz="1800" b="0">
                 <a:solidFill>
-                  <a:srgbClr val="1A1A1A"/>
-                </a:solidFill>
-                <a:latin typeface="Arial"/>
-              </a:defRPr>
-            </a:pPr>
-            <a:r>
-              <a:t>People chosen for work have time limits and can be replaced.</a:t>
+                  <a:srgbClr val="193D4E"/>
+                </a:solidFill>
+                <a:latin typeface="Arial"/>
+              </a:defRPr>
+            </a:pPr>
+            <a:r>
+              <a:t>No investment purchase or promotional work would be required for a voice.</a:t>
             </a:r>
           </a:p>
         </p:txBody>
@@ -9150,13 +9150,13 @@
             <a:pPr>
               <a:defRPr sz="1800" b="0">
                 <a:solidFill>
-                  <a:srgbClr val="1A1A1A"/>
-                </a:solidFill>
-                <a:latin typeface="Arial"/>
-              </a:defRPr>
-            </a:pPr>
-            <a:r>
-              <a:t>Housing and purchase rights stay protected by agreements and law.</a:t>
+                  <a:srgbClr val="193D4E"/>
+                </a:solidFill>
+                <a:latin typeface="Arial"/>
+              </a:defRPr>
+            </a:pPr>
+            <a:r>
+              <a:t>Investor rights and each household’s contract have their own terms.</a:t>
             </a:r>
           </a:p>
         </p:txBody>
@@ -9192,7 +9192,7 @@
               </a:defRPr>
             </a:pPr>
             <a:r>
-              <a:t>IMOBX / PARTNER DISCUSSION DRAFT / 15 OCT 2026</a:t>
+              <a:t>IMOBX / PARTNER DISCUSSION DRAFT / v0.6 / 2026-10-17</a:t>
             </a:r>
           </a:p>
         </p:txBody>
@@ -9387,7 +9387,7 @@
             <a:pPr>
               <a:defRPr sz="4000" b="0">
                 <a:solidFill>
-                  <a:srgbClr val="1A1A1A"/>
+                  <a:srgbClr val="193D4E"/>
                 </a:solidFill>
                 <a:latin typeface="Arial"/>
               </a:defRPr>
@@ -9495,7 +9495,7 @@
             <a:pPr>
               <a:defRPr sz="1800" b="0">
                 <a:solidFill>
-                  <a:srgbClr val="1A1A1A"/>
+                  <a:srgbClr val="193D4E"/>
                 </a:solidFill>
                 <a:latin typeface="Arial"/>
               </a:defRPr>
@@ -9567,7 +9567,7 @@
             <a:pPr>
               <a:defRPr sz="1800" b="0">
                 <a:solidFill>
-                  <a:srgbClr val="1A1A1A"/>
+                  <a:srgbClr val="193D4E"/>
                 </a:solidFill>
                 <a:latin typeface="Arial"/>
               </a:defRPr>
@@ -9639,7 +9639,7 @@
             <a:pPr>
               <a:defRPr sz="1800" b="0">
                 <a:solidFill>
-                  <a:srgbClr val="1A1A1A"/>
+                  <a:srgbClr val="193D4E"/>
                 </a:solidFill>
                 <a:latin typeface="Arial"/>
               </a:defRPr>
@@ -9681,7 +9681,7 @@
               </a:defRPr>
             </a:pPr>
             <a:r>
-              <a:t>IMOBX / PARTNER DISCUSSION DRAFT / 15 OCT 2026</a:t>
+              <a:t>IMOBX / PARTNER DISCUSSION DRAFT / v0.6 / 2026-10-17</a:t>
             </a:r>
           </a:p>
         </p:txBody>
@@ -9876,13 +9876,13 @@
             <a:pPr>
               <a:defRPr sz="4000" b="0">
                 <a:solidFill>
-                  <a:srgbClr val="1A1A1A"/>
-                </a:solidFill>
-                <a:latin typeface="Arial"/>
-              </a:defRPr>
-            </a:pPr>
-            <a:r>
-              <a:t>Raise capital for homes. Define what investors receive.</a:t>
+                  <a:srgbClr val="193D4E"/>
+                </a:solidFill>
+                <a:latin typeface="Arial"/>
+              </a:defRPr>
+            </a:pPr>
+            <a:r>
+              <a:t>A possible token could fund operations and outreach.</a:t>
             </a:r>
           </a:p>
         </p:txBody>
@@ -9918,7 +9918,7 @@
               </a:defRPr>
             </a:pPr>
             <a:r>
-              <a:t>We are studying a financial token to fund construction and growth.</a:t>
+              <a:t>In a direct issue, buyers would pay the issuing organization; their rights are still undecided.</a:t>
             </a:r>
           </a:p>
         </p:txBody>
@@ -9984,13 +9984,13 @@
             <a:pPr>
               <a:defRPr sz="1800" b="0">
                 <a:solidFill>
-                  <a:srgbClr val="1A1A1A"/>
-                </a:solidFill>
-                <a:latin typeface="Arial"/>
-              </a:defRPr>
-            </a:pPr>
-            <a:r>
-              <a:t>A new issue would bring investment money into the housing operation.</a:t>
+                  <a:srgbClr val="193D4E"/>
+                </a:solidFill>
+                <a:latin typeface="Arial"/>
+              </a:defRPr>
+            </a:pPr>
+            <a:r>
+              <a:t>A later resale normally pays the seller; any project fee is separate.</a:t>
             </a:r>
           </a:p>
         </p:txBody>
@@ -10056,13 +10056,13 @@
             <a:pPr>
               <a:defRPr sz="1800" b="0">
                 <a:solidFill>
-                  <a:srgbClr val="1A1A1A"/>
-                </a:solidFill>
-                <a:latin typeface="Arial"/>
-              </a:defRPr>
-            </a:pPr>
-            <a:r>
-              <a:t>Define the issuer, financial rights, income source, losses and exit.</a:t>
+                  <a:srgbClr val="193D4E"/>
+                </a:solidFill>
+                <a:latin typeface="Arial"/>
+              </a:defRPr>
+            </a:pPr>
+            <a:r>
+              <a:t>Paid outreach needs a funded brief, accepted work and disclosure.</a:t>
             </a:r>
           </a:p>
         </p:txBody>
@@ -10128,13 +10128,13 @@
             <a:pPr>
               <a:defRPr sz="1800" b="0">
                 <a:solidFill>
-                  <a:srgbClr val="1A1A1A"/>
-                </a:solidFill>
-                <a:latin typeface="Arial"/>
-              </a:defRPr>
-            </a:pPr>
-            <a:r>
-              <a:t>Keep family agreements and residents’ say in decisions protected.</a:t>
+                  <a:srgbClr val="193D4E"/>
+                </a:solidFill>
+                <a:latin typeface="Arial"/>
+              </a:defRPr>
+            </a:pPr>
+            <a:r>
+              <a:t>No dividend, discount or token voting model has been selected.</a:t>
             </a:r>
           </a:p>
         </p:txBody>
@@ -10170,7 +10170,7 @@
               </a:defRPr>
             </a:pPr>
             <a:r>
-              <a:t>IMOBX / PARTNER DISCUSSION DRAFT / 15 OCT 2026</a:t>
+              <a:t>IMOBX / PARTNER DISCUSSION DRAFT / v0.6 / 2026-10-17</a:t>
             </a:r>
           </a:p>
         </p:txBody>

</xml_diff>

<commit_message>
Clarify housing explanations and organise project documents
</commit_message>
<xml_diff>
--- a/pitchdeck.pptx
+++ b/pitchdeck.pptx
@@ -519,7 +519,7 @@
           <a:p/>
           <a:p>
             <a:r>
-              <a:t>Sources and factual limits: companion whitepaper v0.6 and reference.html.</a:t>
+              <a:t>Sources and factual limits: companion whitepaper v0.7 and reference.html.</a:t>
             </a:r>
           </a:p>
         </p:txBody>
@@ -589,13 +589,13 @@
           <a:lstStyle/>
           <a:p>
             <a:r>
-              <a:t>The six stages are legal structure and property; resident participation; first homes; transparent treasury; funding and account review; more homes and owner partnerships. Rafael contributes construction and local knowledge; John contributes communication and digital coordination. Adviser, accounting, approval and independent inspection roles still need appointments. OLYMPUS is a possible founder-linked contractor requiring independent approval. A community or charitable partner is a possible relationship. Construction dates depend on the chosen project, funding and permissions. A review after at least three operating months is proposed before expanding. The roadmap lists responsibilities and reasons to pause each stage.</a:t>
+              <a:t>The six stages are legal structure and property; resident participation; first homes; payment records people can check; funding and account review; more homes and owner partnerships. Rafael contributes construction and local knowledge; John contributes communication and digital coordination. Adviser, accounting, approval and independent inspection roles still need appointments. OLYMPUS is a possible builder connected to Rafael. Its appointment would need approval by someone independent of the builder. A community or charitable partner is a possible relationship. Construction dates depend on the chosen project, funding and permissions. A review after at least three operating months is proposed before expanding. The roadmap lists responsibilities and reasons to pause each stage.</a:t>
             </a:r>
           </a:p>
           <a:p/>
           <a:p>
             <a:r>
-              <a:t>Sources and factual limits: companion whitepaper v0.6 and reference.html.</a:t>
+              <a:t>Sources and factual limits: companion whitepaper v0.7 and reference.html.</a:t>
             </a:r>
           </a:p>
         </p:txBody>
@@ -665,13 +665,13 @@
           <a:lstStyle/>
           <a:p>
             <a:r>
-              <a:t>Agree response times and affordability targets with local participants. Report homes as planned, contracted, delivered or transferred, with checked records. Token prices and holder counts do not measure how well families are housed. No completed transfers or committed capital are invented here.</a:t>
+              <a:t>Agree response times and affordability targets with local participants. Report homes as planned, contracted, delivered or transferred, with checked records. Token prices and holder counts do not measure how well families are housed. The published records do not yet document completed home transfers or committed capital.</a:t>
             </a:r>
           </a:p>
           <a:p/>
           <a:p>
             <a:r>
-              <a:t>Sources and factual limits: companion whitepaper v0.6 and reference.html.</a:t>
+              <a:t>Sources and factual limits: companion whitepaper v0.7 and reference.html.</a:t>
             </a:r>
           </a:p>
         </p:txBody>
@@ -741,13 +741,13 @@
           <a:lstStyle/>
           <a:p>
             <a:r>
-              <a:t>These are possible contributions, not confirmed partnerships or contracts. The contact page has separate routes and explanations. Receiving contacts are still placeholders: visitors can prepare and copy an introduction, but the website sends nothing. A property introduction can lead to assessment, not an automatic transfer. A founder-linked builder needs independent contract and delivery review. See contact.html and rent-to-own.html#property.</a:t>
+              <a:t>These are possible contributions, not confirmed partnerships or contracts. The contact page has separate routes and explanations. Receiving contacts are still placeholders: visitors can prepare and copy an introduction, but the website sends nothing. A property introduction can lead to assessment, not an automatic transfer. If a builder is connected to an IMOBX founder, someone independent must check the contract and completed work. See contact.html and rent-to-own.html#property.</a:t>
             </a:r>
           </a:p>
           <a:p/>
           <a:p>
             <a:r>
-              <a:t>Sources and factual limits: companion whitepaper v0.6 and reference.html.</a:t>
+              <a:t>Sources and factual limits: companion whitepaper v0.7 and reference.html.</a:t>
             </a:r>
           </a:p>
         </p:txBody>
@@ -817,13 +817,13 @@
           <a:lstStyle/>
           <a:p>
             <a:r>
-              <a:t>Brazil’s 2022 Census counted about 16.4 million residents in favelas and urban communities, 8.1% of the population. That is national context, not a description of a selected family or site. Living in a favela does not itself mean being displaced. Listen to families about work, schools, transport, support networks and whether a move suits them. No pilot families are claimed as enrolled.</a:t>
+              <a:t>Brazil’s 2022 Census counted about 16.4 million residents in favelas and urban communities, 8.1% of the population. That is national context, not a description of a selected family or site. Living in a favela does not itself mean being displaced. Listen to families about work, schools, transport, support networks and whether a move suits them. Participating households are not identified in this draft.</a:t>
             </a:r>
           </a:p>
           <a:p/>
           <a:p>
             <a:r>
-              <a:t>Sources and factual limits: companion whitepaper v0.6 and reference.html.</a:t>
+              <a:t>Sources and factual limits: companion whitepaper v0.7 and reference.html.</a:t>
             </a:r>
           </a:p>
         </p:txBody>
@@ -899,7 +899,7 @@
           <a:p/>
           <a:p>
             <a:r>
-              <a:t>Sources and factual limits: companion whitepaper v0.6 and reference.html.</a:t>
+              <a:t>Sources and factual limits: companion whitepaper v0.7 and reference.html.</a:t>
             </a:r>
           </a:p>
         </p:txBody>
@@ -969,13 +969,13 @@
           <a:lstStyle/>
           <a:p>
             <a:r>
-              <a:t>This is the proposed arrangement, not a current home offer. The first purchase price, monthly payment, purchase credit and payment period have not been set. Rafael’s village budget and the two-loft contract are construction cases, not household sale prices. Repair charges, hardship and exit terms remain open. The household explanation is at rent-to-own.html. Property authority, budget and independent inspection remain necessary for delivery.</a:t>
+              <a:t>The first homes are still being planned. This slide does not offer a home. The first home’s price, monthly payment and time to pay have not been set. How much of each payment would count towards buying it also remains to be agreed. Rafael’s village budget and the two-loft contract are construction cases, not household sale prices. Repair charges, hardship and exit terms remain open. The household explanation is at rent-to-own.html. Before building, the project needs documents showing the right to use the property, a budget and someone independent to inspect the work.</a:t>
             </a:r>
           </a:p>
           <a:p/>
           <a:p>
             <a:r>
-              <a:t>Sources and factual limits: companion whitepaper v0.6 and reference.html.</a:t>
+              <a:t>Sources and factual limits: companion whitepaper v0.7 and reference.html.</a:t>
             </a:r>
           </a:p>
         </p:txBody>
@@ -1051,7 +1051,7 @@
           <a:p/>
           <a:p>
             <a:r>
-              <a:t>Sources and factual limits: companion whitepaper v0.6 and reference.html.</a:t>
+              <a:t>Sources and factual limits: companion whitepaper v0.7 and reference.html.</a:t>
             </a:r>
           </a:p>
         </p:txBody>
@@ -1127,7 +1127,7 @@
           <a:p/>
           <a:p>
             <a:r>
-              <a:t>Sources and factual limits: companion whitepaper v0.6 and reference.html.</a:t>
+              <a:t>Sources and factual limits: companion whitepaper v0.7 and reference.html.</a:t>
             </a:r>
           </a:p>
         </p:txBody>
@@ -1197,13 +1197,13 @@
           <a:lstStyle/>
           <a:p>
             <a:r>
-              <a:t>The voting procedure, spending limits and review route have not been agreed with participants. In the proposed repair process, a resident reports a leak, a maintenance contact obtains a quote, spending follows the agreed limit and another person checks the work. Buying tokens would not give control over another household’s contracted purchase price. See rent-to-own.html#decisions and roadmap.html#governance. Do not describe this proposal as a functioning resident assembly.</a:t>
+              <a:t>The voting procedure, spending limits and way to question a decision have not been agreed with participants. In the proposed repair process, a resident reports a leak, a maintenance contact obtains a quote, spending follows the agreed limit and another person checks the work. Buying tokens would not give control over another household’s contracted purchase price. See rent-to-own.html#decisions and roadmap.html#governance. Resident decision-making is still a proposal and has not yet been demonstrated in IMOBX.</a:t>
             </a:r>
           </a:p>
           <a:p/>
           <a:p>
             <a:r>
-              <a:t>Sources and factual limits: companion whitepaper v0.6 and reference.html.</a:t>
+              <a:t>Sources and factual limits: companion whitepaper v0.7 and reference.html.</a:t>
             </a:r>
           </a:p>
         </p:txBody>
@@ -1279,7 +1279,7 @@
           <a:p/>
           <a:p>
             <a:r>
-              <a:t>Sources and factual limits: companion whitepaper v0.6 and reference.html.</a:t>
+              <a:t>Sources and factual limits: companion whitepaper v0.7 and reference.html.</a:t>
             </a:r>
           </a:p>
         </p:txBody>
@@ -1349,13 +1349,13 @@
           <a:lstStyle/>
           <a:p>
             <a:r>
-              <a:t>Four scenarios remain: no IMOBX token, a service or membership benefit, fee participation, or an investment in the operation. These are alternatives, not combined promised rights. Capital for construction, outreach payments and investor income have different budgets and commitments. Residents’ participation would not depend on investment or promotion. Reference.html#token compares what a buyer might receive and the decisions still open.</a:t>
+              <a:t>Four scenarios remain: no IMOBX token, a service or membership benefit, a share of collected fees, or an investment in the operation. These are alternatives, not combined promised rights. Capital for construction, outreach payments and investor income have different budgets and commitments. Residents’ participation would not depend on investment or promotion. Reference.html#token compares what a buyer might receive and the decisions still open.</a:t>
             </a:r>
           </a:p>
           <a:p/>
           <a:p>
             <a:r>
-              <a:t>Sources and factual limits: companion whitepaper v0.6 and reference.html.</a:t>
+              <a:t>Sources and factual limits: companion whitepaper v0.7 and reference.html.</a:t>
             </a:r>
           </a:p>
         </p:txBody>
@@ -4791,7 +4791,7 @@
               </a:defRPr>
             </a:pPr>
             <a:r>
-              <a:t>IMOBX / PARTNER DISCUSSION DRAFT / v0.6 / 2026-10-17</a:t>
+              <a:t>IMOBX / PARTNER DISCUSSION DRAFT / v0.7 / 2026-10-19</a:t>
             </a:r>
           </a:p>
         </p:txBody>
@@ -5280,7 +5280,7 @@
               </a:defRPr>
             </a:pPr>
             <a:r>
-              <a:t>IMOBX / PARTNER DISCUSSION DRAFT / v0.6 / 2026-10-17</a:t>
+              <a:t>IMOBX / PARTNER DISCUSSION DRAFT / v0.7 / 2026-10-19</a:t>
             </a:r>
           </a:p>
         </p:txBody>
@@ -5661,7 +5661,7 @@
               </a:defRPr>
             </a:pPr>
             <a:r>
-              <a:t>Match every receipt and payment; report repairs and unresolved issues.</a:t>
+              <a:t>Check money received and paid against the records; report repairs and unresolved issues.</a:t>
             </a:r>
           </a:p>
         </p:txBody>
@@ -5769,7 +5769,7 @@
               </a:defRPr>
             </a:pPr>
             <a:r>
-              <a:t>IMOBX / PARTNER DISCUSSION DRAFT / v0.6 / 2026-10-17</a:t>
+              <a:t>IMOBX / PARTNER DISCUSSION DRAFT / v0.7 / 2026-10-19</a:t>
             </a:r>
           </a:p>
         </p:txBody>
@@ -6258,7 +6258,7 @@
               </a:defRPr>
             </a:pPr>
             <a:r>
-              <a:t>IMOBX / PARTNER DISCUSSION DRAFT / v0.6 / 2026-10-17</a:t>
+              <a:t>IMOBX / PARTNER DISCUSSION DRAFT / v0.7 / 2026-10-19</a:t>
             </a:r>
           </a:p>
         </p:txBody>
@@ -6747,7 +6747,7 @@
               </a:defRPr>
             </a:pPr>
             <a:r>
-              <a:t>IMOBX / PARTNER DISCUSSION DRAFT / v0.6 / 2026-10-17</a:t>
+              <a:t>IMOBX / PARTNER DISCUSSION DRAFT / v0.7 / 2026-10-19</a:t>
             </a:r>
           </a:p>
         </p:txBody>
@@ -7236,7 +7236,7 @@
               </a:defRPr>
             </a:pPr>
             <a:r>
-              <a:t>IMOBX / PARTNER DISCUSSION DRAFT / v0.6 / 2026-10-17</a:t>
+              <a:t>IMOBX / PARTNER DISCUSSION DRAFT / v0.7 / 2026-10-19</a:t>
             </a:r>
           </a:p>
         </p:txBody>
@@ -7725,7 +7725,7 @@
               </a:defRPr>
             </a:pPr>
             <a:r>
-              <a:t>IMOBX / PARTNER DISCUSSION DRAFT / v0.6 / 2026-10-17</a:t>
+              <a:t>IMOBX / PARTNER DISCUSSION DRAFT / v0.7 / 2026-10-19</a:t>
             </a:r>
           </a:p>
         </p:txBody>
@@ -8106,7 +8106,7 @@
               </a:defRPr>
             </a:pPr>
             <a:r>
-              <a:t>Keep money for empty homes and commitments to families.</a:t>
+              <a:t>Keep money for empty homes and promises made to families.</a:t>
             </a:r>
           </a:p>
         </p:txBody>
@@ -8214,7 +8214,7 @@
               </a:defRPr>
             </a:pPr>
             <a:r>
-              <a:t>IMOBX / PARTNER DISCUSSION DRAFT / v0.6 / 2026-10-17</a:t>
+              <a:t>IMOBX / PARTNER DISCUSSION DRAFT / v0.7 / 2026-10-19</a:t>
             </a:r>
           </a:p>
         </p:txBody>
@@ -8703,7 +8703,7 @@
               </a:defRPr>
             </a:pPr>
             <a:r>
-              <a:t>IMOBX / PARTNER DISCUSSION DRAFT / v0.6 / 2026-10-17</a:t>
+              <a:t>IMOBX / PARTNER DISCUSSION DRAFT / v0.7 / 2026-10-19</a:t>
             </a:r>
           </a:p>
         </p:txBody>
@@ -9192,7 +9192,7 @@
               </a:defRPr>
             </a:pPr>
             <a:r>
-              <a:t>IMOBX / PARTNER DISCUSSION DRAFT / v0.6 / 2026-10-17</a:t>
+              <a:t>IMOBX / PARTNER DISCUSSION DRAFT / v0.7 / 2026-10-19</a:t>
             </a:r>
           </a:p>
         </p:txBody>
@@ -9681,7 +9681,7 @@
               </a:defRPr>
             </a:pPr>
             <a:r>
-              <a:t>IMOBX / PARTNER DISCUSSION DRAFT / v0.6 / 2026-10-17</a:t>
+              <a:t>IMOBX / PARTNER DISCUSSION DRAFT / v0.7 / 2026-10-19</a:t>
             </a:r>
           </a:p>
         </p:txBody>
@@ -9918,7 +9918,7 @@
               </a:defRPr>
             </a:pPr>
             <a:r>
-              <a:t>In a direct issue, buyers would pay the issuing organization; their rights are still undecided.</a:t>
+              <a:t>Buyers of new tokens would pay the organisation that creates and sells them. Their rights are still undecided.</a:t>
             </a:r>
           </a:p>
         </p:txBody>
@@ -10062,7 +10062,7 @@
               </a:defRPr>
             </a:pPr>
             <a:r>
-              <a:t>Paid outreach needs a funded brief, accepted work and disclosure.</a:t>
+              <a:t>Paid outreach needs a funded task, a check of the completed work and disclosure of payment.</a:t>
             </a:r>
           </a:p>
         </p:txBody>
@@ -10170,7 +10170,7 @@
               </a:defRPr>
             </a:pPr>
             <a:r>
-              <a:t>IMOBX / PARTNER DISCUSSION DRAFT / v0.6 / 2026-10-17</a:t>
+              <a:t>IMOBX / PARTNER DISCUSSION DRAFT / v0.7 / 2026-10-19</a:t>
             </a:r>
           </a:p>
         </p:txBody>

</xml_diff>

<commit_message>
Make the housing proposal read plainly for families
Remove numbered section labels, side stripes and arrow symbols; use one headline style and a darker teal for text. Lead the homepage with a plain statement of what exists and what is not decided yet, and keep funding and token detail on the funding page and the FAQ. Describe the plan plainly, add a footer naming the people involved, label the village illustration as image-generated, and replace the contact menu item until a receiving contact exists. Rebuild the downloadable documents from the same text.

Co-Authored-By: Claude Opus 5.5 <noreply@anthropic.com>
</commit_message>
<xml_diff>
--- a/pitchdeck.pptx
+++ b/pitchdeck.pptx
@@ -741,7 +741,7 @@
           <a:lstStyle/>
           <a:p>
             <a:r>
-              <a:t>These are possible contributions, not confirmed partnerships or contracts. The contact page has separate routes and explanations. Receiving contacts are still placeholders: visitors can prepare and copy an introduction, but the website sends nothing. A property introduction can lead to assessment, not an automatic transfer. If a builder is connected to an IMOBX founder, someone independent must check the contract and completed work. See contact.html and rent-to-own.html#property.</a:t>
+              <a:t>These are possible contributions, not confirmed partnerships or contracts. The contact page has separate routes and explanations. Contact details are still placeholders: visitors can prepare and copy an introduction, but the website sends nothing. A property introduction can lead to assessment, not an automatic transfer. If a builder is connected to an IMOBX founder, someone independent must check the contract and completed work. See contact.html and rent-to-own.html#property.</a:t>
             </a:r>
           </a:p>
           <a:p/>
@@ -4384,7 +4384,7 @@
             <a:avLst/>
           </a:prstGeom>
           <a:solidFill>
-            <a:srgbClr val="4A90A4"/>
+            <a:srgbClr val="276578"/>
           </a:solidFill>
           <a:ln>
             <a:noFill/>
@@ -4444,42 +4444,6 @@
         </p:nvSpPr>
         <p:spPr>
           <a:xfrm>
-            <a:off x="822960" y="548640"/>
-            <a:ext cx="9144000" cy="320040"/>
-          </a:xfrm>
-          <a:prstGeom prst="rect">
-            <a:avLst/>
-          </a:prstGeom>
-          <a:noFill/>
-        </p:spPr>
-        <p:txBody>
-          <a:bodyPr wrap="square" tIns="0" bIns="0" lIns="0" rIns="0">
-            <a:spAutoFit/>
-          </a:bodyPr>
-          <a:lstStyle/>
-          <a:p>
-            <a:pPr>
-              <a:defRPr sz="1100" b="1">
-                <a:solidFill>
-                  <a:srgbClr val="4A90A4"/>
-                </a:solidFill>
-                <a:latin typeface="Arial"/>
-              </a:defRPr>
-            </a:pPr>
-            <a:r>
-              <a:t>01 / THE PROJECT</a:t>
-            </a:r>
-          </a:p>
-        </p:txBody>
-      </p:sp>
-      <p:sp>
-        <p:nvSpPr>
-          <p:cNvPr id="5" name="TextBox 4"/>
-          <p:cNvSpPr txBox="1"/>
-          <p:nvPr/>
-        </p:nvSpPr>
-        <p:spPr>
-          <a:xfrm>
             <a:off x="731520" y="1069848"/>
             <a:ext cx="10698480" cy="1554480"/>
           </a:xfrm>
@@ -4503,14 +4467,14 @@
               </a:defRPr>
             </a:pPr>
             <a:r>
-              <a:t>Families would rent toward owning their home.</a:t>
-            </a:r>
-          </a:p>
-        </p:txBody>
-      </p:sp>
-      <p:sp>
-        <p:nvSpPr>
-          <p:cNvPr id="6" name="TextBox 5"/>
+              <a:t>Families would rent toward owning their home</a:t>
+            </a:r>
+          </a:p>
+        </p:txBody>
+      </p:sp>
+      <p:sp>
+        <p:nvSpPr>
+          <p:cNvPr id="5" name="TextBox 4"/>
           <p:cNvSpPr txBox="1"/>
           <p:nvPr/>
         </p:nvSpPr>
@@ -4546,7 +4510,7 @@
       </p:sp>
       <p:sp>
         <p:nvSpPr>
-          <p:cNvPr id="7" name="TextBox 6"/>
+          <p:cNvPr id="6" name="TextBox 5"/>
           <p:cNvSpPr txBox="1"/>
           <p:nvPr/>
         </p:nvSpPr>
@@ -4569,7 +4533,7 @@
             <a:pPr>
               <a:defRPr sz="1100" b="1">
                 <a:solidFill>
-                  <a:srgbClr val="4A90A4"/>
+                  <a:srgbClr val="276578"/>
                 </a:solidFill>
                 <a:latin typeface="Arial"/>
               </a:defRPr>
@@ -4582,7 +4546,7 @@
       </p:sp>
       <p:sp>
         <p:nvSpPr>
-          <p:cNvPr id="8" name="TextBox 7"/>
+          <p:cNvPr id="7" name="TextBox 6"/>
           <p:cNvSpPr txBox="1"/>
           <p:nvPr/>
         </p:nvSpPr>
@@ -4618,7 +4582,7 @@
       </p:sp>
       <p:sp>
         <p:nvSpPr>
-          <p:cNvPr id="9" name="TextBox 8"/>
+          <p:cNvPr id="8" name="TextBox 7"/>
           <p:cNvSpPr txBox="1"/>
           <p:nvPr/>
         </p:nvSpPr>
@@ -4641,7 +4605,7 @@
             <a:pPr>
               <a:defRPr sz="1100" b="1">
                 <a:solidFill>
-                  <a:srgbClr val="4A90A4"/>
+                  <a:srgbClr val="276578"/>
                 </a:solidFill>
                 <a:latin typeface="Arial"/>
               </a:defRPr>
@@ -4654,7 +4618,7 @@
       </p:sp>
       <p:sp>
         <p:nvSpPr>
-          <p:cNvPr id="10" name="TextBox 9"/>
+          <p:cNvPr id="9" name="TextBox 8"/>
           <p:cNvSpPr txBox="1"/>
           <p:nvPr/>
         </p:nvSpPr>
@@ -4690,7 +4654,7 @@
       </p:sp>
       <p:sp>
         <p:nvSpPr>
-          <p:cNvPr id="11" name="TextBox 10"/>
+          <p:cNvPr id="10" name="TextBox 9"/>
           <p:cNvSpPr txBox="1"/>
           <p:nvPr/>
         </p:nvSpPr>
@@ -4713,7 +4677,7 @@
             <a:pPr>
               <a:defRPr sz="1100" b="1">
                 <a:solidFill>
-                  <a:srgbClr val="4A90A4"/>
+                  <a:srgbClr val="276578"/>
                 </a:solidFill>
                 <a:latin typeface="Arial"/>
               </a:defRPr>
@@ -4726,7 +4690,7 @@
       </p:sp>
       <p:sp>
         <p:nvSpPr>
-          <p:cNvPr id="12" name="TextBox 11"/>
+          <p:cNvPr id="11" name="TextBox 10"/>
           <p:cNvSpPr txBox="1"/>
           <p:nvPr/>
         </p:nvSpPr>
@@ -4762,7 +4726,7 @@
       </p:sp>
       <p:sp>
         <p:nvSpPr>
-          <p:cNvPr id="13" name="TextBox 12"/>
+          <p:cNvPr id="12" name="TextBox 11"/>
           <p:cNvSpPr txBox="1"/>
           <p:nvPr/>
         </p:nvSpPr>
@@ -4798,7 +4762,7 @@
       </p:sp>
       <p:sp>
         <p:nvSpPr>
-          <p:cNvPr id="14" name="TextBox 13"/>
+          <p:cNvPr id="13" name="TextBox 12"/>
           <p:cNvSpPr txBox="1"/>
           <p:nvPr/>
         </p:nvSpPr>
@@ -4873,7 +4837,7 @@
             <a:avLst/>
           </a:prstGeom>
           <a:solidFill>
-            <a:srgbClr val="4A90A4"/>
+            <a:srgbClr val="276578"/>
           </a:solidFill>
           <a:ln>
             <a:noFill/>
@@ -4933,42 +4897,6 @@
         </p:nvSpPr>
         <p:spPr>
           <a:xfrm>
-            <a:off x="822960" y="548640"/>
-            <a:ext cx="9144000" cy="320040"/>
-          </a:xfrm>
-          <a:prstGeom prst="rect">
-            <a:avLst/>
-          </a:prstGeom>
-          <a:noFill/>
-        </p:spPr>
-        <p:txBody>
-          <a:bodyPr wrap="square" tIns="0" bIns="0" lIns="0" rIns="0">
-            <a:spAutoFit/>
-          </a:bodyPr>
-          <a:lstStyle/>
-          <a:p>
-            <a:pPr>
-              <a:defRPr sz="1100" b="1">
-                <a:solidFill>
-                  <a:srgbClr val="4A90A4"/>
-                </a:solidFill>
-                <a:latin typeface="Arial"/>
-              </a:defRPr>
-            </a:pPr>
-            <a:r>
-              <a:t>10 / THE ROADMAP</a:t>
-            </a:r>
-          </a:p>
-        </p:txBody>
-      </p:sp>
-      <p:sp>
-        <p:nvSpPr>
-          <p:cNvPr id="5" name="TextBox 4"/>
-          <p:cNvSpPr txBox="1"/>
-          <p:nvPr/>
-        </p:nvSpPr>
-        <p:spPr>
-          <a:xfrm>
             <a:off x="731520" y="1069848"/>
             <a:ext cx="10698480" cy="1554480"/>
           </a:xfrm>
@@ -4992,14 +4920,14 @@
               </a:defRPr>
             </a:pPr>
             <a:r>
-              <a:t>Each stage needs evidence before it advances.</a:t>
-            </a:r>
-          </a:p>
-        </p:txBody>
-      </p:sp>
-      <p:sp>
-        <p:nvSpPr>
-          <p:cNvPr id="6" name="TextBox 5"/>
+              <a:t>Each stage needs evidence before it advances</a:t>
+            </a:r>
+          </a:p>
+        </p:txBody>
+      </p:sp>
+      <p:sp>
+        <p:nvSpPr>
+          <p:cNvPr id="5" name="TextBox 4"/>
           <p:cNvSpPr txBox="1"/>
           <p:nvPr/>
         </p:nvSpPr>
@@ -5035,7 +4963,7 @@
       </p:sp>
       <p:sp>
         <p:nvSpPr>
-          <p:cNvPr id="7" name="TextBox 6"/>
+          <p:cNvPr id="6" name="TextBox 5"/>
           <p:cNvSpPr txBox="1"/>
           <p:nvPr/>
         </p:nvSpPr>
@@ -5058,7 +4986,7 @@
             <a:pPr>
               <a:defRPr sz="1100" b="1">
                 <a:solidFill>
-                  <a:srgbClr val="4A90A4"/>
+                  <a:srgbClr val="276578"/>
                 </a:solidFill>
                 <a:latin typeface="Arial"/>
               </a:defRPr>
@@ -5071,7 +4999,7 @@
       </p:sp>
       <p:sp>
         <p:nvSpPr>
-          <p:cNvPr id="8" name="TextBox 7"/>
+          <p:cNvPr id="7" name="TextBox 6"/>
           <p:cNvSpPr txBox="1"/>
           <p:nvPr/>
         </p:nvSpPr>
@@ -5107,7 +5035,7 @@
       </p:sp>
       <p:sp>
         <p:nvSpPr>
-          <p:cNvPr id="9" name="TextBox 8"/>
+          <p:cNvPr id="8" name="TextBox 7"/>
           <p:cNvSpPr txBox="1"/>
           <p:nvPr/>
         </p:nvSpPr>
@@ -5130,7 +5058,7 @@
             <a:pPr>
               <a:defRPr sz="1100" b="1">
                 <a:solidFill>
-                  <a:srgbClr val="4A90A4"/>
+                  <a:srgbClr val="276578"/>
                 </a:solidFill>
                 <a:latin typeface="Arial"/>
               </a:defRPr>
@@ -5143,7 +5071,7 @@
       </p:sp>
       <p:sp>
         <p:nvSpPr>
-          <p:cNvPr id="10" name="TextBox 9"/>
+          <p:cNvPr id="9" name="TextBox 8"/>
           <p:cNvSpPr txBox="1"/>
           <p:nvPr/>
         </p:nvSpPr>
@@ -5179,7 +5107,7 @@
       </p:sp>
       <p:sp>
         <p:nvSpPr>
-          <p:cNvPr id="11" name="TextBox 10"/>
+          <p:cNvPr id="10" name="TextBox 9"/>
           <p:cNvSpPr txBox="1"/>
           <p:nvPr/>
         </p:nvSpPr>
@@ -5202,7 +5130,7 @@
             <a:pPr>
               <a:defRPr sz="1100" b="1">
                 <a:solidFill>
-                  <a:srgbClr val="4A90A4"/>
+                  <a:srgbClr val="276578"/>
                 </a:solidFill>
                 <a:latin typeface="Arial"/>
               </a:defRPr>
@@ -5215,7 +5143,7 @@
       </p:sp>
       <p:sp>
         <p:nvSpPr>
-          <p:cNvPr id="12" name="TextBox 11"/>
+          <p:cNvPr id="11" name="TextBox 10"/>
           <p:cNvSpPr txBox="1"/>
           <p:nvPr/>
         </p:nvSpPr>
@@ -5251,7 +5179,7 @@
       </p:sp>
       <p:sp>
         <p:nvSpPr>
-          <p:cNvPr id="13" name="TextBox 12"/>
+          <p:cNvPr id="12" name="TextBox 11"/>
           <p:cNvSpPr txBox="1"/>
           <p:nvPr/>
         </p:nvSpPr>
@@ -5287,7 +5215,7 @@
       </p:sp>
       <p:sp>
         <p:nvSpPr>
-          <p:cNvPr id="14" name="TextBox 13"/>
+          <p:cNvPr id="13" name="TextBox 12"/>
           <p:cNvSpPr txBox="1"/>
           <p:nvPr/>
         </p:nvSpPr>
@@ -5362,7 +5290,7 @@
             <a:avLst/>
           </a:prstGeom>
           <a:solidFill>
-            <a:srgbClr val="4A90A4"/>
+            <a:srgbClr val="276578"/>
           </a:solidFill>
           <a:ln>
             <a:noFill/>
@@ -5422,42 +5350,6 @@
         </p:nvSpPr>
         <p:spPr>
           <a:xfrm>
-            <a:off x="822960" y="548640"/>
-            <a:ext cx="9144000" cy="320040"/>
-          </a:xfrm>
-          <a:prstGeom prst="rect">
-            <a:avLst/>
-          </a:prstGeom>
-          <a:noFill/>
-        </p:spPr>
-        <p:txBody>
-          <a:bodyPr wrap="square" tIns="0" bIns="0" lIns="0" rIns="0">
-            <a:spAutoFit/>
-          </a:bodyPr>
-          <a:lstStyle/>
-          <a:p>
-            <a:pPr>
-              <a:defRPr sz="1100" b="1">
-                <a:solidFill>
-                  <a:srgbClr val="4A90A4"/>
-                </a:solidFill>
-                <a:latin typeface="Arial"/>
-              </a:defRPr>
-            </a:pPr>
-            <a:r>
-              <a:t>11 / PILOT EVIDENCE</a:t>
-            </a:r>
-          </a:p>
-        </p:txBody>
-      </p:sp>
-      <p:sp>
-        <p:nvSpPr>
-          <p:cNvPr id="5" name="TextBox 4"/>
-          <p:cNvSpPr txBox="1"/>
-          <p:nvPr/>
-        </p:nvSpPr>
-        <p:spPr>
-          <a:xfrm>
             <a:off x="731520" y="1069848"/>
             <a:ext cx="10698480" cy="1554480"/>
           </a:xfrm>
@@ -5481,14 +5373,14 @@
               </a:defRPr>
             </a:pPr>
             <a:r>
-              <a:t>Measure homes and promises kept.</a:t>
-            </a:r>
-          </a:p>
-        </p:txBody>
-      </p:sp>
-      <p:sp>
-        <p:nvSpPr>
-          <p:cNvPr id="6" name="TextBox 5"/>
+              <a:t>Measure homes and promises kept</a:t>
+            </a:r>
+          </a:p>
+        </p:txBody>
+      </p:sp>
+      <p:sp>
+        <p:nvSpPr>
+          <p:cNvPr id="5" name="TextBox 4"/>
           <p:cNvSpPr txBox="1"/>
           <p:nvPr/>
         </p:nvSpPr>
@@ -5524,7 +5416,7 @@
       </p:sp>
       <p:sp>
         <p:nvSpPr>
-          <p:cNvPr id="7" name="TextBox 6"/>
+          <p:cNvPr id="6" name="TextBox 5"/>
           <p:cNvSpPr txBox="1"/>
           <p:nvPr/>
         </p:nvSpPr>
@@ -5547,7 +5439,7 @@
             <a:pPr>
               <a:defRPr sz="1100" b="1">
                 <a:solidFill>
-                  <a:srgbClr val="4A90A4"/>
+                  <a:srgbClr val="276578"/>
                 </a:solidFill>
                 <a:latin typeface="Arial"/>
               </a:defRPr>
@@ -5560,7 +5452,7 @@
       </p:sp>
       <p:sp>
         <p:nvSpPr>
-          <p:cNvPr id="8" name="TextBox 7"/>
+          <p:cNvPr id="7" name="TextBox 6"/>
           <p:cNvSpPr txBox="1"/>
           <p:nvPr/>
         </p:nvSpPr>
@@ -5596,7 +5488,7 @@
       </p:sp>
       <p:sp>
         <p:nvSpPr>
-          <p:cNvPr id="9" name="TextBox 8"/>
+          <p:cNvPr id="8" name="TextBox 7"/>
           <p:cNvSpPr txBox="1"/>
           <p:nvPr/>
         </p:nvSpPr>
@@ -5619,7 +5511,7 @@
             <a:pPr>
               <a:defRPr sz="1100" b="1">
                 <a:solidFill>
-                  <a:srgbClr val="4A90A4"/>
+                  <a:srgbClr val="276578"/>
                 </a:solidFill>
                 <a:latin typeface="Arial"/>
               </a:defRPr>
@@ -5632,7 +5524,7 @@
       </p:sp>
       <p:sp>
         <p:nvSpPr>
-          <p:cNvPr id="10" name="TextBox 9"/>
+          <p:cNvPr id="9" name="TextBox 8"/>
           <p:cNvSpPr txBox="1"/>
           <p:nvPr/>
         </p:nvSpPr>
@@ -5668,7 +5560,7 @@
       </p:sp>
       <p:sp>
         <p:nvSpPr>
-          <p:cNvPr id="11" name="TextBox 10"/>
+          <p:cNvPr id="10" name="TextBox 9"/>
           <p:cNvSpPr txBox="1"/>
           <p:nvPr/>
         </p:nvSpPr>
@@ -5691,7 +5583,7 @@
             <a:pPr>
               <a:defRPr sz="1100" b="1">
                 <a:solidFill>
-                  <a:srgbClr val="4A90A4"/>
+                  <a:srgbClr val="276578"/>
                 </a:solidFill>
                 <a:latin typeface="Arial"/>
               </a:defRPr>
@@ -5704,7 +5596,7 @@
       </p:sp>
       <p:sp>
         <p:nvSpPr>
-          <p:cNvPr id="12" name="TextBox 11"/>
+          <p:cNvPr id="11" name="TextBox 10"/>
           <p:cNvSpPr txBox="1"/>
           <p:nvPr/>
         </p:nvSpPr>
@@ -5740,7 +5632,7 @@
       </p:sp>
       <p:sp>
         <p:nvSpPr>
-          <p:cNvPr id="13" name="TextBox 12"/>
+          <p:cNvPr id="12" name="TextBox 11"/>
           <p:cNvSpPr txBox="1"/>
           <p:nvPr/>
         </p:nvSpPr>
@@ -5776,7 +5668,7 @@
       </p:sp>
       <p:sp>
         <p:nvSpPr>
-          <p:cNvPr id="14" name="TextBox 13"/>
+          <p:cNvPr id="13" name="TextBox 12"/>
           <p:cNvSpPr txBox="1"/>
           <p:nvPr/>
         </p:nvSpPr>
@@ -5851,7 +5743,7 @@
             <a:avLst/>
           </a:prstGeom>
           <a:solidFill>
-            <a:srgbClr val="4A90A4"/>
+            <a:srgbClr val="276578"/>
           </a:solidFill>
           <a:ln>
             <a:noFill/>
@@ -5911,42 +5803,6 @@
         </p:nvSpPr>
         <p:spPr>
           <a:xfrm>
-            <a:off x="822960" y="548640"/>
-            <a:ext cx="9144000" cy="320040"/>
-          </a:xfrm>
-          <a:prstGeom prst="rect">
-            <a:avLst/>
-          </a:prstGeom>
-          <a:noFill/>
-        </p:spPr>
-        <p:txBody>
-          <a:bodyPr wrap="square" tIns="0" bIns="0" lIns="0" rIns="0">
-            <a:spAutoFit/>
-          </a:bodyPr>
-          <a:lstStyle/>
-          <a:p>
-            <a:pPr>
-              <a:defRPr sz="1100" b="1">
-                <a:solidFill>
-                  <a:srgbClr val="4A90A4"/>
-                </a:solidFill>
-                <a:latin typeface="Arial"/>
-              </a:defRPr>
-            </a:pPr>
-            <a:r>
-              <a:t>12 / NEXT PARTNERS</a:t>
-            </a:r>
-          </a:p>
-        </p:txBody>
-      </p:sp>
-      <p:sp>
-        <p:nvSpPr>
-          <p:cNvPr id="5" name="TextBox 4"/>
-          <p:cNvSpPr txBox="1"/>
-          <p:nvPr/>
-        </p:nvSpPr>
-        <p:spPr>
-          <a:xfrm>
             <a:off x="731520" y="1069848"/>
             <a:ext cx="10698480" cy="1554480"/>
           </a:xfrm>
@@ -5970,14 +5826,14 @@
               </a:defRPr>
             </a:pPr>
             <a:r>
-              <a:t>One property can become a project to assess.</a:t>
-            </a:r>
-          </a:p>
-        </p:txBody>
-      </p:sp>
-      <p:sp>
-        <p:nvSpPr>
-          <p:cNvPr id="6" name="TextBox 5"/>
+              <a:t>One property can become a project to assess</a:t>
+            </a:r>
+          </a:p>
+        </p:txBody>
+      </p:sp>
+      <p:sp>
+        <p:nvSpPr>
+          <p:cNvPr id="5" name="TextBox 4"/>
           <p:cNvSpPr txBox="1"/>
           <p:nvPr/>
         </p:nvSpPr>
@@ -6013,7 +5869,7 @@
       </p:sp>
       <p:sp>
         <p:nvSpPr>
-          <p:cNvPr id="7" name="TextBox 6"/>
+          <p:cNvPr id="6" name="TextBox 5"/>
           <p:cNvSpPr txBox="1"/>
           <p:nvPr/>
         </p:nvSpPr>
@@ -6036,7 +5892,7 @@
             <a:pPr>
               <a:defRPr sz="1100" b="1">
                 <a:solidFill>
-                  <a:srgbClr val="4A90A4"/>
+                  <a:srgbClr val="276578"/>
                 </a:solidFill>
                 <a:latin typeface="Arial"/>
               </a:defRPr>
@@ -6049,7 +5905,7 @@
       </p:sp>
       <p:sp>
         <p:nvSpPr>
-          <p:cNvPr id="8" name="TextBox 7"/>
+          <p:cNvPr id="7" name="TextBox 6"/>
           <p:cNvSpPr txBox="1"/>
           <p:nvPr/>
         </p:nvSpPr>
@@ -6085,7 +5941,7 @@
       </p:sp>
       <p:sp>
         <p:nvSpPr>
-          <p:cNvPr id="9" name="TextBox 8"/>
+          <p:cNvPr id="8" name="TextBox 7"/>
           <p:cNvSpPr txBox="1"/>
           <p:nvPr/>
         </p:nvSpPr>
@@ -6108,7 +5964,7 @@
             <a:pPr>
               <a:defRPr sz="1100" b="1">
                 <a:solidFill>
-                  <a:srgbClr val="4A90A4"/>
+                  <a:srgbClr val="276578"/>
                 </a:solidFill>
                 <a:latin typeface="Arial"/>
               </a:defRPr>
@@ -6121,7 +5977,7 @@
       </p:sp>
       <p:sp>
         <p:nvSpPr>
-          <p:cNvPr id="10" name="TextBox 9"/>
+          <p:cNvPr id="9" name="TextBox 8"/>
           <p:cNvSpPr txBox="1"/>
           <p:nvPr/>
         </p:nvSpPr>
@@ -6157,7 +6013,7 @@
       </p:sp>
       <p:sp>
         <p:nvSpPr>
-          <p:cNvPr id="11" name="TextBox 10"/>
+          <p:cNvPr id="10" name="TextBox 9"/>
           <p:cNvSpPr txBox="1"/>
           <p:nvPr/>
         </p:nvSpPr>
@@ -6180,7 +6036,7 @@
             <a:pPr>
               <a:defRPr sz="1100" b="1">
                 <a:solidFill>
-                  <a:srgbClr val="4A90A4"/>
+                  <a:srgbClr val="276578"/>
                 </a:solidFill>
                 <a:latin typeface="Arial"/>
               </a:defRPr>
@@ -6193,7 +6049,7 @@
       </p:sp>
       <p:sp>
         <p:nvSpPr>
-          <p:cNvPr id="12" name="TextBox 11"/>
+          <p:cNvPr id="11" name="TextBox 10"/>
           <p:cNvSpPr txBox="1"/>
           <p:nvPr/>
         </p:nvSpPr>
@@ -6229,7 +6085,7 @@
       </p:sp>
       <p:sp>
         <p:nvSpPr>
-          <p:cNvPr id="13" name="TextBox 12"/>
+          <p:cNvPr id="12" name="TextBox 11"/>
           <p:cNvSpPr txBox="1"/>
           <p:nvPr/>
         </p:nvSpPr>
@@ -6265,7 +6121,7 @@
       </p:sp>
       <p:sp>
         <p:nvSpPr>
-          <p:cNvPr id="14" name="TextBox 13"/>
+          <p:cNvPr id="13" name="TextBox 12"/>
           <p:cNvSpPr txBox="1"/>
           <p:nvPr/>
         </p:nvSpPr>
@@ -6340,7 +6196,7 @@
             <a:avLst/>
           </a:prstGeom>
           <a:solidFill>
-            <a:srgbClr val="4A90A4"/>
+            <a:srgbClr val="276578"/>
           </a:solidFill>
           <a:ln>
             <a:noFill/>
@@ -6400,42 +6256,6 @@
         </p:nvSpPr>
         <p:spPr>
           <a:xfrm>
-            <a:off x="822960" y="548640"/>
-            <a:ext cx="9144000" cy="320040"/>
-          </a:xfrm>
-          <a:prstGeom prst="rect">
-            <a:avLst/>
-          </a:prstGeom>
-          <a:noFill/>
-        </p:spPr>
-        <p:txBody>
-          <a:bodyPr wrap="square" tIns="0" bIns="0" lIns="0" rIns="0">
-            <a:spAutoFit/>
-          </a:bodyPr>
-          <a:lstStyle/>
-          <a:p>
-            <a:pPr>
-              <a:defRPr sz="1100" b="1">
-                <a:solidFill>
-                  <a:srgbClr val="4A90A4"/>
-                </a:solidFill>
-                <a:latin typeface="Arial"/>
-              </a:defRPr>
-            </a:pPr>
-            <a:r>
-              <a:t>02 / THE PEOPLE</a:t>
-            </a:r>
-          </a:p>
-        </p:txBody>
-      </p:sp>
-      <p:sp>
-        <p:nvSpPr>
-          <p:cNvPr id="5" name="TextBox 4"/>
-          <p:cNvSpPr txBox="1"/>
-          <p:nvPr/>
-        </p:nvSpPr>
-        <p:spPr>
-          <a:xfrm>
             <a:off x="731520" y="1069848"/>
             <a:ext cx="10698480" cy="1554480"/>
           </a:xfrm>
@@ -6459,14 +6279,14 @@
               </a:defRPr>
             </a:pPr>
             <a:r>
-              <a:t>Start with what a family needs.</a:t>
-            </a:r>
-          </a:p>
-        </p:txBody>
-      </p:sp>
-      <p:sp>
-        <p:nvSpPr>
-          <p:cNvPr id="6" name="TextBox 5"/>
+              <a:t>Start with what a family needs</a:t>
+            </a:r>
+          </a:p>
+        </p:txBody>
+      </p:sp>
+      <p:sp>
+        <p:nvSpPr>
+          <p:cNvPr id="5" name="TextBox 4"/>
           <p:cNvSpPr txBox="1"/>
           <p:nvPr/>
         </p:nvSpPr>
@@ -6502,7 +6322,7 @@
       </p:sp>
       <p:sp>
         <p:nvSpPr>
-          <p:cNvPr id="7" name="TextBox 6"/>
+          <p:cNvPr id="6" name="TextBox 5"/>
           <p:cNvSpPr txBox="1"/>
           <p:nvPr/>
         </p:nvSpPr>
@@ -6525,7 +6345,7 @@
             <a:pPr>
               <a:defRPr sz="1100" b="1">
                 <a:solidFill>
-                  <a:srgbClr val="4A90A4"/>
+                  <a:srgbClr val="276578"/>
                 </a:solidFill>
                 <a:latin typeface="Arial"/>
               </a:defRPr>
@@ -6538,7 +6358,7 @@
       </p:sp>
       <p:sp>
         <p:nvSpPr>
-          <p:cNvPr id="8" name="TextBox 7"/>
+          <p:cNvPr id="7" name="TextBox 6"/>
           <p:cNvSpPr txBox="1"/>
           <p:nvPr/>
         </p:nvSpPr>
@@ -6574,7 +6394,7 @@
       </p:sp>
       <p:sp>
         <p:nvSpPr>
-          <p:cNvPr id="9" name="TextBox 8"/>
+          <p:cNvPr id="8" name="TextBox 7"/>
           <p:cNvSpPr txBox="1"/>
           <p:nvPr/>
         </p:nvSpPr>
@@ -6597,7 +6417,7 @@
             <a:pPr>
               <a:defRPr sz="1100" b="1">
                 <a:solidFill>
-                  <a:srgbClr val="4A90A4"/>
+                  <a:srgbClr val="276578"/>
                 </a:solidFill>
                 <a:latin typeface="Arial"/>
               </a:defRPr>
@@ -6610,7 +6430,7 @@
       </p:sp>
       <p:sp>
         <p:nvSpPr>
-          <p:cNvPr id="10" name="TextBox 9"/>
+          <p:cNvPr id="9" name="TextBox 8"/>
           <p:cNvSpPr txBox="1"/>
           <p:nvPr/>
         </p:nvSpPr>
@@ -6646,7 +6466,7 @@
       </p:sp>
       <p:sp>
         <p:nvSpPr>
-          <p:cNvPr id="11" name="TextBox 10"/>
+          <p:cNvPr id="10" name="TextBox 9"/>
           <p:cNvSpPr txBox="1"/>
           <p:nvPr/>
         </p:nvSpPr>
@@ -6669,7 +6489,7 @@
             <a:pPr>
               <a:defRPr sz="1100" b="1">
                 <a:solidFill>
-                  <a:srgbClr val="4A90A4"/>
+                  <a:srgbClr val="276578"/>
                 </a:solidFill>
                 <a:latin typeface="Arial"/>
               </a:defRPr>
@@ -6682,7 +6502,7 @@
       </p:sp>
       <p:sp>
         <p:nvSpPr>
-          <p:cNvPr id="12" name="TextBox 11"/>
+          <p:cNvPr id="11" name="TextBox 10"/>
           <p:cNvSpPr txBox="1"/>
           <p:nvPr/>
         </p:nvSpPr>
@@ -6718,7 +6538,7 @@
       </p:sp>
       <p:sp>
         <p:nvSpPr>
-          <p:cNvPr id="13" name="TextBox 12"/>
+          <p:cNvPr id="12" name="TextBox 11"/>
           <p:cNvSpPr txBox="1"/>
           <p:nvPr/>
         </p:nvSpPr>
@@ -6754,7 +6574,7 @@
       </p:sp>
       <p:sp>
         <p:nvSpPr>
-          <p:cNvPr id="14" name="TextBox 13"/>
+          <p:cNvPr id="13" name="TextBox 12"/>
           <p:cNvSpPr txBox="1"/>
           <p:nvPr/>
         </p:nvSpPr>
@@ -6829,7 +6649,7 @@
             <a:avLst/>
           </a:prstGeom>
           <a:solidFill>
-            <a:srgbClr val="4A90A4"/>
+            <a:srgbClr val="276578"/>
           </a:solidFill>
           <a:ln>
             <a:noFill/>
@@ -6889,42 +6709,6 @@
         </p:nvSpPr>
         <p:spPr>
           <a:xfrm>
-            <a:off x="822960" y="548640"/>
-            <a:ext cx="9144000" cy="320040"/>
-          </a:xfrm>
-          <a:prstGeom prst="rect">
-            <a:avLst/>
-          </a:prstGeom>
-          <a:noFill/>
-        </p:spPr>
-        <p:txBody>
-          <a:bodyPr wrap="square" tIns="0" bIns="0" lIns="0" rIns="0">
-            <a:spAutoFit/>
-          </a:bodyPr>
-          <a:lstStyle/>
-          <a:p>
-            <a:pPr>
-              <a:defRPr sz="1100" b="1">
-                <a:solidFill>
-                  <a:srgbClr val="4A90A4"/>
-                </a:solidFill>
-                <a:latin typeface="Arial"/>
-              </a:defRPr>
-            </a:pPr>
-            <a:r>
-              <a:t>03 / DELIVERY KNOWLEDGE</a:t>
-            </a:r>
-          </a:p>
-        </p:txBody>
-      </p:sp>
-      <p:sp>
-        <p:nvSpPr>
-          <p:cNvPr id="5" name="TextBox 4"/>
-          <p:cNvSpPr txBox="1"/>
-          <p:nvPr/>
-        </p:nvSpPr>
-        <p:spPr>
-          <a:xfrm>
             <a:off x="731520" y="1069848"/>
             <a:ext cx="10698480" cy="1554480"/>
           </a:xfrm>
@@ -6948,14 +6732,14 @@
               </a:defRPr>
             </a:pPr>
             <a:r>
-              <a:t>Rafael has supplied a building budget.</a:t>
-            </a:r>
-          </a:p>
-        </p:txBody>
-      </p:sp>
-      <p:sp>
-        <p:nvSpPr>
-          <p:cNvPr id="6" name="TextBox 5"/>
+              <a:t>Rafael has supplied a building budget</a:t>
+            </a:r>
+          </a:p>
+        </p:txBody>
+      </p:sp>
+      <p:sp>
+        <p:nvSpPr>
+          <p:cNvPr id="5" name="TextBox 4"/>
           <p:cNvSpPr txBox="1"/>
           <p:nvPr/>
         </p:nvSpPr>
@@ -6991,7 +6775,7 @@
       </p:sp>
       <p:sp>
         <p:nvSpPr>
-          <p:cNvPr id="7" name="TextBox 6"/>
+          <p:cNvPr id="6" name="TextBox 5"/>
           <p:cNvSpPr txBox="1"/>
           <p:nvPr/>
         </p:nvSpPr>
@@ -7014,7 +6798,7 @@
             <a:pPr>
               <a:defRPr sz="1100" b="1">
                 <a:solidFill>
-                  <a:srgbClr val="4A90A4"/>
+                  <a:srgbClr val="276578"/>
                 </a:solidFill>
                 <a:latin typeface="Arial"/>
               </a:defRPr>
@@ -7027,7 +6811,7 @@
       </p:sp>
       <p:sp>
         <p:nvSpPr>
-          <p:cNvPr id="8" name="TextBox 7"/>
+          <p:cNvPr id="7" name="TextBox 6"/>
           <p:cNvSpPr txBox="1"/>
           <p:nvPr/>
         </p:nvSpPr>
@@ -7063,7 +6847,7 @@
       </p:sp>
       <p:sp>
         <p:nvSpPr>
-          <p:cNvPr id="9" name="TextBox 8"/>
+          <p:cNvPr id="8" name="TextBox 7"/>
           <p:cNvSpPr txBox="1"/>
           <p:nvPr/>
         </p:nvSpPr>
@@ -7086,7 +6870,7 @@
             <a:pPr>
               <a:defRPr sz="1100" b="1">
                 <a:solidFill>
-                  <a:srgbClr val="4A90A4"/>
+                  <a:srgbClr val="276578"/>
                 </a:solidFill>
                 <a:latin typeface="Arial"/>
               </a:defRPr>
@@ -7099,7 +6883,7 @@
       </p:sp>
       <p:sp>
         <p:nvSpPr>
-          <p:cNvPr id="10" name="TextBox 9"/>
+          <p:cNvPr id="9" name="TextBox 8"/>
           <p:cNvSpPr txBox="1"/>
           <p:nvPr/>
         </p:nvSpPr>
@@ -7135,7 +6919,7 @@
       </p:sp>
       <p:sp>
         <p:nvSpPr>
-          <p:cNvPr id="11" name="TextBox 10"/>
+          <p:cNvPr id="10" name="TextBox 9"/>
           <p:cNvSpPr txBox="1"/>
           <p:nvPr/>
         </p:nvSpPr>
@@ -7158,7 +6942,7 @@
             <a:pPr>
               <a:defRPr sz="1100" b="1">
                 <a:solidFill>
-                  <a:srgbClr val="4A90A4"/>
+                  <a:srgbClr val="276578"/>
                 </a:solidFill>
                 <a:latin typeface="Arial"/>
               </a:defRPr>
@@ -7171,7 +6955,7 @@
       </p:sp>
       <p:sp>
         <p:nvSpPr>
-          <p:cNvPr id="12" name="TextBox 11"/>
+          <p:cNvPr id="11" name="TextBox 10"/>
           <p:cNvSpPr txBox="1"/>
           <p:nvPr/>
         </p:nvSpPr>
@@ -7207,7 +6991,7 @@
       </p:sp>
       <p:sp>
         <p:nvSpPr>
-          <p:cNvPr id="13" name="TextBox 12"/>
+          <p:cNvPr id="12" name="TextBox 11"/>
           <p:cNvSpPr txBox="1"/>
           <p:nvPr/>
         </p:nvSpPr>
@@ -7243,7 +7027,7 @@
       </p:sp>
       <p:sp>
         <p:nvSpPr>
-          <p:cNvPr id="14" name="TextBox 13"/>
+          <p:cNvPr id="13" name="TextBox 12"/>
           <p:cNvSpPr txBox="1"/>
           <p:nvPr/>
         </p:nvSpPr>
@@ -7318,7 +7102,7 @@
             <a:avLst/>
           </a:prstGeom>
           <a:solidFill>
-            <a:srgbClr val="4A90A4"/>
+            <a:srgbClr val="276578"/>
           </a:solidFill>
           <a:ln>
             <a:noFill/>
@@ -7378,42 +7162,6 @@
         </p:nvSpPr>
         <p:spPr>
           <a:xfrm>
-            <a:off x="822960" y="548640"/>
-            <a:ext cx="9144000" cy="320040"/>
-          </a:xfrm>
-          <a:prstGeom prst="rect">
-            <a:avLst/>
-          </a:prstGeom>
-          <a:noFill/>
-        </p:spPr>
-        <p:txBody>
-          <a:bodyPr wrap="square" tIns="0" bIns="0" lIns="0" rIns="0">
-            <a:spAutoFit/>
-          </a:bodyPr>
-          <a:lstStyle/>
-          <a:p>
-            <a:pPr>
-              <a:defRPr sz="1100" b="1">
-                <a:solidFill>
-                  <a:srgbClr val="4A90A4"/>
-                </a:solidFill>
-                <a:latin typeface="Arial"/>
-              </a:defRPr>
-            </a:pPr>
-            <a:r>
-              <a:t>04 / THE OPERATING MODEL</a:t>
-            </a:r>
-          </a:p>
-        </p:txBody>
-      </p:sp>
-      <p:sp>
-        <p:nvSpPr>
-          <p:cNvPr id="5" name="TextBox 4"/>
-          <p:cNvSpPr txBox="1"/>
-          <p:nvPr/>
-        </p:nvSpPr>
-        <p:spPr>
-          <a:xfrm>
             <a:off x="731520" y="1069848"/>
             <a:ext cx="10698480" cy="1554480"/>
           </a:xfrm>
@@ -7437,14 +7185,14 @@
               </a:defRPr>
             </a:pPr>
             <a:r>
-              <a:t>Part of each payment would go towards buying the home.</a:t>
-            </a:r>
-          </a:p>
-        </p:txBody>
-      </p:sp>
-      <p:sp>
-        <p:nvSpPr>
-          <p:cNvPr id="6" name="TextBox 5"/>
+              <a:t>Part of each payment would go towards buying the home</a:t>
+            </a:r>
+          </a:p>
+        </p:txBody>
+      </p:sp>
+      <p:sp>
+        <p:nvSpPr>
+          <p:cNvPr id="5" name="TextBox 4"/>
           <p:cNvSpPr txBox="1"/>
           <p:nvPr/>
         </p:nvSpPr>
@@ -7480,7 +7228,7 @@
       </p:sp>
       <p:sp>
         <p:nvSpPr>
-          <p:cNvPr id="7" name="TextBox 6"/>
+          <p:cNvPr id="6" name="TextBox 5"/>
           <p:cNvSpPr txBox="1"/>
           <p:nvPr/>
         </p:nvSpPr>
@@ -7503,7 +7251,7 @@
             <a:pPr>
               <a:defRPr sz="1100" b="1">
                 <a:solidFill>
-                  <a:srgbClr val="4A90A4"/>
+                  <a:srgbClr val="276578"/>
                 </a:solidFill>
                 <a:latin typeface="Arial"/>
               </a:defRPr>
@@ -7516,7 +7264,7 @@
       </p:sp>
       <p:sp>
         <p:nvSpPr>
-          <p:cNvPr id="8" name="TextBox 7"/>
+          <p:cNvPr id="7" name="TextBox 6"/>
           <p:cNvSpPr txBox="1"/>
           <p:nvPr/>
         </p:nvSpPr>
@@ -7552,7 +7300,7 @@
       </p:sp>
       <p:sp>
         <p:nvSpPr>
-          <p:cNvPr id="9" name="TextBox 8"/>
+          <p:cNvPr id="8" name="TextBox 7"/>
           <p:cNvSpPr txBox="1"/>
           <p:nvPr/>
         </p:nvSpPr>
@@ -7575,7 +7323,7 @@
             <a:pPr>
               <a:defRPr sz="1100" b="1">
                 <a:solidFill>
-                  <a:srgbClr val="4A90A4"/>
+                  <a:srgbClr val="276578"/>
                 </a:solidFill>
                 <a:latin typeface="Arial"/>
               </a:defRPr>
@@ -7588,7 +7336,7 @@
       </p:sp>
       <p:sp>
         <p:nvSpPr>
-          <p:cNvPr id="10" name="TextBox 9"/>
+          <p:cNvPr id="9" name="TextBox 8"/>
           <p:cNvSpPr txBox="1"/>
           <p:nvPr/>
         </p:nvSpPr>
@@ -7624,7 +7372,7 @@
       </p:sp>
       <p:sp>
         <p:nvSpPr>
-          <p:cNvPr id="11" name="TextBox 10"/>
+          <p:cNvPr id="10" name="TextBox 9"/>
           <p:cNvSpPr txBox="1"/>
           <p:nvPr/>
         </p:nvSpPr>
@@ -7647,7 +7395,7 @@
             <a:pPr>
               <a:defRPr sz="1100" b="1">
                 <a:solidFill>
-                  <a:srgbClr val="4A90A4"/>
+                  <a:srgbClr val="276578"/>
                 </a:solidFill>
                 <a:latin typeface="Arial"/>
               </a:defRPr>
@@ -7660,7 +7408,7 @@
       </p:sp>
       <p:sp>
         <p:nvSpPr>
-          <p:cNvPr id="12" name="TextBox 11"/>
+          <p:cNvPr id="11" name="TextBox 10"/>
           <p:cNvSpPr txBox="1"/>
           <p:nvPr/>
         </p:nvSpPr>
@@ -7696,7 +7444,7 @@
       </p:sp>
       <p:sp>
         <p:nvSpPr>
-          <p:cNvPr id="13" name="TextBox 12"/>
+          <p:cNvPr id="12" name="TextBox 11"/>
           <p:cNvSpPr txBox="1"/>
           <p:nvPr/>
         </p:nvSpPr>
@@ -7732,7 +7480,7 @@
       </p:sp>
       <p:sp>
         <p:nvSpPr>
-          <p:cNvPr id="14" name="TextBox 13"/>
+          <p:cNvPr id="13" name="TextBox 12"/>
           <p:cNvSpPr txBox="1"/>
           <p:nvPr/>
         </p:nvSpPr>
@@ -7807,7 +7555,7 @@
             <a:avLst/>
           </a:prstGeom>
           <a:solidFill>
-            <a:srgbClr val="4A90A4"/>
+            <a:srgbClr val="276578"/>
           </a:solidFill>
           <a:ln>
             <a:noFill/>
@@ -7867,42 +7615,6 @@
         </p:nvSpPr>
         <p:spPr>
           <a:xfrm>
-            <a:off x="822960" y="548640"/>
-            <a:ext cx="9144000" cy="320040"/>
-          </a:xfrm>
-          <a:prstGeom prst="rect">
-            <a:avLst/>
-          </a:prstGeom>
-          <a:noFill/>
-        </p:spPr>
-        <p:txBody>
-          <a:bodyPr wrap="square" tIns="0" bIns="0" lIns="0" rIns="0">
-            <a:spAutoFit/>
-          </a:bodyPr>
-          <a:lstStyle/>
-          <a:p>
-            <a:pPr>
-              <a:defRPr sz="1100" b="1">
-                <a:solidFill>
-                  <a:srgbClr val="4A90A4"/>
-                </a:solidFill>
-                <a:latin typeface="Arial"/>
-              </a:defRPr>
-            </a:pPr>
-            <a:r>
-              <a:t>05 / MONEY</a:t>
-            </a:r>
-          </a:p>
-        </p:txBody>
-      </p:sp>
-      <p:sp>
-        <p:nvSpPr>
-          <p:cNvPr id="5" name="TextBox 4"/>
-          <p:cNvSpPr txBox="1"/>
-          <p:nvPr/>
-        </p:nvSpPr>
-        <p:spPr>
-          <a:xfrm>
             <a:off x="731520" y="1069848"/>
             <a:ext cx="10698480" cy="1554480"/>
           </a:xfrm>
@@ -7926,14 +7638,14 @@
               </a:defRPr>
             </a:pPr>
             <a:r>
-              <a:t>Show where each payment goes.</a:t>
-            </a:r>
-          </a:p>
-        </p:txBody>
-      </p:sp>
-      <p:sp>
-        <p:nvSpPr>
-          <p:cNvPr id="6" name="TextBox 5"/>
+              <a:t>Show where each payment goes</a:t>
+            </a:r>
+          </a:p>
+        </p:txBody>
+      </p:sp>
+      <p:sp>
+        <p:nvSpPr>
+          <p:cNvPr id="5" name="TextBox 4"/>
           <p:cNvSpPr txBox="1"/>
           <p:nvPr/>
         </p:nvSpPr>
@@ -7969,7 +7681,7 @@
       </p:sp>
       <p:sp>
         <p:nvSpPr>
-          <p:cNvPr id="7" name="TextBox 6"/>
+          <p:cNvPr id="6" name="TextBox 5"/>
           <p:cNvSpPr txBox="1"/>
           <p:nvPr/>
         </p:nvSpPr>
@@ -7992,7 +7704,7 @@
             <a:pPr>
               <a:defRPr sz="1100" b="1">
                 <a:solidFill>
-                  <a:srgbClr val="4A90A4"/>
+                  <a:srgbClr val="276578"/>
                 </a:solidFill>
                 <a:latin typeface="Arial"/>
               </a:defRPr>
@@ -8005,7 +7717,7 @@
       </p:sp>
       <p:sp>
         <p:nvSpPr>
-          <p:cNvPr id="8" name="TextBox 7"/>
+          <p:cNvPr id="7" name="TextBox 6"/>
           <p:cNvSpPr txBox="1"/>
           <p:nvPr/>
         </p:nvSpPr>
@@ -8041,7 +7753,7 @@
       </p:sp>
       <p:sp>
         <p:nvSpPr>
-          <p:cNvPr id="9" name="TextBox 8"/>
+          <p:cNvPr id="8" name="TextBox 7"/>
           <p:cNvSpPr txBox="1"/>
           <p:nvPr/>
         </p:nvSpPr>
@@ -8064,7 +7776,7 @@
             <a:pPr>
               <a:defRPr sz="1100" b="1">
                 <a:solidFill>
-                  <a:srgbClr val="4A90A4"/>
+                  <a:srgbClr val="276578"/>
                 </a:solidFill>
                 <a:latin typeface="Arial"/>
               </a:defRPr>
@@ -8077,7 +7789,7 @@
       </p:sp>
       <p:sp>
         <p:nvSpPr>
-          <p:cNvPr id="10" name="TextBox 9"/>
+          <p:cNvPr id="9" name="TextBox 8"/>
           <p:cNvSpPr txBox="1"/>
           <p:nvPr/>
         </p:nvSpPr>
@@ -8113,7 +7825,7 @@
       </p:sp>
       <p:sp>
         <p:nvSpPr>
-          <p:cNvPr id="11" name="TextBox 10"/>
+          <p:cNvPr id="10" name="TextBox 9"/>
           <p:cNvSpPr txBox="1"/>
           <p:nvPr/>
         </p:nvSpPr>
@@ -8136,7 +7848,7 @@
             <a:pPr>
               <a:defRPr sz="1100" b="1">
                 <a:solidFill>
-                  <a:srgbClr val="4A90A4"/>
+                  <a:srgbClr val="276578"/>
                 </a:solidFill>
                 <a:latin typeface="Arial"/>
               </a:defRPr>
@@ -8149,7 +7861,7 @@
       </p:sp>
       <p:sp>
         <p:nvSpPr>
-          <p:cNvPr id="12" name="TextBox 11"/>
+          <p:cNvPr id="11" name="TextBox 10"/>
           <p:cNvSpPr txBox="1"/>
           <p:nvPr/>
         </p:nvSpPr>
@@ -8185,7 +7897,7 @@
       </p:sp>
       <p:sp>
         <p:nvSpPr>
-          <p:cNvPr id="13" name="TextBox 12"/>
+          <p:cNvPr id="12" name="TextBox 11"/>
           <p:cNvSpPr txBox="1"/>
           <p:nvPr/>
         </p:nvSpPr>
@@ -8221,7 +7933,7 @@
       </p:sp>
       <p:sp>
         <p:nvSpPr>
-          <p:cNvPr id="14" name="TextBox 13"/>
+          <p:cNvPr id="13" name="TextBox 12"/>
           <p:cNvSpPr txBox="1"/>
           <p:nvPr/>
         </p:nvSpPr>
@@ -8296,7 +8008,7 @@
             <a:avLst/>
           </a:prstGeom>
           <a:solidFill>
-            <a:srgbClr val="4A90A4"/>
+            <a:srgbClr val="276578"/>
           </a:solidFill>
           <a:ln>
             <a:noFill/>
@@ -8356,42 +8068,6 @@
         </p:nvSpPr>
         <p:spPr>
           <a:xfrm>
-            <a:off x="822960" y="548640"/>
-            <a:ext cx="9144000" cy="320040"/>
-          </a:xfrm>
-          <a:prstGeom prst="rect">
-            <a:avLst/>
-          </a:prstGeom>
-          <a:noFill/>
-        </p:spPr>
-        <p:txBody>
-          <a:bodyPr wrap="square" tIns="0" bIns="0" lIns="0" rIns="0">
-            <a:spAutoFit/>
-          </a:bodyPr>
-          <a:lstStyle/>
-          <a:p>
-            <a:pPr>
-              <a:defRPr sz="1100" b="1">
-                <a:solidFill>
-                  <a:srgbClr val="4A90A4"/>
-                </a:solidFill>
-                <a:latin typeface="Arial"/>
-              </a:defRPr>
-            </a:pPr>
-            <a:r>
-              <a:t>06 / CONTINUITY</a:t>
-            </a:r>
-          </a:p>
-        </p:txBody>
-      </p:sp>
-      <p:sp>
-        <p:nvSpPr>
-          <p:cNvPr id="5" name="TextBox 4"/>
-          <p:cNvSpPr txBox="1"/>
-          <p:nvPr/>
-        </p:nvSpPr>
-        <p:spPr>
-          <a:xfrm>
             <a:off x="731520" y="1069848"/>
             <a:ext cx="10698480" cy="1554480"/>
           </a:xfrm>
@@ -8415,14 +8091,14 @@
               </a:defRPr>
             </a:pPr>
             <a:r>
-              <a:t>Pay today’s bills. Plan the next homes.</a:t>
-            </a:r>
-          </a:p>
-        </p:txBody>
-      </p:sp>
-      <p:sp>
-        <p:nvSpPr>
-          <p:cNvPr id="6" name="TextBox 5"/>
+              <a:t>Pay today’s bills and plan the next homes</a:t>
+            </a:r>
+          </a:p>
+        </p:txBody>
+      </p:sp>
+      <p:sp>
+        <p:nvSpPr>
+          <p:cNvPr id="5" name="TextBox 4"/>
           <p:cNvSpPr txBox="1"/>
           <p:nvPr/>
         </p:nvSpPr>
@@ -8458,7 +8134,7 @@
       </p:sp>
       <p:sp>
         <p:nvSpPr>
-          <p:cNvPr id="7" name="TextBox 6"/>
+          <p:cNvPr id="6" name="TextBox 5"/>
           <p:cNvSpPr txBox="1"/>
           <p:nvPr/>
         </p:nvSpPr>
@@ -8481,7 +8157,7 @@
             <a:pPr>
               <a:defRPr sz="1100" b="1">
                 <a:solidFill>
-                  <a:srgbClr val="4A90A4"/>
+                  <a:srgbClr val="276578"/>
                 </a:solidFill>
                 <a:latin typeface="Arial"/>
               </a:defRPr>
@@ -8494,7 +8170,7 @@
       </p:sp>
       <p:sp>
         <p:nvSpPr>
-          <p:cNvPr id="8" name="TextBox 7"/>
+          <p:cNvPr id="7" name="TextBox 6"/>
           <p:cNvSpPr txBox="1"/>
           <p:nvPr/>
         </p:nvSpPr>
@@ -8530,7 +8206,7 @@
       </p:sp>
       <p:sp>
         <p:nvSpPr>
-          <p:cNvPr id="9" name="TextBox 8"/>
+          <p:cNvPr id="8" name="TextBox 7"/>
           <p:cNvSpPr txBox="1"/>
           <p:nvPr/>
         </p:nvSpPr>
@@ -8553,7 +8229,7 @@
             <a:pPr>
               <a:defRPr sz="1100" b="1">
                 <a:solidFill>
-                  <a:srgbClr val="4A90A4"/>
+                  <a:srgbClr val="276578"/>
                 </a:solidFill>
                 <a:latin typeface="Arial"/>
               </a:defRPr>
@@ -8566,7 +8242,7 @@
       </p:sp>
       <p:sp>
         <p:nvSpPr>
-          <p:cNvPr id="10" name="TextBox 9"/>
+          <p:cNvPr id="9" name="TextBox 8"/>
           <p:cNvSpPr txBox="1"/>
           <p:nvPr/>
         </p:nvSpPr>
@@ -8602,7 +8278,7 @@
       </p:sp>
       <p:sp>
         <p:nvSpPr>
-          <p:cNvPr id="11" name="TextBox 10"/>
+          <p:cNvPr id="10" name="TextBox 9"/>
           <p:cNvSpPr txBox="1"/>
           <p:nvPr/>
         </p:nvSpPr>
@@ -8625,7 +8301,7 @@
             <a:pPr>
               <a:defRPr sz="1100" b="1">
                 <a:solidFill>
-                  <a:srgbClr val="4A90A4"/>
+                  <a:srgbClr val="276578"/>
                 </a:solidFill>
                 <a:latin typeface="Arial"/>
               </a:defRPr>
@@ -8638,7 +8314,7 @@
       </p:sp>
       <p:sp>
         <p:nvSpPr>
-          <p:cNvPr id="12" name="TextBox 11"/>
+          <p:cNvPr id="11" name="TextBox 10"/>
           <p:cNvSpPr txBox="1"/>
           <p:nvPr/>
         </p:nvSpPr>
@@ -8674,7 +8350,7 @@
       </p:sp>
       <p:sp>
         <p:nvSpPr>
-          <p:cNvPr id="13" name="TextBox 12"/>
+          <p:cNvPr id="12" name="TextBox 11"/>
           <p:cNvSpPr txBox="1"/>
           <p:nvPr/>
         </p:nvSpPr>
@@ -8710,7 +8386,7 @@
       </p:sp>
       <p:sp>
         <p:nvSpPr>
-          <p:cNvPr id="14" name="TextBox 13"/>
+          <p:cNvPr id="13" name="TextBox 12"/>
           <p:cNvSpPr txBox="1"/>
           <p:nvPr/>
         </p:nvSpPr>
@@ -8785,7 +8461,7 @@
             <a:avLst/>
           </a:prstGeom>
           <a:solidFill>
-            <a:srgbClr val="4A90A4"/>
+            <a:srgbClr val="276578"/>
           </a:solidFill>
           <a:ln>
             <a:noFill/>
@@ -8845,42 +8521,6 @@
         </p:nvSpPr>
         <p:spPr>
           <a:xfrm>
-            <a:off x="822960" y="548640"/>
-            <a:ext cx="9144000" cy="320040"/>
-          </a:xfrm>
-          <a:prstGeom prst="rect">
-            <a:avLst/>
-          </a:prstGeom>
-          <a:noFill/>
-        </p:spPr>
-        <p:txBody>
-          <a:bodyPr wrap="square" tIns="0" bIns="0" lIns="0" rIns="0">
-            <a:spAutoFit/>
-          </a:bodyPr>
-          <a:lstStyle/>
-          <a:p>
-            <a:pPr>
-              <a:defRPr sz="1100" b="1">
-                <a:solidFill>
-                  <a:srgbClr val="4A90A4"/>
-                </a:solidFill>
-                <a:latin typeface="Arial"/>
-              </a:defRPr>
-            </a:pPr>
-            <a:r>
-              <a:t>07 / RESIDENT VOICE</a:t>
-            </a:r>
-          </a:p>
-        </p:txBody>
-      </p:sp>
-      <p:sp>
-        <p:nvSpPr>
-          <p:cNvPr id="5" name="TextBox 4"/>
-          <p:cNvSpPr txBox="1"/>
-          <p:nvPr/>
-        </p:nvSpPr>
-        <p:spPr>
-          <a:xfrm>
             <a:off x="731520" y="1069848"/>
             <a:ext cx="10698480" cy="1554480"/>
           </a:xfrm>
@@ -8904,14 +8544,14 @@
               </a:defRPr>
             </a:pPr>
             <a:r>
-              <a:t>Residents would decide how shared spaces are used.</a:t>
-            </a:r>
-          </a:p>
-        </p:txBody>
-      </p:sp>
-      <p:sp>
-        <p:nvSpPr>
-          <p:cNvPr id="6" name="TextBox 5"/>
+              <a:t>Residents would decide how shared spaces are used</a:t>
+            </a:r>
+          </a:p>
+        </p:txBody>
+      </p:sp>
+      <p:sp>
+        <p:nvSpPr>
+          <p:cNvPr id="5" name="TextBox 4"/>
           <p:cNvSpPr txBox="1"/>
           <p:nvPr/>
         </p:nvSpPr>
@@ -8947,7 +8587,7 @@
       </p:sp>
       <p:sp>
         <p:nvSpPr>
-          <p:cNvPr id="7" name="TextBox 6"/>
+          <p:cNvPr id="6" name="TextBox 5"/>
           <p:cNvSpPr txBox="1"/>
           <p:nvPr/>
         </p:nvSpPr>
@@ -8970,7 +8610,7 @@
             <a:pPr>
               <a:defRPr sz="1100" b="1">
                 <a:solidFill>
-                  <a:srgbClr val="4A90A4"/>
+                  <a:srgbClr val="276578"/>
                 </a:solidFill>
                 <a:latin typeface="Arial"/>
               </a:defRPr>
@@ -8983,7 +8623,7 @@
       </p:sp>
       <p:sp>
         <p:nvSpPr>
-          <p:cNvPr id="8" name="TextBox 7"/>
+          <p:cNvPr id="7" name="TextBox 6"/>
           <p:cNvSpPr txBox="1"/>
           <p:nvPr/>
         </p:nvSpPr>
@@ -9019,7 +8659,7 @@
       </p:sp>
       <p:sp>
         <p:nvSpPr>
-          <p:cNvPr id="9" name="TextBox 8"/>
+          <p:cNvPr id="8" name="TextBox 7"/>
           <p:cNvSpPr txBox="1"/>
           <p:nvPr/>
         </p:nvSpPr>
@@ -9042,7 +8682,7 @@
             <a:pPr>
               <a:defRPr sz="1100" b="1">
                 <a:solidFill>
-                  <a:srgbClr val="4A90A4"/>
+                  <a:srgbClr val="276578"/>
                 </a:solidFill>
                 <a:latin typeface="Arial"/>
               </a:defRPr>
@@ -9055,7 +8695,7 @@
       </p:sp>
       <p:sp>
         <p:nvSpPr>
-          <p:cNvPr id="10" name="TextBox 9"/>
+          <p:cNvPr id="9" name="TextBox 8"/>
           <p:cNvSpPr txBox="1"/>
           <p:nvPr/>
         </p:nvSpPr>
@@ -9091,7 +8731,7 @@
       </p:sp>
       <p:sp>
         <p:nvSpPr>
-          <p:cNvPr id="11" name="TextBox 10"/>
+          <p:cNvPr id="10" name="TextBox 9"/>
           <p:cNvSpPr txBox="1"/>
           <p:nvPr/>
         </p:nvSpPr>
@@ -9114,7 +8754,7 @@
             <a:pPr>
               <a:defRPr sz="1100" b="1">
                 <a:solidFill>
-                  <a:srgbClr val="4A90A4"/>
+                  <a:srgbClr val="276578"/>
                 </a:solidFill>
                 <a:latin typeface="Arial"/>
               </a:defRPr>
@@ -9127,7 +8767,7 @@
       </p:sp>
       <p:sp>
         <p:nvSpPr>
-          <p:cNvPr id="12" name="TextBox 11"/>
+          <p:cNvPr id="11" name="TextBox 10"/>
           <p:cNvSpPr txBox="1"/>
           <p:nvPr/>
         </p:nvSpPr>
@@ -9163,7 +8803,7 @@
       </p:sp>
       <p:sp>
         <p:nvSpPr>
-          <p:cNvPr id="13" name="TextBox 12"/>
+          <p:cNvPr id="12" name="TextBox 11"/>
           <p:cNvSpPr txBox="1"/>
           <p:nvPr/>
         </p:nvSpPr>
@@ -9199,7 +8839,7 @@
       </p:sp>
       <p:sp>
         <p:nvSpPr>
-          <p:cNvPr id="14" name="TextBox 13"/>
+          <p:cNvPr id="13" name="TextBox 12"/>
           <p:cNvSpPr txBox="1"/>
           <p:nvPr/>
         </p:nvSpPr>
@@ -9274,7 +8914,7 @@
             <a:avLst/>
           </a:prstGeom>
           <a:solidFill>
-            <a:srgbClr val="4A90A4"/>
+            <a:srgbClr val="276578"/>
           </a:solidFill>
           <a:ln>
             <a:noFill/>
@@ -9334,42 +8974,6 @@
         </p:nvSpPr>
         <p:spPr>
           <a:xfrm>
-            <a:off x="822960" y="548640"/>
-            <a:ext cx="9144000" cy="320040"/>
-          </a:xfrm>
-          <a:prstGeom prst="rect">
-            <a:avLst/>
-          </a:prstGeom>
-          <a:noFill/>
-        </p:spPr>
-        <p:txBody>
-          <a:bodyPr wrap="square" tIns="0" bIns="0" lIns="0" rIns="0">
-            <a:spAutoFit/>
-          </a:bodyPr>
-          <a:lstStyle/>
-          <a:p>
-            <a:pPr>
-              <a:defRPr sz="1100" b="1">
-                <a:solidFill>
-                  <a:srgbClr val="4A90A4"/>
-                </a:solidFill>
-                <a:latin typeface="Arial"/>
-              </a:defRPr>
-            </a:pPr>
-            <a:r>
-              <a:t>08 / DIGITAL TOOLS</a:t>
-            </a:r>
-          </a:p>
-        </p:txBody>
-      </p:sp>
-      <p:sp>
-        <p:nvSpPr>
-          <p:cNvPr id="5" name="TextBox 4"/>
-          <p:cNvSpPr txBox="1"/>
-          <p:nvPr/>
-        </p:nvSpPr>
-        <p:spPr>
-          <a:xfrm>
             <a:off x="731520" y="1069848"/>
             <a:ext cx="10698480" cy="1554480"/>
           </a:xfrm>
@@ -9393,14 +8997,14 @@
               </a:defRPr>
             </a:pPr>
             <a:r>
-              <a:t>From a request to checked work.</a:t>
-            </a:r>
-          </a:p>
-        </p:txBody>
-      </p:sp>
-      <p:sp>
-        <p:nvSpPr>
-          <p:cNvPr id="6" name="TextBox 5"/>
+              <a:t>From a request to checked work</a:t>
+            </a:r>
+          </a:p>
+        </p:txBody>
+      </p:sp>
+      <p:sp>
+        <p:nvSpPr>
+          <p:cNvPr id="5" name="TextBox 4"/>
           <p:cNvSpPr txBox="1"/>
           <p:nvPr/>
         </p:nvSpPr>
@@ -9436,7 +9040,7 @@
       </p:sp>
       <p:sp>
         <p:nvSpPr>
-          <p:cNvPr id="7" name="TextBox 6"/>
+          <p:cNvPr id="6" name="TextBox 5"/>
           <p:cNvSpPr txBox="1"/>
           <p:nvPr/>
         </p:nvSpPr>
@@ -9459,7 +9063,7 @@
             <a:pPr>
               <a:defRPr sz="1100" b="1">
                 <a:solidFill>
-                  <a:srgbClr val="4A90A4"/>
+                  <a:srgbClr val="276578"/>
                 </a:solidFill>
                 <a:latin typeface="Arial"/>
               </a:defRPr>
@@ -9472,7 +9076,7 @@
       </p:sp>
       <p:sp>
         <p:nvSpPr>
-          <p:cNvPr id="8" name="TextBox 7"/>
+          <p:cNvPr id="7" name="TextBox 6"/>
           <p:cNvSpPr txBox="1"/>
           <p:nvPr/>
         </p:nvSpPr>
@@ -9508,7 +9112,7 @@
       </p:sp>
       <p:sp>
         <p:nvSpPr>
-          <p:cNvPr id="9" name="TextBox 8"/>
+          <p:cNvPr id="8" name="TextBox 7"/>
           <p:cNvSpPr txBox="1"/>
           <p:nvPr/>
         </p:nvSpPr>
@@ -9531,7 +9135,7 @@
             <a:pPr>
               <a:defRPr sz="1100" b="1">
                 <a:solidFill>
-                  <a:srgbClr val="4A90A4"/>
+                  <a:srgbClr val="276578"/>
                 </a:solidFill>
                 <a:latin typeface="Arial"/>
               </a:defRPr>
@@ -9544,7 +9148,7 @@
       </p:sp>
       <p:sp>
         <p:nvSpPr>
-          <p:cNvPr id="10" name="TextBox 9"/>
+          <p:cNvPr id="9" name="TextBox 8"/>
           <p:cNvSpPr txBox="1"/>
           <p:nvPr/>
         </p:nvSpPr>
@@ -9580,7 +9184,7 @@
       </p:sp>
       <p:sp>
         <p:nvSpPr>
-          <p:cNvPr id="11" name="TextBox 10"/>
+          <p:cNvPr id="10" name="TextBox 9"/>
           <p:cNvSpPr txBox="1"/>
           <p:nvPr/>
         </p:nvSpPr>
@@ -9603,7 +9207,7 @@
             <a:pPr>
               <a:defRPr sz="1100" b="1">
                 <a:solidFill>
-                  <a:srgbClr val="4A90A4"/>
+                  <a:srgbClr val="276578"/>
                 </a:solidFill>
                 <a:latin typeface="Arial"/>
               </a:defRPr>
@@ -9616,7 +9220,7 @@
       </p:sp>
       <p:sp>
         <p:nvSpPr>
-          <p:cNvPr id="12" name="TextBox 11"/>
+          <p:cNvPr id="11" name="TextBox 10"/>
           <p:cNvSpPr txBox="1"/>
           <p:nvPr/>
         </p:nvSpPr>
@@ -9652,7 +9256,7 @@
       </p:sp>
       <p:sp>
         <p:nvSpPr>
-          <p:cNvPr id="13" name="TextBox 12"/>
+          <p:cNvPr id="12" name="TextBox 11"/>
           <p:cNvSpPr txBox="1"/>
           <p:nvPr/>
         </p:nvSpPr>
@@ -9688,7 +9292,7 @@
       </p:sp>
       <p:sp>
         <p:nvSpPr>
-          <p:cNvPr id="14" name="TextBox 13"/>
+          <p:cNvPr id="13" name="TextBox 12"/>
           <p:cNvSpPr txBox="1"/>
           <p:nvPr/>
         </p:nvSpPr>
@@ -9763,7 +9367,7 @@
             <a:avLst/>
           </a:prstGeom>
           <a:solidFill>
-            <a:srgbClr val="4A90A4"/>
+            <a:srgbClr val="276578"/>
           </a:solidFill>
           <a:ln>
             <a:noFill/>
@@ -9823,42 +9427,6 @@
         </p:nvSpPr>
         <p:spPr>
           <a:xfrm>
-            <a:off x="822960" y="548640"/>
-            <a:ext cx="9144000" cy="320040"/>
-          </a:xfrm>
-          <a:prstGeom prst="rect">
-            <a:avLst/>
-          </a:prstGeom>
-          <a:noFill/>
-        </p:spPr>
-        <p:txBody>
-          <a:bodyPr wrap="square" tIns="0" bIns="0" lIns="0" rIns="0">
-            <a:spAutoFit/>
-          </a:bodyPr>
-          <a:lstStyle/>
-          <a:p>
-            <a:pPr>
-              <a:defRPr sz="1100" b="1">
-                <a:solidFill>
-                  <a:srgbClr val="4A90A4"/>
-                </a:solidFill>
-                <a:latin typeface="Arial"/>
-              </a:defRPr>
-            </a:pPr>
-            <a:r>
-              <a:t>09 / TOKEN DECISION</a:t>
-            </a:r>
-          </a:p>
-        </p:txBody>
-      </p:sp>
-      <p:sp>
-        <p:nvSpPr>
-          <p:cNvPr id="5" name="TextBox 4"/>
-          <p:cNvSpPr txBox="1"/>
-          <p:nvPr/>
-        </p:nvSpPr>
-        <p:spPr>
-          <a:xfrm>
             <a:off x="731520" y="1069848"/>
             <a:ext cx="10698480" cy="1554480"/>
           </a:xfrm>
@@ -9882,14 +9450,14 @@
               </a:defRPr>
             </a:pPr>
             <a:r>
-              <a:t>A possible token could fund operations and outreach.</a:t>
-            </a:r>
-          </a:p>
-        </p:txBody>
-      </p:sp>
-      <p:sp>
-        <p:nvSpPr>
-          <p:cNvPr id="6" name="TextBox 5"/>
+              <a:t>A possible token could fund operations and outreach</a:t>
+            </a:r>
+          </a:p>
+        </p:txBody>
+      </p:sp>
+      <p:sp>
+        <p:nvSpPr>
+          <p:cNvPr id="5" name="TextBox 4"/>
           <p:cNvSpPr txBox="1"/>
           <p:nvPr/>
         </p:nvSpPr>
@@ -9925,7 +9493,7 @@
       </p:sp>
       <p:sp>
         <p:nvSpPr>
-          <p:cNvPr id="7" name="TextBox 6"/>
+          <p:cNvPr id="6" name="TextBox 5"/>
           <p:cNvSpPr txBox="1"/>
           <p:nvPr/>
         </p:nvSpPr>
@@ -9948,7 +9516,7 @@
             <a:pPr>
               <a:defRPr sz="1100" b="1">
                 <a:solidFill>
-                  <a:srgbClr val="4A90A4"/>
+                  <a:srgbClr val="276578"/>
                 </a:solidFill>
                 <a:latin typeface="Arial"/>
               </a:defRPr>
@@ -9961,7 +9529,7 @@
       </p:sp>
       <p:sp>
         <p:nvSpPr>
-          <p:cNvPr id="8" name="TextBox 7"/>
+          <p:cNvPr id="7" name="TextBox 6"/>
           <p:cNvSpPr txBox="1"/>
           <p:nvPr/>
         </p:nvSpPr>
@@ -9997,7 +9565,7 @@
       </p:sp>
       <p:sp>
         <p:nvSpPr>
-          <p:cNvPr id="9" name="TextBox 8"/>
+          <p:cNvPr id="8" name="TextBox 7"/>
           <p:cNvSpPr txBox="1"/>
           <p:nvPr/>
         </p:nvSpPr>
@@ -10020,7 +9588,7 @@
             <a:pPr>
               <a:defRPr sz="1100" b="1">
                 <a:solidFill>
-                  <a:srgbClr val="4A90A4"/>
+                  <a:srgbClr val="276578"/>
                 </a:solidFill>
                 <a:latin typeface="Arial"/>
               </a:defRPr>
@@ -10033,7 +9601,7 @@
       </p:sp>
       <p:sp>
         <p:nvSpPr>
-          <p:cNvPr id="10" name="TextBox 9"/>
+          <p:cNvPr id="9" name="TextBox 8"/>
           <p:cNvSpPr txBox="1"/>
           <p:nvPr/>
         </p:nvSpPr>
@@ -10069,7 +9637,7 @@
       </p:sp>
       <p:sp>
         <p:nvSpPr>
-          <p:cNvPr id="11" name="TextBox 10"/>
+          <p:cNvPr id="10" name="TextBox 9"/>
           <p:cNvSpPr txBox="1"/>
           <p:nvPr/>
         </p:nvSpPr>
@@ -10092,7 +9660,7 @@
             <a:pPr>
               <a:defRPr sz="1100" b="1">
                 <a:solidFill>
-                  <a:srgbClr val="4A90A4"/>
+                  <a:srgbClr val="276578"/>
                 </a:solidFill>
                 <a:latin typeface="Arial"/>
               </a:defRPr>
@@ -10105,7 +9673,7 @@
       </p:sp>
       <p:sp>
         <p:nvSpPr>
-          <p:cNvPr id="12" name="TextBox 11"/>
+          <p:cNvPr id="11" name="TextBox 10"/>
           <p:cNvSpPr txBox="1"/>
           <p:nvPr/>
         </p:nvSpPr>
@@ -10141,7 +9709,7 @@
       </p:sp>
       <p:sp>
         <p:nvSpPr>
-          <p:cNvPr id="13" name="TextBox 12"/>
+          <p:cNvPr id="12" name="TextBox 11"/>
           <p:cNvSpPr txBox="1"/>
           <p:nvPr/>
         </p:nvSpPr>
@@ -10177,7 +9745,7 @@
       </p:sp>
       <p:sp>
         <p:nvSpPr>
-          <p:cNvPr id="14" name="TextBox 13"/>
+          <p:cNvPr id="13" name="TextBox 12"/>
           <p:cNvSpPr txBox="1"/>
           <p:nvPr/>
         </p:nvSpPr>

</xml_diff>

<commit_message>
Make the housing proposal clearer and shorter for families
Shorten the homepage and phone header, cut the menu to six items, and merge the FAQ into the family and funding pages (old links still redirect). Rewrite the whitepaper, pilot guide and project reference in plain language. Remove statements the evidence does not support (a signed contract, a steep site, a contracted builder), use Brazilian number format in Portuguese, make every label follow the page language, word the vote protection the same everywhere, keep tools that do not exist yet in the conditional, make the participation page say plainly that nothing is sent, keep crypto vocabulary off the family pages, and stack tables on phones so no column is hidden. Rebuild the downloadable documents from the same text.

Co-Authored-By: Claude Opus 5.5 <noreply@anthropic.com>
</commit_message>
<xml_diff>
--- a/pitchdeck.pptx
+++ b/pitchdeck.pptx
@@ -741,7 +741,7 @@
           <a:lstStyle/>
           <a:p>
             <a:r>
-              <a:t>These are possible contributions, not confirmed partnerships or contracts. The contact page has separate routes and explanations. Contact details are still placeholders: visitors can prepare and copy an introduction, but the website sends nothing. A property introduction can lead to assessment, not an automatic transfer. If a builder is connected to an IMOBX founder, someone independent must check the contract and completed work. See contact.html and rent-to-own.html#property.</a:t>
+              <a:t>These are possible contributions, not confirmed partnerships or contracts. The contact page has separate routes and explanations. There is no contact address yet: visitors can prepare and copy an introduction, but the website sends nothing. A property introduction can lead to assessment, not an automatic transfer. If a builder is connected to an IMOBX founder, someone independent must check the contract and completed work. See contact.html and rent-to-own.html#property.</a:t>
             </a:r>
           </a:p>
           <a:p/>
@@ -4755,7 +4755,7 @@
               </a:defRPr>
             </a:pPr>
             <a:r>
-              <a:t>IMOBX / PARTNER DISCUSSION DRAFT / v0.7 / 2026-10-19</a:t>
+              <a:t>IMOBX / PARTNER DISCUSSION DRAFT / v0.7 / 2026-10-21</a:t>
             </a:r>
           </a:p>
         </p:txBody>
@@ -5208,7 +5208,7 @@
               </a:defRPr>
             </a:pPr>
             <a:r>
-              <a:t>IMOBX / PARTNER DISCUSSION DRAFT / v0.7 / 2026-10-19</a:t>
+              <a:t>IMOBX / PARTNER DISCUSSION DRAFT / v0.7 / 2026-10-21</a:t>
             </a:r>
           </a:p>
         </p:txBody>
@@ -5661,7 +5661,7 @@
               </a:defRPr>
             </a:pPr>
             <a:r>
-              <a:t>IMOBX / PARTNER DISCUSSION DRAFT / v0.7 / 2026-10-19</a:t>
+              <a:t>IMOBX / PARTNER DISCUSSION DRAFT / v0.7 / 2026-10-21</a:t>
             </a:r>
           </a:p>
         </p:txBody>
@@ -6114,7 +6114,7 @@
               </a:defRPr>
             </a:pPr>
             <a:r>
-              <a:t>IMOBX / PARTNER DISCUSSION DRAFT / v0.7 / 2026-10-19</a:t>
+              <a:t>IMOBX / PARTNER DISCUSSION DRAFT / v0.7 / 2026-10-21</a:t>
             </a:r>
           </a:p>
         </p:txBody>
@@ -6567,7 +6567,7 @@
               </a:defRPr>
             </a:pPr>
             <a:r>
-              <a:t>IMOBX / PARTNER DISCUSSION DRAFT / v0.7 / 2026-10-19</a:t>
+              <a:t>IMOBX / PARTNER DISCUSSION DRAFT / v0.7 / 2026-10-21</a:t>
             </a:r>
           </a:p>
         </p:txBody>
@@ -7020,7 +7020,7 @@
               </a:defRPr>
             </a:pPr>
             <a:r>
-              <a:t>IMOBX / PARTNER DISCUSSION DRAFT / v0.7 / 2026-10-19</a:t>
+              <a:t>IMOBX / PARTNER DISCUSSION DRAFT / v0.7 / 2026-10-21</a:t>
             </a:r>
           </a:p>
         </p:txBody>
@@ -7473,7 +7473,7 @@
               </a:defRPr>
             </a:pPr>
             <a:r>
-              <a:t>IMOBX / PARTNER DISCUSSION DRAFT / v0.7 / 2026-10-19</a:t>
+              <a:t>IMOBX / PARTNER DISCUSSION DRAFT / v0.7 / 2026-10-21</a:t>
             </a:r>
           </a:p>
         </p:txBody>
@@ -7926,7 +7926,7 @@
               </a:defRPr>
             </a:pPr>
             <a:r>
-              <a:t>IMOBX / PARTNER DISCUSSION DRAFT / v0.7 / 2026-10-19</a:t>
+              <a:t>IMOBX / PARTNER DISCUSSION DRAFT / v0.7 / 2026-10-21</a:t>
             </a:r>
           </a:p>
         </p:txBody>
@@ -8379,7 +8379,7 @@
               </a:defRPr>
             </a:pPr>
             <a:r>
-              <a:t>IMOBX / PARTNER DISCUSSION DRAFT / v0.7 / 2026-10-19</a:t>
+              <a:t>IMOBX / PARTNER DISCUSSION DRAFT / v0.7 / 2026-10-21</a:t>
             </a:r>
           </a:p>
         </p:txBody>
@@ -8832,7 +8832,7 @@
               </a:defRPr>
             </a:pPr>
             <a:r>
-              <a:t>IMOBX / PARTNER DISCUSSION DRAFT / v0.7 / 2026-10-19</a:t>
+              <a:t>IMOBX / PARTNER DISCUSSION DRAFT / v0.7 / 2026-10-21</a:t>
             </a:r>
           </a:p>
         </p:txBody>
@@ -9285,7 +9285,7 @@
               </a:defRPr>
             </a:pPr>
             <a:r>
-              <a:t>IMOBX / PARTNER DISCUSSION DRAFT / v0.7 / 2026-10-19</a:t>
+              <a:t>IMOBX / PARTNER DISCUSSION DRAFT / v0.7 / 2026-10-21</a:t>
             </a:r>
           </a:p>
         </p:txBody>
@@ -9738,7 +9738,7 @@
               </a:defRPr>
             </a:pPr>
             <a:r>
-              <a:t>IMOBX / PARTNER DISCUSSION DRAFT / v0.7 / 2026-10-19</a:t>
+              <a:t>IMOBX / PARTNER DISCUSSION DRAFT / v0.7 / 2026-10-21</a:t>
             </a:r>
           </a:p>
         </p:txBody>

</xml_diff>

<commit_message>
Make the site clearer for families and readers: sources sit under the sentence they support, project stages show what runs together, icons replace text arrows, plain version labels, the first screen says no homes are available yet, and the budget table fits on a phone
Co-Authored-By: Claude Sonnet 5.5 <noreply@anthropic.com>
</commit_message>
<xml_diff>
--- a/pitchdeck.pptx
+++ b/pitchdeck.pptx
@@ -4732,6 +4732,42 @@
         </p:nvSpPr>
         <p:spPr>
           <a:xfrm>
+            <a:off x="749808" y="5760720"/>
+            <a:ext cx="10607040" cy="256032"/>
+          </a:xfrm>
+          <a:prstGeom prst="rect">
+            <a:avLst/>
+          </a:prstGeom>
+          <a:noFill/>
+        </p:spPr>
+        <p:txBody>
+          <a:bodyPr wrap="square" tIns="0" bIns="0" lIns="0" rIns="0">
+            <a:spAutoFit/>
+          </a:bodyPr>
+          <a:lstStyle/>
+          <a:p>
+            <a:pPr>
+              <a:defRPr sz="1100" b="0">
+                <a:solidFill>
+                  <a:srgbClr val="596772"/>
+                </a:solidFill>
+                <a:latin typeface="Arial"/>
+              </a:defRPr>
+            </a:pPr>
+            <a:r>
+              <a:t>Source: IMOBX project reference. Lists what exists and what is not decided, with a review date. It is the project's own record.</a:t>
+            </a:r>
+          </a:p>
+        </p:txBody>
+      </p:sp>
+      <p:sp>
+        <p:nvSpPr>
+          <p:cNvPr id="13" name="TextBox 12"/>
+          <p:cNvSpPr txBox="1"/>
+          <p:nvPr/>
+        </p:nvSpPr>
+        <p:spPr>
+          <a:xfrm>
             <a:off x="749808" y="6437376"/>
             <a:ext cx="9144000" cy="182880"/>
           </a:xfrm>
@@ -4755,14 +4791,14 @@
               </a:defRPr>
             </a:pPr>
             <a:r>
-              <a:t>IMOBX / PARTNER DISCUSSION DRAFT / v0.7 / 2026-10-21</a:t>
-            </a:r>
-          </a:p>
-        </p:txBody>
-      </p:sp>
-      <p:sp>
-        <p:nvSpPr>
-          <p:cNvPr id="13" name="TextBox 12"/>
+              <a:t>IMOBX / PARTNER DISCUSSION DRAFT / Version 0.7, 21 October 2026</a:t>
+            </a:r>
+          </a:p>
+        </p:txBody>
+      </p:sp>
+      <p:sp>
+        <p:nvSpPr>
+          <p:cNvPr id="14" name="TextBox 13"/>
           <p:cNvSpPr txBox="1"/>
           <p:nvPr/>
         </p:nvSpPr>
@@ -5185,6 +5221,42 @@
         </p:nvSpPr>
         <p:spPr>
           <a:xfrm>
+            <a:off x="749808" y="5760720"/>
+            <a:ext cx="10607040" cy="256032"/>
+          </a:xfrm>
+          <a:prstGeom prst="rect">
+            <a:avLst/>
+          </a:prstGeom>
+          <a:noFill/>
+        </p:spPr>
+        <p:txBody>
+          <a:bodyPr wrap="square" tIns="0" bIns="0" lIns="0" rIns="0">
+            <a:spAutoFit/>
+          </a:bodyPr>
+          <a:lstStyle/>
+          <a:p>
+            <a:pPr>
+              <a:defRPr sz="1100" b="0">
+                <a:solidFill>
+                  <a:srgbClr val="596772"/>
+                </a:solidFill>
+                <a:latin typeface="Arial"/>
+              </a:defRPr>
+            </a:pPr>
+            <a:r>
+              <a:t>Source: IMOBX project stages. Sets out the stages and what must be ready in each. It sets no dates.</a:t>
+            </a:r>
+          </a:p>
+        </p:txBody>
+      </p:sp>
+      <p:sp>
+        <p:nvSpPr>
+          <p:cNvPr id="13" name="TextBox 12"/>
+          <p:cNvSpPr txBox="1"/>
+          <p:nvPr/>
+        </p:nvSpPr>
+        <p:spPr>
+          <a:xfrm>
             <a:off x="749808" y="6437376"/>
             <a:ext cx="9144000" cy="182880"/>
           </a:xfrm>
@@ -5208,14 +5280,14 @@
               </a:defRPr>
             </a:pPr>
             <a:r>
-              <a:t>IMOBX / PARTNER DISCUSSION DRAFT / v0.7 / 2026-10-21</a:t>
-            </a:r>
-          </a:p>
-        </p:txBody>
-      </p:sp>
-      <p:sp>
-        <p:nvSpPr>
-          <p:cNvPr id="13" name="TextBox 12"/>
+              <a:t>IMOBX / PARTNER DISCUSSION DRAFT / Version 0.7, 21 October 2026</a:t>
+            </a:r>
+          </a:p>
+        </p:txBody>
+      </p:sp>
+      <p:sp>
+        <p:nvSpPr>
+          <p:cNvPr id="14" name="TextBox 13"/>
           <p:cNvSpPr txBox="1"/>
           <p:nvPr/>
         </p:nvSpPr>
@@ -5661,7 +5733,7 @@
               </a:defRPr>
             </a:pPr>
             <a:r>
-              <a:t>IMOBX / PARTNER DISCUSSION DRAFT / v0.7 / 2026-10-21</a:t>
+              <a:t>IMOBX / PARTNER DISCUSSION DRAFT / Version 0.7, 21 October 2026</a:t>
             </a:r>
           </a:p>
         </p:txBody>
@@ -6114,7 +6186,7 @@
               </a:defRPr>
             </a:pPr>
             <a:r>
-              <a:t>IMOBX / PARTNER DISCUSSION DRAFT / v0.7 / 2026-10-21</a:t>
+              <a:t>IMOBX / PARTNER DISCUSSION DRAFT / Version 0.7, 21 October 2026</a:t>
             </a:r>
           </a:p>
         </p:txBody>
@@ -6544,6 +6616,42 @@
         </p:nvSpPr>
         <p:spPr>
           <a:xfrm>
+            <a:off x="749808" y="5760720"/>
+            <a:ext cx="10607040" cy="256032"/>
+          </a:xfrm>
+          <a:prstGeom prst="rect">
+            <a:avLst/>
+          </a:prstGeom>
+          <a:noFill/>
+        </p:spPr>
+        <p:txBody>
+          <a:bodyPr wrap="square" tIns="0" bIns="0" lIns="0" rIns="0">
+            <a:spAutoFit/>
+          </a:bodyPr>
+          <a:lstStyle/>
+          <a:p>
+            <a:pPr>
+              <a:defRPr sz="1100" b="0">
+                <a:solidFill>
+                  <a:srgbClr val="596772"/>
+                </a:solidFill>
+                <a:latin typeface="Arial"/>
+              </a:defRPr>
+            </a:pPr>
+            <a:r>
+              <a:t>Source: UN-Habitat: adequate housing. Describes what adequate housing means. It does not assess IMOBX.</a:t>
+            </a:r>
+          </a:p>
+        </p:txBody>
+      </p:sp>
+      <p:sp>
+        <p:nvSpPr>
+          <p:cNvPr id="13" name="TextBox 12"/>
+          <p:cNvSpPr txBox="1"/>
+          <p:nvPr/>
+        </p:nvSpPr>
+        <p:spPr>
+          <a:xfrm>
             <a:off x="749808" y="6437376"/>
             <a:ext cx="9144000" cy="182880"/>
           </a:xfrm>
@@ -6567,14 +6675,14 @@
               </a:defRPr>
             </a:pPr>
             <a:r>
-              <a:t>IMOBX / PARTNER DISCUSSION DRAFT / v0.7 / 2026-10-21</a:t>
-            </a:r>
-          </a:p>
-        </p:txBody>
-      </p:sp>
-      <p:sp>
-        <p:nvSpPr>
-          <p:cNvPr id="13" name="TextBox 12"/>
+              <a:t>IMOBX / PARTNER DISCUSSION DRAFT / Version 0.7, 21 October 2026</a:t>
+            </a:r>
+          </a:p>
+        </p:txBody>
+      </p:sp>
+      <p:sp>
+        <p:nvSpPr>
+          <p:cNvPr id="14" name="TextBox 13"/>
           <p:cNvSpPr txBox="1"/>
           <p:nvPr/>
         </p:nvSpPr>
@@ -6997,6 +7105,42 @@
         </p:nvSpPr>
         <p:spPr>
           <a:xfrm>
+            <a:off x="749808" y="5760720"/>
+            <a:ext cx="10607040" cy="256032"/>
+          </a:xfrm>
+          <a:prstGeom prst="rect">
+            <a:avLst/>
+          </a:prstGeom>
+          <a:noFill/>
+        </p:spPr>
+        <p:txBody>
+          <a:bodyPr wrap="square" tIns="0" bIns="0" lIns="0" rIns="0">
+            <a:spAutoFit/>
+          </a:bodyPr>
+          <a:lstStyle/>
+          <a:p>
+            <a:pPr>
+              <a:defRPr sz="1100" b="0">
+                <a:solidFill>
+                  <a:srgbClr val="596772"/>
+                </a:solidFill>
+                <a:latin typeface="Arial"/>
+              </a:defRPr>
+            </a:pPr>
+            <a:r>
+              <a:t>Source: Whitepaper, section 3: the costs. Shows how Rafael supplied these figures. It is not an independent check of them.</a:t>
+            </a:r>
+          </a:p>
+        </p:txBody>
+      </p:sp>
+      <p:sp>
+        <p:nvSpPr>
+          <p:cNvPr id="13" name="TextBox 12"/>
+          <p:cNvSpPr txBox="1"/>
+          <p:nvPr/>
+        </p:nvSpPr>
+        <p:spPr>
+          <a:xfrm>
             <a:off x="749808" y="6437376"/>
             <a:ext cx="9144000" cy="182880"/>
           </a:xfrm>
@@ -7020,14 +7164,14 @@
               </a:defRPr>
             </a:pPr>
             <a:r>
-              <a:t>IMOBX / PARTNER DISCUSSION DRAFT / v0.7 / 2026-10-21</a:t>
-            </a:r>
-          </a:p>
-        </p:txBody>
-      </p:sp>
-      <p:sp>
-        <p:nvSpPr>
-          <p:cNvPr id="13" name="TextBox 12"/>
+              <a:t>IMOBX / PARTNER DISCUSSION DRAFT / Version 0.7, 21 October 2026</a:t>
+            </a:r>
+          </a:p>
+        </p:txBody>
+      </p:sp>
+      <p:sp>
+        <p:nvSpPr>
+          <p:cNvPr id="14" name="TextBox 13"/>
           <p:cNvSpPr txBox="1"/>
           <p:nvPr/>
         </p:nvSpPr>
@@ -7473,7 +7617,7 @@
               </a:defRPr>
             </a:pPr>
             <a:r>
-              <a:t>IMOBX / PARTNER DISCUSSION DRAFT / v0.7 / 2026-10-21</a:t>
+              <a:t>IMOBX / PARTNER DISCUSSION DRAFT / Version 0.7, 21 October 2026</a:t>
             </a:r>
           </a:p>
         </p:txBody>
@@ -7926,7 +8070,7 @@
               </a:defRPr>
             </a:pPr>
             <a:r>
-              <a:t>IMOBX / PARTNER DISCUSSION DRAFT / v0.7 / 2026-10-21</a:t>
+              <a:t>IMOBX / PARTNER DISCUSSION DRAFT / Version 0.7, 21 October 2026</a:t>
             </a:r>
           </a:p>
         </p:txBody>
@@ -8379,7 +8523,7 @@
               </a:defRPr>
             </a:pPr>
             <a:r>
-              <a:t>IMOBX / PARTNER DISCUSSION DRAFT / v0.7 / 2026-10-21</a:t>
+              <a:t>IMOBX / PARTNER DISCUSSION DRAFT / Version 0.7, 21 October 2026</a:t>
             </a:r>
           </a:p>
         </p:txBody>
@@ -8809,6 +8953,78 @@
         </p:nvSpPr>
         <p:spPr>
           <a:xfrm>
+            <a:off x="749808" y="5760720"/>
+            <a:ext cx="10607040" cy="256032"/>
+          </a:xfrm>
+          <a:prstGeom prst="rect">
+            <a:avLst/>
+          </a:prstGeom>
+          <a:noFill/>
+        </p:spPr>
+        <p:txBody>
+          <a:bodyPr wrap="square" tIns="0" bIns="0" lIns="0" rIns="0">
+            <a:spAutoFit/>
+          </a:bodyPr>
+          <a:lstStyle/>
+          <a:p>
+            <a:pPr>
+              <a:defRPr sz="1100" b="0">
+                <a:solidFill>
+                  <a:srgbClr val="596772"/>
+                </a:solidFill>
+                <a:latin typeface="Arial"/>
+              </a:defRPr>
+            </a:pPr>
+            <a:r>
+              <a:t>Source: ICA: cooperative identity. States the principles of cooperatives, including member participation. It does not review IMOBX.</a:t>
+            </a:r>
+          </a:p>
+        </p:txBody>
+      </p:sp>
+      <p:sp>
+        <p:nvSpPr>
+          <p:cNvPr id="13" name="TextBox 12"/>
+          <p:cNvSpPr txBox="1"/>
+          <p:nvPr/>
+        </p:nvSpPr>
+        <p:spPr>
+          <a:xfrm>
+            <a:off x="749808" y="6035040"/>
+            <a:ext cx="10607040" cy="256032"/>
+          </a:xfrm>
+          <a:prstGeom prst="rect">
+            <a:avLst/>
+          </a:prstGeom>
+          <a:noFill/>
+        </p:spPr>
+        <p:txBody>
+          <a:bodyPr wrap="square" tIns="0" bIns="0" lIns="0" rIns="0">
+            <a:spAutoFit/>
+          </a:bodyPr>
+          <a:lstStyle/>
+          <a:p>
+            <a:pPr>
+              <a:defRPr sz="1100" b="0">
+                <a:solidFill>
+                  <a:srgbClr val="596772"/>
+                </a:solidFill>
+                <a:latin typeface="Arial"/>
+              </a:defRPr>
+            </a:pPr>
+            <a:r>
+              <a:t>Source: Elinor Ostrom: Nobel lecture. Is research on how communities manage shared resources. It does not test IMOBX's rules.</a:t>
+            </a:r>
+          </a:p>
+        </p:txBody>
+      </p:sp>
+      <p:sp>
+        <p:nvSpPr>
+          <p:cNvPr id="14" name="TextBox 13"/>
+          <p:cNvSpPr txBox="1"/>
+          <p:nvPr/>
+        </p:nvSpPr>
+        <p:spPr>
+          <a:xfrm>
             <a:off x="749808" y="6437376"/>
             <a:ext cx="9144000" cy="182880"/>
           </a:xfrm>
@@ -8832,14 +9048,14 @@
               </a:defRPr>
             </a:pPr>
             <a:r>
-              <a:t>IMOBX / PARTNER DISCUSSION DRAFT / v0.7 / 2026-10-21</a:t>
-            </a:r>
-          </a:p>
-        </p:txBody>
-      </p:sp>
-      <p:sp>
-        <p:nvSpPr>
-          <p:cNvPr id="13" name="TextBox 12"/>
+              <a:t>IMOBX / PARTNER DISCUSSION DRAFT / Version 0.7, 21 October 2026</a:t>
+            </a:r>
+          </a:p>
+        </p:txBody>
+      </p:sp>
+      <p:sp>
+        <p:nvSpPr>
+          <p:cNvPr id="15" name="TextBox 14"/>
           <p:cNvSpPr txBox="1"/>
           <p:nvPr/>
         </p:nvSpPr>
@@ -9285,7 +9501,7 @@
               </a:defRPr>
             </a:pPr>
             <a:r>
-              <a:t>IMOBX / PARTNER DISCUSSION DRAFT / v0.7 / 2026-10-21</a:t>
+              <a:t>IMOBX / PARTNER DISCUSSION DRAFT / Version 0.7, 21 October 2026</a:t>
             </a:r>
           </a:p>
         </p:txBody>
@@ -9715,6 +9931,78 @@
         </p:nvSpPr>
         <p:spPr>
           <a:xfrm>
+            <a:off x="749808" y="5760720"/>
+            <a:ext cx="10607040" cy="256032"/>
+          </a:xfrm>
+          <a:prstGeom prst="rect">
+            <a:avLst/>
+          </a:prstGeom>
+          <a:noFill/>
+        </p:spPr>
+        <p:txBody>
+          <a:bodyPr wrap="square" tIns="0" bIns="0" lIns="0" rIns="0">
+            <a:spAutoFit/>
+          </a:bodyPr>
+          <a:lstStyle/>
+          <a:p>
+            <a:pPr>
+              <a:defRPr sz="1100" b="0">
+                <a:solidFill>
+                  <a:srgbClr val="596772"/>
+                </a:solidFill>
+                <a:latin typeface="Arial"/>
+              </a:defRPr>
+            </a:pPr>
+            <a:r>
+              <a:t>Source: CVM Guidance Opinion 40. Says Brazil's regulator looks at what an investment actually gives, not its name. It does not say whether an IMOBX token would comply.</a:t>
+            </a:r>
+          </a:p>
+        </p:txBody>
+      </p:sp>
+      <p:sp>
+        <p:nvSpPr>
+          <p:cNvPr id="13" name="TextBox 12"/>
+          <p:cNvSpPr txBox="1"/>
+          <p:nvPr/>
+        </p:nvSpPr>
+        <p:spPr>
+          <a:xfrm>
+            <a:off x="749808" y="6035040"/>
+            <a:ext cx="10607040" cy="256032"/>
+          </a:xfrm>
+          <a:prstGeom prst="rect">
+            <a:avLst/>
+          </a:prstGeom>
+          <a:noFill/>
+        </p:spPr>
+        <p:txBody>
+          <a:bodyPr wrap="square" tIns="0" bIns="0" lIns="0" rIns="0">
+            <a:spAutoFit/>
+          </a:bodyPr>
+          <a:lstStyle/>
+          <a:p>
+            <a:pPr>
+              <a:defRPr sz="1100" b="0">
+                <a:solidFill>
+                  <a:srgbClr val="596772"/>
+                </a:solidFill>
+                <a:latin typeface="Arial"/>
+              </a:defRPr>
+            </a:pPr>
+            <a:r>
+              <a:t>Source: IMOBX: questions about funding, tokens and governance. Holds the project's own answers on the token. Nothing there is decided.</a:t>
+            </a:r>
+          </a:p>
+        </p:txBody>
+      </p:sp>
+      <p:sp>
+        <p:nvSpPr>
+          <p:cNvPr id="14" name="TextBox 13"/>
+          <p:cNvSpPr txBox="1"/>
+          <p:nvPr/>
+        </p:nvSpPr>
+        <p:spPr>
+          <a:xfrm>
             <a:off x="749808" y="6437376"/>
             <a:ext cx="9144000" cy="182880"/>
           </a:xfrm>
@@ -9738,14 +10026,14 @@
               </a:defRPr>
             </a:pPr>
             <a:r>
-              <a:t>IMOBX / PARTNER DISCUSSION DRAFT / v0.7 / 2026-10-21</a:t>
-            </a:r>
-          </a:p>
-        </p:txBody>
-      </p:sp>
-      <p:sp>
-        <p:nvSpPr>
-          <p:cNvPr id="13" name="TextBox 12"/>
+              <a:t>IMOBX / PARTNER DISCUSSION DRAFT / Version 0.7, 21 October 2026</a:t>
+            </a:r>
+          </a:p>
+        </p:txBody>
+      </p:sp>
+      <p:sp>
+        <p:nvSpPr>
+          <p:cNvPr id="15" name="TextBox 14"/>
           <p:cNvSpPr txBox="1"/>
           <p:nvPr/>
         </p:nvSpPr>

</xml_diff>

<commit_message>
Village-first redesign and the token page: Rafael's village opens the homepage, the vision as four steps from a house to a resilient neighbourhood, three ways to house a family, the founding circle as one panel, and a page on what the token is for and why it stays separate from the cooperative
Co-Authored-By: Claude Opus 5.5 <noreply@anthropic.com>
</commit_message>
<xml_diff>
--- a/pitchdeck.pptx
+++ b/pitchdeck.pptx
@@ -519,7 +519,7 @@
           <a:p/>
           <a:p>
             <a:r>
-              <a:t>Sources and factual limits: companion whitepaper v0.7 and reference.html.</a:t>
+              <a:t>Sources and factual limits: companion whitepaper v0.8 and reference.html.</a:t>
             </a:r>
           </a:p>
         </p:txBody>
@@ -595,7 +595,7 @@
           <a:p/>
           <a:p>
             <a:r>
-              <a:t>Sources and factual limits: companion whitepaper v0.7 and reference.html.</a:t>
+              <a:t>Sources and factual limits: companion whitepaper v0.8 and reference.html.</a:t>
             </a:r>
           </a:p>
         </p:txBody>
@@ -671,7 +671,7 @@
           <a:p/>
           <a:p>
             <a:r>
-              <a:t>Sources and factual limits: companion whitepaper v0.7 and reference.html.</a:t>
+              <a:t>Sources and factual limits: companion whitepaper v0.8 and reference.html.</a:t>
             </a:r>
           </a:p>
         </p:txBody>
@@ -747,7 +747,7 @@
           <a:p/>
           <a:p>
             <a:r>
-              <a:t>Sources and factual limits: companion whitepaper v0.7 and reference.html.</a:t>
+              <a:t>Sources and factual limits: companion whitepaper v0.8 and reference.html.</a:t>
             </a:r>
           </a:p>
         </p:txBody>
@@ -823,7 +823,7 @@
           <a:p/>
           <a:p>
             <a:r>
-              <a:t>Sources and factual limits: companion whitepaper v0.7 and reference.html.</a:t>
+              <a:t>Sources and factual limits: companion whitepaper v0.8 and reference.html.</a:t>
             </a:r>
           </a:p>
         </p:txBody>
@@ -899,7 +899,7 @@
           <a:p/>
           <a:p>
             <a:r>
-              <a:t>Sources and factual limits: companion whitepaper v0.7 and reference.html.</a:t>
+              <a:t>Sources and factual limits: companion whitepaper v0.8 and reference.html.</a:t>
             </a:r>
           </a:p>
         </p:txBody>
@@ -975,7 +975,7 @@
           <a:p/>
           <a:p>
             <a:r>
-              <a:t>Sources and factual limits: companion whitepaper v0.7 and reference.html.</a:t>
+              <a:t>Sources and factual limits: companion whitepaper v0.8 and reference.html.</a:t>
             </a:r>
           </a:p>
         </p:txBody>
@@ -1051,7 +1051,7 @@
           <a:p/>
           <a:p>
             <a:r>
-              <a:t>Sources and factual limits: companion whitepaper v0.7 and reference.html.</a:t>
+              <a:t>Sources and factual limits: companion whitepaper v0.8 and reference.html.</a:t>
             </a:r>
           </a:p>
         </p:txBody>
@@ -1127,7 +1127,7 @@
           <a:p/>
           <a:p>
             <a:r>
-              <a:t>Sources and factual limits: companion whitepaper v0.7 and reference.html.</a:t>
+              <a:t>Sources and factual limits: companion whitepaper v0.8 and reference.html.</a:t>
             </a:r>
           </a:p>
         </p:txBody>
@@ -1203,7 +1203,7 @@
           <a:p/>
           <a:p>
             <a:r>
-              <a:t>Sources and factual limits: companion whitepaper v0.7 and reference.html.</a:t>
+              <a:t>Sources and factual limits: companion whitepaper v0.8 and reference.html.</a:t>
             </a:r>
           </a:p>
         </p:txBody>
@@ -1279,7 +1279,7 @@
           <a:p/>
           <a:p>
             <a:r>
-              <a:t>Sources and factual limits: companion whitepaper v0.7 and reference.html.</a:t>
+              <a:t>Sources and factual limits: companion whitepaper v0.8 and reference.html.</a:t>
             </a:r>
           </a:p>
         </p:txBody>
@@ -1355,7 +1355,7 @@
           <a:p/>
           <a:p>
             <a:r>
-              <a:t>Sources and factual limits: companion whitepaper v0.7 and reference.html.</a:t>
+              <a:t>Sources and factual limits: companion whitepaper v0.8 and reference.html.</a:t>
             </a:r>
           </a:p>
         </p:txBody>
@@ -4791,7 +4791,7 @@
               </a:defRPr>
             </a:pPr>
             <a:r>
-              <a:t>IMOBX / PARTNER DISCUSSION DRAFT / Version 0.7, 21 October 2026</a:t>
+              <a:t>IMOBX / PARTNER DISCUSSION DRAFT / Version 0.8, 24 October 2026</a:t>
             </a:r>
           </a:p>
         </p:txBody>
@@ -5280,7 +5280,7 @@
               </a:defRPr>
             </a:pPr>
             <a:r>
-              <a:t>IMOBX / PARTNER DISCUSSION DRAFT / Version 0.7, 21 October 2026</a:t>
+              <a:t>IMOBX / PARTNER DISCUSSION DRAFT / Version 0.8, 24 October 2026</a:t>
             </a:r>
           </a:p>
         </p:txBody>
@@ -5733,7 +5733,7 @@
               </a:defRPr>
             </a:pPr>
             <a:r>
-              <a:t>IMOBX / PARTNER DISCUSSION DRAFT / Version 0.7, 21 October 2026</a:t>
+              <a:t>IMOBX / PARTNER DISCUSSION DRAFT / Version 0.8, 24 October 2026</a:t>
             </a:r>
           </a:p>
         </p:txBody>
@@ -6186,7 +6186,7 @@
               </a:defRPr>
             </a:pPr>
             <a:r>
-              <a:t>IMOBX / PARTNER DISCUSSION DRAFT / Version 0.7, 21 October 2026</a:t>
+              <a:t>IMOBX / PARTNER DISCUSSION DRAFT / Version 0.8, 24 October 2026</a:t>
             </a:r>
           </a:p>
         </p:txBody>
@@ -6675,7 +6675,7 @@
               </a:defRPr>
             </a:pPr>
             <a:r>
-              <a:t>IMOBX / PARTNER DISCUSSION DRAFT / Version 0.7, 21 October 2026</a:t>
+              <a:t>IMOBX / PARTNER DISCUSSION DRAFT / Version 0.8, 24 October 2026</a:t>
             </a:r>
           </a:p>
         </p:txBody>
@@ -7164,7 +7164,7 @@
               </a:defRPr>
             </a:pPr>
             <a:r>
-              <a:t>IMOBX / PARTNER DISCUSSION DRAFT / Version 0.7, 21 October 2026</a:t>
+              <a:t>IMOBX / PARTNER DISCUSSION DRAFT / Version 0.8, 24 October 2026</a:t>
             </a:r>
           </a:p>
         </p:txBody>
@@ -7617,7 +7617,7 @@
               </a:defRPr>
             </a:pPr>
             <a:r>
-              <a:t>IMOBX / PARTNER DISCUSSION DRAFT / Version 0.7, 21 October 2026</a:t>
+              <a:t>IMOBX / PARTNER DISCUSSION DRAFT / Version 0.8, 24 October 2026</a:t>
             </a:r>
           </a:p>
         </p:txBody>
@@ -8070,7 +8070,7 @@
               </a:defRPr>
             </a:pPr>
             <a:r>
-              <a:t>IMOBX / PARTNER DISCUSSION DRAFT / Version 0.7, 21 October 2026</a:t>
+              <a:t>IMOBX / PARTNER DISCUSSION DRAFT / Version 0.8, 24 October 2026</a:t>
             </a:r>
           </a:p>
         </p:txBody>
@@ -8523,7 +8523,7 @@
               </a:defRPr>
             </a:pPr>
             <a:r>
-              <a:t>IMOBX / PARTNER DISCUSSION DRAFT / Version 0.7, 21 October 2026</a:t>
+              <a:t>IMOBX / PARTNER DISCUSSION DRAFT / Version 0.8, 24 October 2026</a:t>
             </a:r>
           </a:p>
         </p:txBody>
@@ -9048,7 +9048,7 @@
               </a:defRPr>
             </a:pPr>
             <a:r>
-              <a:t>IMOBX / PARTNER DISCUSSION DRAFT / Version 0.7, 21 October 2026</a:t>
+              <a:t>IMOBX / PARTNER DISCUSSION DRAFT / Version 0.8, 24 October 2026</a:t>
             </a:r>
           </a:p>
         </p:txBody>
@@ -9501,7 +9501,7 @@
               </a:defRPr>
             </a:pPr>
             <a:r>
-              <a:t>IMOBX / PARTNER DISCUSSION DRAFT / Version 0.7, 21 October 2026</a:t>
+              <a:t>IMOBX / PARTNER DISCUSSION DRAFT / Version 0.8, 24 October 2026</a:t>
             </a:r>
           </a:p>
         </p:txBody>
@@ -9666,7 +9666,7 @@
               </a:defRPr>
             </a:pPr>
             <a:r>
-              <a:t>A possible token could fund operations and outreach</a:t>
+              <a:t>A possible token could fund homes, operations and outreach</a:t>
             </a:r>
           </a:p>
         </p:txBody>
@@ -10026,7 +10026,7 @@
               </a:defRPr>
             </a:pPr>
             <a:r>
-              <a:t>IMOBX / PARTNER DISCUSSION DRAFT / Version 0.7, 21 October 2026</a:t>
+              <a:t>IMOBX / PARTNER DISCUSSION DRAFT / Version 0.8, 24 October 2026</a:t>
             </a:r>
           </a:p>
         </p:txBody>

</xml_diff>

<commit_message>
Funding instead of money and houses instead of homes, site-wide; the token as a matrix (Volume, Verify, Voting, Vow) with More info; the token launches only once it can be used for services and goods; property page fixes; homepage links name their facts; dead partner links removed
Co-Authored-By: Claude Opus 5.5 <noreply@anthropic.com>
</commit_message>
<xml_diff>
--- a/pitchdeck.pptx
+++ b/pitchdeck.pptx
@@ -589,7 +589,7 @@
           <a:lstStyle/>
           <a:p>
             <a:r>
-              <a:t>The six stages are legal structure and property; resident participation; first homes; payment records people can check; funding and account review; more homes and owner partnerships. Rafael contributes construction and local knowledge; John contributes communication and digital coordination. Adviser, accounting, approval and independent inspection roles still need appointments. OLYMPUS is a possible builder connected to Rafael. Its appointment would need approval by someone independent of the builder. A community or charitable partner is a possible relationship. Construction dates depend on the chosen project, funding and permissions. A review after at least three operating months is proposed before expanding. The roadmap lists responsibilities and reasons to pause each stage.</a:t>
+              <a:t>The six stages are legal structure and property; resident participation; first houses; payment records people can check; funding and account review; more houses and owner partnerships. Rafael contributes construction and local knowledge; John contributes communication and digital coordination. Adviser, accounting, approval and independent inspection roles still need appointments. OLYMPUS is a possible builder connected to Rafael. Its appointment would need approval by someone independent of the builder. A community or charitable partner is a possible relationship. Construction dates depend on the chosen project, funding and permissions. A review after at least three operating months is proposed before expanding. The roadmap lists responsibilities and reasons to pause each stage.</a:t>
             </a:r>
           </a:p>
           <a:p/>
@@ -665,7 +665,7 @@
           <a:lstStyle/>
           <a:p>
             <a:r>
-              <a:t>Agree response times and affordability targets with local participants. Report homes as planned, contracted, delivered or transferred, with checked records. Token prices and holder counts do not measure how well families are housed. The published records do not yet document completed home transfers or committed capital.</a:t>
+              <a:t>Agree response times and affordability targets with local participants. Report houses as planned, contracted, delivered or transferred, with checked records. Token prices and holder counts do not measure how well families are housed. The published records do not yet document completed home transfers or committed capital.</a:t>
             </a:r>
           </a:p>
           <a:p/>
@@ -893,7 +893,7 @@
           <a:lstStyle/>
           <a:p>
             <a:r>
-              <a:t>On 30 November 2025 Rafael showed a US$21,883.86 construction calculation plus land, then the revised US$27,777 budget. Direct purchasing and shared costs form part of the plan. Thirty-six homes total US$999,972, with a proposed 12-month program. These are Rafael’s budget figures, not an index-published finished-home price. Track dates, included work, prices in reais and actual invoices. The separate January contract is US$27,777 for both lofts together.</a:t>
+              <a:t>On 30 November 2025 Rafael showed a US$21,883.86 construction calculation plus land, then the revised US$27,777 budget. Direct purchasing and shared costs form part of the plan. Thirty-six houses total US$999,972, with a proposed 12-month program. These are Rafael’s budget figures, not an index-published finished-home price. Track dates, included work, prices in reais and actual invoices. The separate January contract is US$27,777 for both lofts together.</a:t>
             </a:r>
           </a:p>
           <a:p/>
@@ -969,7 +969,7 @@
           <a:lstStyle/>
           <a:p>
             <a:r>
-              <a:t>The first homes are still being planned. This slide does not offer a home. The first home’s price, monthly payment and time to pay have not been set. How much of each payment would count towards buying it also remains to be agreed. Rafael’s village budget and the two-loft contract are construction cases, not household sale prices. Repair charges, hardship and exit terms remain open. The household explanation is at rent-to-own.html. Before building, the project needs documents showing the right to use the property, a budget and someone independent to inspect the work.</a:t>
+              <a:t>The first houses are still being planned. This slide does not offer a home. The first home’s price, monthly payment and time to pay have not been set. How much of each payment would count towards buying it also remains to be agreed. Rafael’s village budget and the two-loft contract are construction cases, not household sale prices. Repair charges, hardship and exit terms remain open. The household explanation is at rent-to-own.html. Before building, the project needs documents showing the right to use the property, a budget and someone independent to inspect the work.</a:t>
             </a:r>
           </a:p>
           <a:p/>
@@ -1045,7 +1045,7 @@
           <a:lstStyle/>
           <a:p>
             <a:r>
-              <a:t>Money credited toward a family’s purchase is not a second receipt of cash. Money paid by a buyer to a token seller normally goes to that seller, apart from separately collected fees. Money locked in a trading market is not also available to build homes.</a:t>
+              <a:t>Funding credited toward a family’s purchase is not a second receipt of cash. Funding paid by a buyer to a token seller normally goes to that seller, apart from separately collected fees. Funding locked in a trading market is not also available to build houses.</a:t>
             </a:r>
           </a:p>
           <a:p/>
@@ -1121,7 +1121,7 @@
           <a:lstStyle/>
           <a:p>
             <a:r>
-              <a:t>Having a thousand homes does not itself show that the accounts balance. One-off grants can help construction but do not become continuing income. Any ongoing charge needs a real, affordable service under agreed terms.</a:t>
+              <a:t>Having a thousand houses does not itself show that the accounts balance. One-off grants can help construction but do not become continuing income. Any ongoing charge needs a real, affordable service under agreed terms.</a:t>
             </a:r>
           </a:p>
           <a:p/>
@@ -5064,7 +5064,7 @@
               </a:defRPr>
             </a:pPr>
             <a:r>
-              <a:t>Property rights, household terms and budgets underpin the first homes.</a:t>
+              <a:t>Property rights, household terms and budgets underpin the first houses.</a:t>
             </a:r>
           </a:p>
         </p:txBody>
@@ -5445,7 +5445,7 @@
               </a:defRPr>
             </a:pPr>
             <a:r>
-              <a:t>Measure homes and promises kept</a:t>
+              <a:t>Measure houses and promises kept</a:t>
             </a:r>
           </a:p>
         </p:txBody>
@@ -5625,7 +5625,7 @@
               </a:defRPr>
             </a:pPr>
             <a:r>
-              <a:t>Check money received and paid against the records; report repairs and unresolved issues.</a:t>
+              <a:t>Check funding received and paid against the records; report repairs and unresolved issues.</a:t>
             </a:r>
           </a:p>
         </p:txBody>
@@ -7092,7 +7092,7 @@
               </a:defRPr>
             </a:pPr>
             <a:r>
-              <a:t>The village plan assumes at least 36 homes built together.</a:t>
+              <a:t>The village plan assumes at least 36 houses built together.</a:t>
             </a:r>
           </a:p>
         </p:txBody>
@@ -7962,7 +7962,7 @@
               </a:defRPr>
             </a:pPr>
             <a:r>
-              <a:t>Keep money for empty homes and promises made to families.</a:t>
+              <a:t>Keep funding for empty houses and promises made to families.</a:t>
             </a:r>
           </a:p>
         </p:txBody>
@@ -8034,7 +8034,7 @@
               </a:defRPr>
             </a:pPr>
             <a:r>
-              <a:t>Fund more homes; consider any permitted investor payments afterward.</a:t>
+              <a:t>Fund more houses; consider any permitted investor payments afterward.</a:t>
             </a:r>
           </a:p>
         </p:txBody>
@@ -8235,7 +8235,7 @@
               </a:defRPr>
             </a:pPr>
             <a:r>
-              <a:t>Pay today’s bills and plan the next homes</a:t>
+              <a:t>Pay today’s bills and plan the next houses</a:t>
             </a:r>
           </a:p>
         </p:txBody>
@@ -8271,7 +8271,7 @@
               </a:defRPr>
             </a:pPr>
             <a:r>
-              <a:t>Running the existing homes and building more need separate budgets.</a:t>
+              <a:t>Running the existing houses and building more need separate budgets.</a:t>
             </a:r>
           </a:p>
         </p:txBody>
@@ -9666,7 +9666,7 @@
               </a:defRPr>
             </a:pPr>
             <a:r>
-              <a:t>A possible token could fund homes, operations and outreach</a:t>
+              <a:t>A possible token could fund houses, operations and outreach</a:t>
             </a:r>
           </a:p>
         </p:txBody>

</xml_diff>

<commit_message>
Token section as decided (decision 33); partner deck and whitepaper match it (no fee share, investment, dividend or buyback paths; houses, not homes); Aneel card removed
Co-Authored-By: Claude Opus 5.5 <noreply@anthropic.com>
</commit_message>
<xml_diff>
--- a/pitchdeck.pptx
+++ b/pitchdeck.pptx
@@ -665,7 +665,7 @@
           <a:lstStyle/>
           <a:p>
             <a:r>
-              <a:t>Agree response times and affordability targets with local participants. Report houses as planned, contracted, delivered or transferred, with checked records. Token prices and holder counts do not measure how well families are housed. The published records do not yet document completed home transfers or committed capital.</a:t>
+              <a:t>Agree response times and affordability targets with local participants. Report houses as planned, contracted, delivered or transferred, with checked records. Token prices and holder counts do not measure how well families are housed. The published records do not yet document completed house transfers or committed capital.</a:t>
             </a:r>
           </a:p>
           <a:p/>
@@ -969,7 +969,7 @@
           <a:lstStyle/>
           <a:p>
             <a:r>
-              <a:t>The first houses are still being planned. This slide does not offer a home. The first home’s price, monthly payment and time to pay have not been set. How much of each payment would count towards buying it also remains to be agreed. Rafael’s village budget and the two-loft contract are construction cases, not household sale prices. Repair charges, hardship and exit terms remain open. The household explanation is at rent-to-own.html. Before building, the project needs documents showing the right to use the property, a budget and someone independent to inspect the work.</a:t>
+              <a:t>The first houses are still being planned. The first house’s price, monthly payment and time to pay have not been set. How much of each payment would count towards buying it also remains to be agreed. Rafael’s village budget and the two-loft contract are construction cases, not household sale prices. Repair charges, hardship and exit terms remain open. The household explanation is at rent-to-own.html. Before building, the project needs documents showing the right to use the property, a budget and someone independent to inspect the work.</a:t>
             </a:r>
           </a:p>
           <a:p/>
@@ -1197,7 +1197,7 @@
           <a:lstStyle/>
           <a:p>
             <a:r>
-              <a:t>The voting procedure, spending limits and way to question a decision have not been agreed with participants. In the proposed repair process, a resident reports a leak, a maintenance contact obtains a quote, spending follows the agreed limit and another person checks the work. Buying tokens would not give control over another household’s contracted purchase price. See rent-to-own.html#decisions and roadmap.html#governance. Resident decision-making is still a proposal and has not yet been demonstrated in IMOBX.</a:t>
+              <a:t>The voting procedure, spending limits and way to question a decision have not been agreed with participants. In the proposed repair process, a resident reports a leak, a maintenance contact obtains a quote, spending follows the agreed limit and another person checks the work. Whatever a token vote decides, only the family and IMOBX together, under the law, can change a family’s housing agreement. See rent-to-own.html#decisions and governance.html. Resident decision-making is still a proposal and has not yet been demonstrated in IMOBX.</a:t>
             </a:r>
           </a:p>
           <a:p/>
@@ -1349,7 +1349,7 @@
           <a:lstStyle/>
           <a:p>
             <a:r>
-              <a:t>Four scenarios remain: no IMOBX token, a service or membership benefit, a share of collected fees, or an investment in the operation. These are alternatives, not combined promised rights. Capital for construction, outreach payments and investor income have different budgets and commitments. Residents’ participation would not depend on investment or promotion. Reference.html#token compares what a buyer might receive and the decisions still open.</a:t>
+              <a:t>A Brazilian lawyer is reviewing the token’s design; what holders receive is set after that review, under the CVM’s rules. We start building a house only when its funding is secured. Residents take part as members, whether or not they hold tokens. Paid outreach needs a funded task, a check of the completed work and disclosure of payment.</a:t>
             </a:r>
           </a:p>
           <a:p/>
@@ -4755,7 +4755,7 @@
               </a:defRPr>
             </a:pPr>
             <a:r>
-              <a:t>Source: IMOBX project reference. Lists what exists and what is not decided, with a review date. It is the project's own record.</a:t>
+              <a:t>Source: IMOBX resources and sources. Lists what exists and what is not decided, with a review date. It is the project's own record.</a:t>
             </a:r>
           </a:p>
         </p:txBody>
@@ -6876,7 +6876,7 @@
               </a:defRPr>
             </a:pPr>
             <a:r>
-              <a:t>His US$27,777 per-home plan uses CUB and SINAPI, Brazilian building-cost references.</a:t>
+              <a:t>His US$27,777 per-house plan uses CUB and SINAPI, Brazilian building-cost references.</a:t>
             </a:r>
           </a:p>
         </p:txBody>
@@ -7581,7 +7581,7 @@
               </a:defRPr>
             </a:pPr>
             <a:r>
-              <a:t>The whole home transfers to the household once the purchase terms are met.</a:t>
+              <a:t>The whole house transfers to the household once the purchase terms are met.</a:t>
             </a:r>
           </a:p>
         </p:txBody>
@@ -8796,7 +8796,7 @@
               </a:defRPr>
             </a:pPr>
             <a:r>
-              <a:t>One vote per member is an option under discussion.</a:t>
+              <a:t>One member, one vote, as Brazil’s cooperative law sets out.</a:t>
             </a:r>
           </a:p>
         </p:txBody>
@@ -9666,7 +9666,7 @@
               </a:defRPr>
             </a:pPr>
             <a:r>
-              <a:t>A possible token could fund houses, operations and outreach</a:t>
+              <a:t>The token launches once it can be used</a:t>
             </a:r>
           </a:p>
         </p:txBody>
@@ -9702,7 +9702,7 @@
               </a:defRPr>
             </a:pPr>
             <a:r>
-              <a:t>Buyers of new tokens would pay the organisation that creates and sells them. Their rights are still undecided.</a:t>
+              <a:t>We are examining how to introduce the IMOBX token in line with Brazilian law. It launches when holders can use it to reach the community’s services and goods.</a:t>
             </a:r>
           </a:p>
         </p:txBody>
@@ -9774,7 +9774,7 @@
               </a:defRPr>
             </a:pPr>
             <a:r>
-              <a:t>A later resale normally pays the seller; any project fee is separate.</a:t>
+              <a:t>Volume: trading fees, paid in USDC, pay for checked work.</a:t>
             </a:r>
           </a:p>
         </p:txBody>
@@ -9846,7 +9846,7 @@
               </a:defRPr>
             </a:pPr>
             <a:r>
-              <a:t>Paid outreach needs a funded task, a check of the completed work and disclosure of payment.</a:t>
+              <a:t>Voting: holders vote on the token’s own rules; the cooperative keeps one member, one vote.</a:t>
             </a:r>
           </a:p>
         </p:txBody>
@@ -9918,7 +9918,7 @@
               </a:defRPr>
             </a:pPr>
             <a:r>
-              <a:t>No dividend, discount or token voting model has been selected.</a:t>
+              <a:t>Verify: in the plan, anyone can check each payment and who approved it.</a:t>
             </a:r>
           </a:p>
         </p:txBody>
@@ -9990,7 +9990,7 @@
               </a:defRPr>
             </a:pPr>
             <a:r>
-              <a:t>Source: IMOBX: questions about funding, tokens and governance. Holds the project's own answers on the token. Nothing there is decided.</a:t>
+              <a:t>Source: IMOBX: the token, on the distributed ledger page. Sets out the token’s four functions as the project describes them. A Brazilian lawyer is reviewing the design.</a:t>
             </a:r>
           </a:p>
         </p:txBody>

</xml_diff>

<commit_message>
House cost in reais with full context (owner, 29 Oct: AI-slop-like); the unsupported two-loft figure removed; lawyer-review process lines removed (owner: no copy about our background process); the law item names the rules that apply
Co-Authored-By: Claude Opus 5.5 <noreply@anthropic.com>
</commit_message>
<xml_diff>
--- a/pitchdeck.pptx
+++ b/pitchdeck.pptx
@@ -893,7 +893,7 @@
           <a:lstStyle/>
           <a:p>
             <a:r>
-              <a:t>On 30 November 2025 Rafael showed a US$21,883.86 construction calculation plus land, then the revised US$27,777 budget. Direct purchasing and shared costs form part of the plan. Thirty-six houses total US$999,972, with a proposed 12-month program. These are Rafael’s budget figures, not an index-published finished-home price. Track dates, included work, prices in reais and actual invoices. The separate January contract is US$27,777 for both lofts together.</a:t>
+              <a:t>On 30 November 2025 Rafael showed a US$21,883.86 construction calculation plus land, then the revised US$27,777 budget. Direct purchasing and shared costs form part of the plan. Thirty-six houses total US$999,972, with a proposed 12-month program. These are Rafael’s budget figures, not an index-published finished-home price. Track dates, included work, prices in reais and actual invoices.</a:t>
             </a:r>
           </a:p>
           <a:p/>
@@ -1349,7 +1349,7 @@
           <a:lstStyle/>
           <a:p>
             <a:r>
-              <a:t>A Brazilian lawyer is reviewing the token’s design; what holders receive is set after that review, under the CVM’s rules. We start building a house only when its funding is secured. Residents take part as members, whether or not they hold tokens. Paid outreach needs a funded task, a check of the completed work and disclosure of payment.</a:t>
+              <a:t>We start building a house only when its funding is secured. Residents take part as members, whether or not they hold tokens. Paid outreach needs a funded task, a check of the completed work and disclosure of payment.</a:t>
             </a:r>
           </a:p>
           <a:p/>
@@ -9990,7 +9990,7 @@
               </a:defRPr>
             </a:pPr>
             <a:r>
-              <a:t>Source: IMOBX: the token, on the distributed ledger page. Sets out the token’s four functions as the project describes them. A Brazilian lawyer is reviewing the design.</a:t>
+              <a:t>Source: IMOBX: the token, on the distributed ledger page. Sets out the token’s four functions as the project describes them.</a:t>
             </a:r>
           </a:p>
         </p:txBody>

</xml_diff>

<commit_message>
Cost story told in full (owner, 29-30 Oct): the family's problem with checked figures, building at cost with a licensed builder, about 60% above cost over 15 years with no down payment, we win when families win, and why 36 houses built together cost less; lines about our background work removed; the founders' company named as the proposed builder
Co-Authored-By: Claude Opus 5.5 <noreply@anthropic.com>
</commit_message>
<xml_diff>
--- a/pitchdeck.pptx
+++ b/pitchdeck.pptx
@@ -665,7 +665,7 @@
           <a:lstStyle/>
           <a:p>
             <a:r>
-              <a:t>Agree response times and affordability targets with local participants. Report houses as planned, contracted, delivered or transferred, with checked records. Token prices and holder counts do not measure how well families are housed. The published records do not yet document completed house transfers or committed capital.</a:t>
+              <a:t>Agree response times and affordability targets with local participants. Report houses as planned, contracted, delivered or transferred, with checked records. Token prices and holder counts do not measure how well families are housed.</a:t>
             </a:r>
           </a:p>
           <a:p/>
@@ -969,7 +969,7 @@
           <a:lstStyle/>
           <a:p>
             <a:r>
-              <a:t>The first houses are still being planned. The first house’s price, monthly payment and time to pay have not been set. How much of each payment would count towards buying it also remains to be agreed. Rafael’s village budget and the two-loft contract are construction cases, not household sale prices. Repair charges, hardship and exit terms remain open. The household explanation is at rent-to-own.html. Before building, the project needs documents showing the right to use the property, a budget and someone independent to inspect the work.</a:t>
+              <a:t>The first houses are still being planned. A family pays about 60% above the building cost over 15 years; each family’s monthly payment is agreed with it. How much of each payment would count towards buying it also remains to be agreed. Rafael’s village budget and the two-loft contract are construction cases, not household sale prices. Repair charges, hardship and exit terms remain open. The household explanation is at rent-to-own.html. Before building, the project needs documents showing the right to use the property, a budget and someone independent to inspect the work.</a:t>
             </a:r>
           </a:p>
           <a:p/>
@@ -1197,7 +1197,7 @@
           <a:lstStyle/>
           <a:p>
             <a:r>
-              <a:t>The voting procedure, spending limits and way to question a decision have not been agreed with participants. In the proposed repair process, a resident reports a leak, a maintenance contact obtains a quote, spending follows the agreed limit and another person checks the work. Whatever a token vote decides, only the family and IMOBX together, under the law, can change a family’s housing agreement. See rent-to-own.html#decisions and governance.html. Resident decision-making is still a proposal and has not yet been demonstrated in IMOBX.</a:t>
+              <a:t>The voting procedure, spending limits and way to question a decision have not been agreed with participants. In the proposed repair process, a resident reports a leak, a maintenance contact obtains a quote, spending follows the agreed limit and another person checks the work. Whatever a token vote decides, only the family and IMOBX together, under the law, can change a family’s housing agreement. See rent-to-own.html#decisions and governance.html.</a:t>
             </a:r>
           </a:p>
           <a:p/>
@@ -1349,7 +1349,7 @@
           <a:lstStyle/>
           <a:p>
             <a:r>
-              <a:t>We start building a house only when its funding is secured. Residents take part as members, whether or not they hold tokens. Paid outreach needs a funded task, a check of the completed work and disclosure of payment.</a:t>
+              <a:t>We start building a house only when its funding is secured. Residents take part as members, whether or not they hold tokens.</a:t>
             </a:r>
           </a:p>
           <a:p/>
@@ -7128,7 +7128,7 @@
               </a:defRPr>
             </a:pPr>
             <a:r>
-              <a:t>Source: Whitepaper, section 3: the costs. Shows how Rafael supplied these figures. It is not an independent check of them.</a:t>
+              <a:t>Source: Whitepaper, section 3: the costs. Shows how Rafael supplied these figures.</a:t>
             </a:r>
           </a:p>
         </p:txBody>
@@ -9954,7 +9954,7 @@
               </a:defRPr>
             </a:pPr>
             <a:r>
-              <a:t>Source: CVM Guidance Opinion 40. Says Brazil's regulator looks at what an investment actually gives, not its name. It does not say whether an IMOBX token would comply.</a:t>
+              <a:t>Source: CVM Guidance Opinion 40. Says Brazil's regulator looks at what an investment actually gives, not its name.</a:t>
             </a:r>
           </a:p>
         </p:txBody>

</xml_diff>